<commit_message>
docs: commentaires complets JS, Go, HTML, CSS, SQL
</commit_message>
<xml_diff>
--- a/ChronoPath_Presentation.pptx
+++ b/ChronoPath_Presentation.pptx
@@ -122,7 +122,8 @@
 <file path=ppt/revisionInfo.xml><?xml version="1.0" encoding="utf-8"?>
 <p1510:revInfo xmlns:a="http://schemas.openxmlformats.org/drawingml/2006/main" xmlns:r="http://schemas.openxmlformats.org/officeDocument/2006/relationships" xmlns:p1510="http://schemas.microsoft.com/office/powerpoint/2015/10/main">
   <p1510:revLst>
-    <p1510:client id="{D7FBF17F-F930-4C75-935A-476591B0B09D}" v="146" dt="2026-06-01T06:51:10.318"/>
+    <p1510:client id="{0DDFFFFF-B08E-4228-AF3E-A777D9D520E4}" v="210" dt="2026-06-01T07:12:23.080"/>
+    <p1510:client id="{D7FBF17F-F930-4C75-935A-476591B0B09D}" v="225" dt="2026-06-01T07:20:23.641"/>
   </p1510:revLst>
 </p1510:revInfo>
 </file>
@@ -130,58 +131,58 @@
 <file path=ppt/changesInfos/changesInfo1.xml><?xml version="1.0" encoding="utf-8"?>
 <pc:chgInfo xmlns:a="http://schemas.openxmlformats.org/drawingml/2006/main" xmlns:r="http://schemas.openxmlformats.org/officeDocument/2006/relationships" xmlns:ac="http://schemas.microsoft.com/office/drawing/2013/main/command" xmlns:pc="http://schemas.microsoft.com/office/powerpoint/2013/main/command">
   <pc:docChgLst>
-    <pc:chgData name="Giovanardi Fabio" userId="f4a989cf-038f-4c93-aae6-0cbdd9f74f63" providerId="ADAL" clId="{D979BA3E-480B-4515-8F4F-734DE973C2AB}"/>
-    <pc:docChg chg="modSld">
-      <pc:chgData name="Giovanardi Fabio" userId="f4a989cf-038f-4c93-aae6-0cbdd9f74f63" providerId="ADAL" clId="{D979BA3E-480B-4515-8F4F-734DE973C2AB}" dt="2026-05-27T12:07:41.381" v="18" actId="1076"/>
+    <pc:chgData name="Schiesser Mathis" userId="b47ba13d-b521-430f-81e6-e15e56bc5a77" providerId="ADAL" clId="{DC098AA2-EA73-415F-840D-60C9EDB678FC}"/>
+    <pc:docChg chg="undo custSel addSld delSld modSld sldOrd">
+      <pc:chgData name="Schiesser Mathis" userId="b47ba13d-b521-430f-81e6-e15e56bc5a77" providerId="ADAL" clId="{DC098AA2-EA73-415F-840D-60C9EDB678FC}" dt="2026-06-01T07:20:23.641" v="828" actId="20577"/>
       <pc:docMkLst>
         <pc:docMk/>
       </pc:docMkLst>
-      <pc:sldChg chg="modSp mod">
-        <pc:chgData name="Giovanardi Fabio" userId="f4a989cf-038f-4c93-aae6-0cbdd9f74f63" providerId="ADAL" clId="{D979BA3E-480B-4515-8F4F-734DE973C2AB}" dt="2026-05-27T12:07:41.381" v="18" actId="1076"/>
-        <pc:sldMkLst>
-          <pc:docMk/>
-          <pc:sldMk cId="1754514512" sldId="259"/>
-        </pc:sldMkLst>
-        <pc:spChg chg="mod">
-          <ac:chgData name="Giovanardi Fabio" userId="f4a989cf-038f-4c93-aae6-0cbdd9f74f63" providerId="ADAL" clId="{D979BA3E-480B-4515-8F4F-734DE973C2AB}" dt="2026-05-27T12:07:41.381" v="18" actId="1076"/>
-          <ac:spMkLst>
-            <pc:docMk/>
-            <pc:sldMk cId="1754514512" sldId="259"/>
-            <ac:spMk id="2" creationId="{8D08C410-DB7E-C76B-6D87-908473567C60}"/>
-          </ac:spMkLst>
-        </pc:spChg>
-      </pc:sldChg>
-    </pc:docChg>
-  </pc:docChgLst>
-  <pc:docChgLst>
-    <pc:chgData name="Schiesser Mathis" userId="b47ba13d-b521-430f-81e6-e15e56bc5a77" providerId="ADAL" clId="{DC098AA2-EA73-415F-840D-60C9EDB678FC}"/>
-    <pc:docChg chg="custSel addSld delSld modSld sldOrd">
-      <pc:chgData name="Schiesser Mathis" userId="b47ba13d-b521-430f-81e6-e15e56bc5a77" providerId="ADAL" clId="{DC098AA2-EA73-415F-840D-60C9EDB678FC}" dt="2026-06-01T06:51:17.708" v="748" actId="20577"/>
-      <pc:docMkLst>
-        <pc:docMk/>
-      </pc:docMkLst>
-      <pc:sldChg chg="modSp mod">
-        <pc:chgData name="Schiesser Mathis" userId="b47ba13d-b521-430f-81e6-e15e56bc5a77" providerId="ADAL" clId="{DC098AA2-EA73-415F-840D-60C9EDB678FC}" dt="2026-05-27T11:29:48.194" v="109" actId="20577"/>
+      <pc:sldChg chg="addSp delSp modSp mod">
+        <pc:chgData name="Schiesser Mathis" userId="b47ba13d-b521-430f-81e6-e15e56bc5a77" providerId="ADAL" clId="{DC098AA2-EA73-415F-840D-60C9EDB678FC}" dt="2026-06-01T07:14:46.147" v="771" actId="478"/>
         <pc:sldMkLst>
           <pc:docMk/>
           <pc:sldMk cId="2515313489" sldId="256"/>
         </pc:sldMkLst>
-        <pc:spChg chg="mod">
-          <ac:chgData name="Schiesser Mathis" userId="b47ba13d-b521-430f-81e6-e15e56bc5a77" providerId="ADAL" clId="{DC098AA2-EA73-415F-840D-60C9EDB678FC}" dt="2026-05-27T11:29:24.153" v="107" actId="122"/>
+        <pc:spChg chg="add del mod">
+          <ac:chgData name="Schiesser Mathis" userId="b47ba13d-b521-430f-81e6-e15e56bc5a77" providerId="ADAL" clId="{DC098AA2-EA73-415F-840D-60C9EDB678FC}" dt="2026-06-01T07:14:46.147" v="771" actId="478"/>
           <ac:spMkLst>
             <pc:docMk/>
             <pc:sldMk cId="2515313489" sldId="256"/>
             <ac:spMk id="3" creationId="{317D7691-BCC3-D52B-AB4D-859317FBAD54}"/>
           </ac:spMkLst>
         </pc:spChg>
-        <pc:spChg chg="mod">
-          <ac:chgData name="Schiesser Mathis" userId="b47ba13d-b521-430f-81e6-e15e56bc5a77" providerId="ADAL" clId="{DC098AA2-EA73-415F-840D-60C9EDB678FC}" dt="2026-05-27T11:29:48.194" v="109" actId="20577"/>
+        <pc:spChg chg="add del mod">
+          <ac:chgData name="Schiesser Mathis" userId="b47ba13d-b521-430f-81e6-e15e56bc5a77" providerId="ADAL" clId="{DC098AA2-EA73-415F-840D-60C9EDB678FC}" dt="2026-06-01T07:14:45.746" v="770" actId="478"/>
           <ac:spMkLst>
             <pc:docMk/>
             <pc:sldMk cId="2515313489" sldId="256"/>
             <ac:spMk id="4" creationId="{1DE01912-E755-437E-95BD-01B477C9BB8D}"/>
           </ac:spMkLst>
         </pc:spChg>
+        <pc:spChg chg="add del mod">
+          <ac:chgData name="Schiesser Mathis" userId="b47ba13d-b521-430f-81e6-e15e56bc5a77" providerId="ADAL" clId="{DC098AA2-EA73-415F-840D-60C9EDB678FC}" dt="2026-06-01T07:14:46.147" v="771" actId="478"/>
+          <ac:spMkLst>
+            <pc:docMk/>
+            <pc:sldMk cId="2515313489" sldId="256"/>
+            <ac:spMk id="10" creationId="{A742E245-DD22-A80F-9A23-34CD59077A15}"/>
+          </ac:spMkLst>
+        </pc:spChg>
+        <pc:picChg chg="add mod modCrop">
+          <ac:chgData name="Schiesser Mathis" userId="b47ba13d-b521-430f-81e6-e15e56bc5a77" providerId="ADAL" clId="{DC098AA2-EA73-415F-840D-60C9EDB678FC}" dt="2026-06-01T07:13:59.938" v="762" actId="1076"/>
+          <ac:picMkLst>
+            <pc:docMk/>
+            <pc:sldMk cId="2515313489" sldId="256"/>
+            <ac:picMk id="6" creationId="{8AB6A35A-E4D6-1141-A3C1-09D73C949665}"/>
+          </ac:picMkLst>
+        </pc:picChg>
+        <pc:picChg chg="add mod">
+          <ac:chgData name="Schiesser Mathis" userId="b47ba13d-b521-430f-81e6-e15e56bc5a77" providerId="ADAL" clId="{DC098AA2-EA73-415F-840D-60C9EDB678FC}" dt="2026-06-01T07:14:10.071" v="765" actId="1076"/>
+          <ac:picMkLst>
+            <pc:docMk/>
+            <pc:sldMk cId="2515313489" sldId="256"/>
+            <ac:picMk id="8" creationId="{8755FA51-59A5-87F4-9979-EF8446CE6C64}"/>
+          </ac:picMkLst>
+        </pc:picChg>
       </pc:sldChg>
       <pc:sldChg chg="addSp modSp mod">
         <pc:chgData name="Schiesser Mathis" userId="b47ba13d-b521-430f-81e6-e15e56bc5a77" providerId="ADAL" clId="{DC098AA2-EA73-415F-840D-60C9EDB678FC}" dt="2026-05-27T11:51:36.376" v="475" actId="14100"/>
@@ -265,7 +266,7 @@
         </pc:sldMkLst>
       </pc:sldChg>
       <pc:sldChg chg="addSp delSp modSp add mod setBg">
-        <pc:chgData name="Schiesser Mathis" userId="b47ba13d-b521-430f-81e6-e15e56bc5a77" providerId="ADAL" clId="{DC098AA2-EA73-415F-840D-60C9EDB678FC}" dt="2026-06-01T06:47:43.238" v="653" actId="790"/>
+        <pc:chgData name="Schiesser Mathis" userId="b47ba13d-b521-430f-81e6-e15e56bc5a77" providerId="ADAL" clId="{DC098AA2-EA73-415F-840D-60C9EDB678FC}" dt="2026-06-01T07:16:06.006" v="781" actId="20577"/>
         <pc:sldMkLst>
           <pc:docMk/>
           <pc:sldMk cId="0" sldId="265"/>
@@ -300,6 +301,14 @@
             <pc:docMk/>
             <pc:sldMk cId="0" sldId="265"/>
             <ac:spMk id="18" creationId="{00000000-0000-0000-0000-000000000000}"/>
+          </ac:spMkLst>
+        </pc:spChg>
+        <pc:spChg chg="mod">
+          <ac:chgData name="Schiesser Mathis" userId="b47ba13d-b521-430f-81e6-e15e56bc5a77" providerId="ADAL" clId="{DC098AA2-EA73-415F-840D-60C9EDB678FC}" dt="2026-06-01T07:16:06.006" v="781" actId="20577"/>
+          <ac:spMkLst>
+            <pc:docMk/>
+            <pc:sldMk cId="0" sldId="265"/>
+            <ac:spMk id="23" creationId="{00000000-0000-0000-0000-000000000000}"/>
           </ac:spMkLst>
         </pc:spChg>
         <pc:spChg chg="mod">
@@ -490,7 +499,7 @@
         </pc:spChg>
       </pc:sldChg>
       <pc:sldChg chg="addSp delSp modSp add mod ord setBg modNotesTx">
-        <pc:chgData name="Schiesser Mathis" userId="b47ba13d-b521-430f-81e6-e15e56bc5a77" providerId="ADAL" clId="{DC098AA2-EA73-415F-840D-60C9EDB678FC}" dt="2026-06-01T06:48:54.820" v="688" actId="20577"/>
+        <pc:chgData name="Schiesser Mathis" userId="b47ba13d-b521-430f-81e6-e15e56bc5a77" providerId="ADAL" clId="{DC098AA2-EA73-415F-840D-60C9EDB678FC}" dt="2026-06-01T07:20:23.641" v="828" actId="20577"/>
         <pc:sldMkLst>
           <pc:docMk/>
           <pc:sldMk cId="0" sldId="270"/>
@@ -512,7 +521,7 @@
           </ac:spMkLst>
         </pc:spChg>
         <pc:spChg chg="mod">
-          <ac:chgData name="Schiesser Mathis" userId="b47ba13d-b521-430f-81e6-e15e56bc5a77" providerId="ADAL" clId="{DC098AA2-EA73-415F-840D-60C9EDB678FC}" dt="2026-06-01T06:48:25.645" v="683" actId="20577"/>
+          <ac:chgData name="Schiesser Mathis" userId="b47ba13d-b521-430f-81e6-e15e56bc5a77" providerId="ADAL" clId="{DC098AA2-EA73-415F-840D-60C9EDB678FC}" dt="2026-06-01T07:19:36.955" v="824" actId="113"/>
           <ac:spMkLst>
             <pc:docMk/>
             <pc:sldMk cId="0" sldId="270"/>
@@ -528,7 +537,7 @@
           </ac:spMkLst>
         </pc:spChg>
         <pc:spChg chg="mod">
-          <ac:chgData name="Schiesser Mathis" userId="b47ba13d-b521-430f-81e6-e15e56bc5a77" providerId="ADAL" clId="{DC098AA2-EA73-415F-840D-60C9EDB678FC}" dt="2026-06-01T06:48:27.969" v="684" actId="20577"/>
+          <ac:chgData name="Schiesser Mathis" userId="b47ba13d-b521-430f-81e6-e15e56bc5a77" providerId="ADAL" clId="{DC098AA2-EA73-415F-840D-60C9EDB678FC}" dt="2026-06-01T07:20:23.641" v="828" actId="20577"/>
           <ac:spMkLst>
             <pc:docMk/>
             <pc:sldMk cId="0" sldId="270"/>
@@ -550,6 +559,330 @@
           <pc:docMk/>
           <pc:sldMk cId="1228356947" sldId="270"/>
         </pc:sldMkLst>
+      </pc:sldChg>
+    </pc:docChg>
+  </pc:docChgLst>
+  <pc:docChgLst>
+    <pc:chgData name="Giovanardi Fabio" userId="f4a989cf-038f-4c93-aae6-0cbdd9f74f63" providerId="ADAL" clId="{D979BA3E-480B-4515-8F4F-734DE973C2AB}"/>
+    <pc:docChg chg="undo custSel modSld">
+      <pc:chgData name="Giovanardi Fabio" userId="f4a989cf-038f-4c93-aae6-0cbdd9f74f63" providerId="ADAL" clId="{D979BA3E-480B-4515-8F4F-734DE973C2AB}" dt="2026-06-01T07:12:23.080" v="228" actId="1076"/>
+      <pc:docMkLst>
+        <pc:docMk/>
+      </pc:docMkLst>
+      <pc:sldChg chg="modSp mod">
+        <pc:chgData name="Giovanardi Fabio" userId="f4a989cf-038f-4c93-aae6-0cbdd9f74f63" providerId="ADAL" clId="{D979BA3E-480B-4515-8F4F-734DE973C2AB}" dt="2026-06-01T07:12:23.080" v="228" actId="1076"/>
+        <pc:sldMkLst>
+          <pc:docMk/>
+          <pc:sldMk cId="1754514512" sldId="259"/>
+        </pc:sldMkLst>
+        <pc:spChg chg="mod">
+          <ac:chgData name="Giovanardi Fabio" userId="f4a989cf-038f-4c93-aae6-0cbdd9f74f63" providerId="ADAL" clId="{D979BA3E-480B-4515-8F4F-734DE973C2AB}" dt="2026-05-27T12:07:41.381" v="18" actId="1076"/>
+          <ac:spMkLst>
+            <pc:docMk/>
+            <pc:sldMk cId="1754514512" sldId="259"/>
+            <ac:spMk id="2" creationId="{8D08C410-DB7E-C76B-6D87-908473567C60}"/>
+          </ac:spMkLst>
+        </pc:spChg>
+        <pc:picChg chg="mod">
+          <ac:chgData name="Giovanardi Fabio" userId="f4a989cf-038f-4c93-aae6-0cbdd9f74f63" providerId="ADAL" clId="{D979BA3E-480B-4515-8F4F-734DE973C2AB}" dt="2026-06-01T07:12:23.080" v="228" actId="1076"/>
+          <ac:picMkLst>
+            <pc:docMk/>
+            <pc:sldMk cId="1754514512" sldId="259"/>
+            <ac:picMk id="4" creationId="{0D534152-0451-1F68-A64A-2B4ED0E7923A}"/>
+          </ac:picMkLst>
+        </pc:picChg>
+      </pc:sldChg>
+      <pc:sldChg chg="modSp mod">
+        <pc:chgData name="Giovanardi Fabio" userId="f4a989cf-038f-4c93-aae6-0cbdd9f74f63" providerId="ADAL" clId="{D979BA3E-480B-4515-8F4F-734DE973C2AB}" dt="2026-06-01T07:09:08.541" v="216" actId="20577"/>
+        <pc:sldMkLst>
+          <pc:docMk/>
+          <pc:sldMk cId="0" sldId="265"/>
+        </pc:sldMkLst>
+        <pc:spChg chg="mod">
+          <ac:chgData name="Giovanardi Fabio" userId="f4a989cf-038f-4c93-aae6-0cbdd9f74f63" providerId="ADAL" clId="{D979BA3E-480B-4515-8F4F-734DE973C2AB}" dt="2026-06-01T07:09:08.541" v="216" actId="20577"/>
+          <ac:spMkLst>
+            <pc:docMk/>
+            <pc:sldMk cId="0" sldId="265"/>
+            <ac:spMk id="12" creationId="{00000000-0000-0000-0000-000000000000}"/>
+          </ac:spMkLst>
+        </pc:spChg>
+      </pc:sldChg>
+      <pc:sldChg chg="modSp mod">
+        <pc:chgData name="Giovanardi Fabio" userId="f4a989cf-038f-4c93-aae6-0cbdd9f74f63" providerId="ADAL" clId="{D979BA3E-480B-4515-8F4F-734DE973C2AB}" dt="2026-06-01T07:09:38.822" v="222" actId="20577"/>
+        <pc:sldMkLst>
+          <pc:docMk/>
+          <pc:sldMk cId="0" sldId="267"/>
+        </pc:sldMkLst>
+        <pc:spChg chg="mod">
+          <ac:chgData name="Giovanardi Fabio" userId="f4a989cf-038f-4c93-aae6-0cbdd9f74f63" providerId="ADAL" clId="{D979BA3E-480B-4515-8F4F-734DE973C2AB}" dt="2026-06-01T07:09:38.822" v="222" actId="20577"/>
+          <ac:spMkLst>
+            <pc:docMk/>
+            <pc:sldMk cId="0" sldId="267"/>
+            <ac:spMk id="6" creationId="{00000000-0000-0000-0000-000000000000}"/>
+          </ac:spMkLst>
+        </pc:spChg>
+        <pc:spChg chg="mod">
+          <ac:chgData name="Giovanardi Fabio" userId="f4a989cf-038f-4c93-aae6-0cbdd9f74f63" providerId="ADAL" clId="{D979BA3E-480B-4515-8F4F-734DE973C2AB}" dt="2026-06-01T07:09:37.335" v="219" actId="20577"/>
+          <ac:spMkLst>
+            <pc:docMk/>
+            <pc:sldMk cId="0" sldId="267"/>
+            <ac:spMk id="10" creationId="{00000000-0000-0000-0000-000000000000}"/>
+          </ac:spMkLst>
+        </pc:spChg>
+      </pc:sldChg>
+      <pc:sldChg chg="addSp delSp modSp mod">
+        <pc:chgData name="Giovanardi Fabio" userId="f4a989cf-038f-4c93-aae6-0cbdd9f74f63" providerId="ADAL" clId="{D979BA3E-480B-4515-8F4F-734DE973C2AB}" dt="2026-06-01T07:10:30.060" v="224" actId="478"/>
+        <pc:sldMkLst>
+          <pc:docMk/>
+          <pc:sldMk cId="0" sldId="268"/>
+        </pc:sldMkLst>
+        <pc:spChg chg="mod">
+          <ac:chgData name="Giovanardi Fabio" userId="f4a989cf-038f-4c93-aae6-0cbdd9f74f63" providerId="ADAL" clId="{D979BA3E-480B-4515-8F4F-734DE973C2AB}" dt="2026-06-01T07:07:11.390" v="71" actId="14100"/>
+          <ac:spMkLst>
+            <pc:docMk/>
+            <pc:sldMk cId="0" sldId="268"/>
+            <ac:spMk id="3" creationId="{00000000-0000-0000-0000-000000000000}"/>
+          </ac:spMkLst>
+        </pc:spChg>
+        <pc:spChg chg="mod">
+          <ac:chgData name="Giovanardi Fabio" userId="f4a989cf-038f-4c93-aae6-0cbdd9f74f63" providerId="ADAL" clId="{D979BA3E-480B-4515-8F4F-734DE973C2AB}" dt="2026-06-01T07:02:21.344" v="39" actId="1076"/>
+          <ac:spMkLst>
+            <pc:docMk/>
+            <pc:sldMk cId="0" sldId="268"/>
+            <ac:spMk id="4" creationId="{00000000-0000-0000-0000-000000000000}"/>
+          </ac:spMkLst>
+        </pc:spChg>
+        <pc:spChg chg="mod">
+          <ac:chgData name="Giovanardi Fabio" userId="f4a989cf-038f-4c93-aae6-0cbdd9f74f63" providerId="ADAL" clId="{D979BA3E-480B-4515-8F4F-734DE973C2AB}" dt="2026-06-01T07:02:39.109" v="41" actId="1076"/>
+          <ac:spMkLst>
+            <pc:docMk/>
+            <pc:sldMk cId="0" sldId="268"/>
+            <ac:spMk id="5" creationId="{00000000-0000-0000-0000-000000000000}"/>
+          </ac:spMkLst>
+        </pc:spChg>
+        <pc:spChg chg="mod">
+          <ac:chgData name="Giovanardi Fabio" userId="f4a989cf-038f-4c93-aae6-0cbdd9f74f63" providerId="ADAL" clId="{D979BA3E-480B-4515-8F4F-734DE973C2AB}" dt="2026-06-01T07:02:39.109" v="41" actId="1076"/>
+          <ac:spMkLst>
+            <pc:docMk/>
+            <pc:sldMk cId="0" sldId="268"/>
+            <ac:spMk id="6" creationId="{00000000-0000-0000-0000-000000000000}"/>
+          </ac:spMkLst>
+        </pc:spChg>
+        <pc:spChg chg="mod">
+          <ac:chgData name="Giovanardi Fabio" userId="f4a989cf-038f-4c93-aae6-0cbdd9f74f63" providerId="ADAL" clId="{D979BA3E-480B-4515-8F4F-734DE973C2AB}" dt="2026-06-01T07:07:19.075" v="75" actId="20577"/>
+          <ac:spMkLst>
+            <pc:docMk/>
+            <pc:sldMk cId="0" sldId="268"/>
+            <ac:spMk id="8" creationId="{00000000-0000-0000-0000-000000000000}"/>
+          </ac:spMkLst>
+        </pc:spChg>
+        <pc:spChg chg="mod">
+          <ac:chgData name="Giovanardi Fabio" userId="f4a989cf-038f-4c93-aae6-0cbdd9f74f63" providerId="ADAL" clId="{D979BA3E-480B-4515-8F4F-734DE973C2AB}" dt="2026-06-01T07:07:23.322" v="85" actId="20577"/>
+          <ac:spMkLst>
+            <pc:docMk/>
+            <pc:sldMk cId="0" sldId="268"/>
+            <ac:spMk id="9" creationId="{00000000-0000-0000-0000-000000000000}"/>
+          </ac:spMkLst>
+        </pc:spChg>
+        <pc:spChg chg="mod">
+          <ac:chgData name="Giovanardi Fabio" userId="f4a989cf-038f-4c93-aae6-0cbdd9f74f63" providerId="ADAL" clId="{D979BA3E-480B-4515-8F4F-734DE973C2AB}" dt="2026-06-01T07:02:32.964" v="40" actId="1076"/>
+          <ac:spMkLst>
+            <pc:docMk/>
+            <pc:sldMk cId="0" sldId="268"/>
+            <ac:spMk id="10" creationId="{00000000-0000-0000-0000-000000000000}"/>
+          </ac:spMkLst>
+        </pc:spChg>
+        <pc:spChg chg="mod">
+          <ac:chgData name="Giovanardi Fabio" userId="f4a989cf-038f-4c93-aae6-0cbdd9f74f63" providerId="ADAL" clId="{D979BA3E-480B-4515-8F4F-734DE973C2AB}" dt="2026-06-01T07:06:41.794" v="68" actId="1076"/>
+          <ac:spMkLst>
+            <pc:docMk/>
+            <pc:sldMk cId="0" sldId="268"/>
+            <ac:spMk id="12" creationId="{00000000-0000-0000-0000-000000000000}"/>
+          </ac:spMkLst>
+        </pc:spChg>
+        <pc:spChg chg="mod">
+          <ac:chgData name="Giovanardi Fabio" userId="f4a989cf-038f-4c93-aae6-0cbdd9f74f63" providerId="ADAL" clId="{D979BA3E-480B-4515-8F4F-734DE973C2AB}" dt="2026-06-01T07:02:39.109" v="41" actId="1076"/>
+          <ac:spMkLst>
+            <pc:docMk/>
+            <pc:sldMk cId="0" sldId="268"/>
+            <ac:spMk id="13" creationId="{00000000-0000-0000-0000-000000000000}"/>
+          </ac:spMkLst>
+        </pc:spChg>
+        <pc:spChg chg="mod">
+          <ac:chgData name="Giovanardi Fabio" userId="f4a989cf-038f-4c93-aae6-0cbdd9f74f63" providerId="ADAL" clId="{D979BA3E-480B-4515-8F4F-734DE973C2AB}" dt="2026-06-01T07:01:34.784" v="32" actId="20577"/>
+          <ac:spMkLst>
+            <pc:docMk/>
+            <pc:sldMk cId="0" sldId="268"/>
+            <ac:spMk id="14" creationId="{00000000-0000-0000-0000-000000000000}"/>
+          </ac:spMkLst>
+        </pc:spChg>
+        <pc:spChg chg="del mod">
+          <ac:chgData name="Giovanardi Fabio" userId="f4a989cf-038f-4c93-aae6-0cbdd9f74f63" providerId="ADAL" clId="{D979BA3E-480B-4515-8F4F-734DE973C2AB}" dt="2026-06-01T07:05:49.058" v="57" actId="478"/>
+          <ac:spMkLst>
+            <pc:docMk/>
+            <pc:sldMk cId="0" sldId="268"/>
+            <ac:spMk id="16" creationId="{00000000-0000-0000-0000-000000000000}"/>
+          </ac:spMkLst>
+        </pc:spChg>
+        <pc:spChg chg="mod">
+          <ac:chgData name="Giovanardi Fabio" userId="f4a989cf-038f-4c93-aae6-0cbdd9f74f63" providerId="ADAL" clId="{D979BA3E-480B-4515-8F4F-734DE973C2AB}" dt="2026-06-01T07:07:07.098" v="70" actId="1076"/>
+          <ac:spMkLst>
+            <pc:docMk/>
+            <pc:sldMk cId="0" sldId="268"/>
+            <ac:spMk id="17" creationId="{00000000-0000-0000-0000-000000000000}"/>
+          </ac:spMkLst>
+        </pc:spChg>
+        <pc:spChg chg="mod">
+          <ac:chgData name="Giovanardi Fabio" userId="f4a989cf-038f-4c93-aae6-0cbdd9f74f63" providerId="ADAL" clId="{D979BA3E-480B-4515-8F4F-734DE973C2AB}" dt="2026-06-01T07:07:07.098" v="70" actId="1076"/>
+          <ac:spMkLst>
+            <pc:docMk/>
+            <pc:sldMk cId="0" sldId="268"/>
+            <ac:spMk id="18" creationId="{00000000-0000-0000-0000-000000000000}"/>
+          </ac:spMkLst>
+        </pc:spChg>
+        <pc:spChg chg="mod">
+          <ac:chgData name="Giovanardi Fabio" userId="f4a989cf-038f-4c93-aae6-0cbdd9f74f63" providerId="ADAL" clId="{D979BA3E-480B-4515-8F4F-734DE973C2AB}" dt="2026-06-01T07:07:07.098" v="70" actId="1076"/>
+          <ac:spMkLst>
+            <pc:docMk/>
+            <pc:sldMk cId="0" sldId="268"/>
+            <ac:spMk id="19" creationId="{00000000-0000-0000-0000-000000000000}"/>
+          </ac:spMkLst>
+        </pc:spChg>
+        <pc:spChg chg="mod">
+          <ac:chgData name="Giovanardi Fabio" userId="f4a989cf-038f-4c93-aae6-0cbdd9f74f63" providerId="ADAL" clId="{D979BA3E-480B-4515-8F4F-734DE973C2AB}" dt="2026-06-01T07:02:39.109" v="41" actId="1076"/>
+          <ac:spMkLst>
+            <pc:docMk/>
+            <pc:sldMk cId="0" sldId="268"/>
+            <ac:spMk id="20" creationId="{00000000-0000-0000-0000-000000000000}"/>
+          </ac:spMkLst>
+        </pc:spChg>
+        <pc:spChg chg="mod">
+          <ac:chgData name="Giovanardi Fabio" userId="f4a989cf-038f-4c93-aae6-0cbdd9f74f63" providerId="ADAL" clId="{D979BA3E-480B-4515-8F4F-734DE973C2AB}" dt="2026-06-01T07:02:21.344" v="39" actId="1076"/>
+          <ac:spMkLst>
+            <pc:docMk/>
+            <pc:sldMk cId="0" sldId="268"/>
+            <ac:spMk id="21" creationId="{00000000-0000-0000-0000-000000000000}"/>
+          </ac:spMkLst>
+        </pc:spChg>
+        <pc:spChg chg="mod">
+          <ac:chgData name="Giovanardi Fabio" userId="f4a989cf-038f-4c93-aae6-0cbdd9f74f63" providerId="ADAL" clId="{D979BA3E-480B-4515-8F4F-734DE973C2AB}" dt="2026-06-01T07:01:36.104" v="34" actId="20577"/>
+          <ac:spMkLst>
+            <pc:docMk/>
+            <pc:sldMk cId="0" sldId="268"/>
+            <ac:spMk id="22" creationId="{00000000-0000-0000-0000-000000000000}"/>
+          </ac:spMkLst>
+        </pc:spChg>
+        <pc:spChg chg="mod">
+          <ac:chgData name="Giovanardi Fabio" userId="f4a989cf-038f-4c93-aae6-0cbdd9f74f63" providerId="ADAL" clId="{D979BA3E-480B-4515-8F4F-734DE973C2AB}" dt="2026-06-01T07:02:39.109" v="41" actId="1076"/>
+          <ac:spMkLst>
+            <pc:docMk/>
+            <pc:sldMk cId="0" sldId="268"/>
+            <ac:spMk id="23" creationId="{00000000-0000-0000-0000-000000000000}"/>
+          </ac:spMkLst>
+        </pc:spChg>
+        <pc:spChg chg="mod">
+          <ac:chgData name="Giovanardi Fabio" userId="f4a989cf-038f-4c93-aae6-0cbdd9f74f63" providerId="ADAL" clId="{D979BA3E-480B-4515-8F4F-734DE973C2AB}" dt="2026-06-01T07:07:57.912" v="104" actId="20577"/>
+          <ac:spMkLst>
+            <pc:docMk/>
+            <pc:sldMk cId="0" sldId="268"/>
+            <ac:spMk id="24" creationId="{00000000-0000-0000-0000-000000000000}"/>
+          </ac:spMkLst>
+        </pc:spChg>
+        <pc:spChg chg="mod">
+          <ac:chgData name="Giovanardi Fabio" userId="f4a989cf-038f-4c93-aae6-0cbdd9f74f63" providerId="ADAL" clId="{D979BA3E-480B-4515-8F4F-734DE973C2AB}" dt="2026-06-01T07:07:54.204" v="98" actId="20577"/>
+          <ac:spMkLst>
+            <pc:docMk/>
+            <pc:sldMk cId="0" sldId="268"/>
+            <ac:spMk id="25" creationId="{00000000-0000-0000-0000-000000000000}"/>
+          </ac:spMkLst>
+        </pc:spChg>
+        <pc:spChg chg="del mod">
+          <ac:chgData name="Giovanardi Fabio" userId="f4a989cf-038f-4c93-aae6-0cbdd9f74f63" providerId="ADAL" clId="{D979BA3E-480B-4515-8F4F-734DE973C2AB}" dt="2026-06-01T07:10:30.060" v="224" actId="478"/>
+          <ac:spMkLst>
+            <pc:docMk/>
+            <pc:sldMk cId="0" sldId="268"/>
+            <ac:spMk id="27" creationId="{00000000-0000-0000-0000-000000000000}"/>
+          </ac:spMkLst>
+        </pc:spChg>
+        <pc:spChg chg="mod">
+          <ac:chgData name="Giovanardi Fabio" userId="f4a989cf-038f-4c93-aae6-0cbdd9f74f63" providerId="ADAL" clId="{D979BA3E-480B-4515-8F4F-734DE973C2AB}" dt="2026-06-01T07:03:06.472" v="51" actId="14100"/>
+          <ac:spMkLst>
+            <pc:docMk/>
+            <pc:sldMk cId="0" sldId="268"/>
+            <ac:spMk id="28" creationId="{00000000-0000-0000-0000-000000000000}"/>
+          </ac:spMkLst>
+        </pc:spChg>
+        <pc:spChg chg="mod">
+          <ac:chgData name="Giovanardi Fabio" userId="f4a989cf-038f-4c93-aae6-0cbdd9f74f63" providerId="ADAL" clId="{D979BA3E-480B-4515-8F4F-734DE973C2AB}" dt="2026-06-01T07:03:17.063" v="55" actId="14100"/>
+          <ac:spMkLst>
+            <pc:docMk/>
+            <pc:sldMk cId="0" sldId="268"/>
+            <ac:spMk id="29" creationId="{00000000-0000-0000-0000-000000000000}"/>
+          </ac:spMkLst>
+        </pc:spChg>
+        <pc:spChg chg="mod">
+          <ac:chgData name="Giovanardi Fabio" userId="f4a989cf-038f-4c93-aae6-0cbdd9f74f63" providerId="ADAL" clId="{D979BA3E-480B-4515-8F4F-734DE973C2AB}" dt="2026-06-01T07:03:24.232" v="56" actId="1076"/>
+          <ac:spMkLst>
+            <pc:docMk/>
+            <pc:sldMk cId="0" sldId="268"/>
+            <ac:spMk id="30" creationId="{00000000-0000-0000-0000-000000000000}"/>
+          </ac:spMkLst>
+        </pc:spChg>
+        <pc:spChg chg="mod">
+          <ac:chgData name="Giovanardi Fabio" userId="f4a989cf-038f-4c93-aae6-0cbdd9f74f63" providerId="ADAL" clId="{D979BA3E-480B-4515-8F4F-734DE973C2AB}" dt="2026-06-01T07:03:09.968" v="52" actId="1076"/>
+          <ac:spMkLst>
+            <pc:docMk/>
+            <pc:sldMk cId="0" sldId="268"/>
+            <ac:spMk id="31" creationId="{00000000-0000-0000-0000-000000000000}"/>
+          </ac:spMkLst>
+        </pc:spChg>
+        <pc:spChg chg="add del mod">
+          <ac:chgData name="Giovanardi Fabio" userId="f4a989cf-038f-4c93-aae6-0cbdd9f74f63" providerId="ADAL" clId="{D979BA3E-480B-4515-8F4F-734DE973C2AB}" dt="2026-06-01T07:07:38.499" v="88" actId="478"/>
+          <ac:spMkLst>
+            <pc:docMk/>
+            <pc:sldMk cId="0" sldId="268"/>
+            <ac:spMk id="32" creationId="{4F9D7F29-CB1F-AE51-CD7D-BA98170FBD51}"/>
+          </ac:spMkLst>
+        </pc:spChg>
+      </pc:sldChg>
+      <pc:sldChg chg="modSp mod">
+        <pc:chgData name="Giovanardi Fabio" userId="f4a989cf-038f-4c93-aae6-0cbdd9f74f63" providerId="ADAL" clId="{D979BA3E-480B-4515-8F4F-734DE973C2AB}" dt="2026-06-01T07:08:56.122" v="210" actId="20577"/>
+        <pc:sldMkLst>
+          <pc:docMk/>
+          <pc:sldMk cId="0" sldId="269"/>
+        </pc:sldMkLst>
+        <pc:spChg chg="mod">
+          <ac:chgData name="Giovanardi Fabio" userId="f4a989cf-038f-4c93-aae6-0cbdd9f74f63" providerId="ADAL" clId="{D979BA3E-480B-4515-8F4F-734DE973C2AB}" dt="2026-06-01T07:08:40.598" v="119" actId="20577"/>
+          <ac:spMkLst>
+            <pc:docMk/>
+            <pc:sldMk cId="0" sldId="269"/>
+            <ac:spMk id="10" creationId="{00000000-0000-0000-0000-000000000000}"/>
+          </ac:spMkLst>
+        </pc:spChg>
+        <pc:spChg chg="mod">
+          <ac:chgData name="Giovanardi Fabio" userId="f4a989cf-038f-4c93-aae6-0cbdd9f74f63" providerId="ADAL" clId="{D979BA3E-480B-4515-8F4F-734DE973C2AB}" dt="2026-06-01T07:08:46.609" v="143" actId="20577"/>
+          <ac:spMkLst>
+            <pc:docMk/>
+            <pc:sldMk cId="0" sldId="269"/>
+            <ac:spMk id="15" creationId="{00000000-0000-0000-0000-000000000000}"/>
+          </ac:spMkLst>
+        </pc:spChg>
+        <pc:spChg chg="mod">
+          <ac:chgData name="Giovanardi Fabio" userId="f4a989cf-038f-4c93-aae6-0cbdd9f74f63" providerId="ADAL" clId="{D979BA3E-480B-4515-8F4F-734DE973C2AB}" dt="2026-06-01T07:08:51.036" v="177" actId="20577"/>
+          <ac:spMkLst>
+            <pc:docMk/>
+            <pc:sldMk cId="0" sldId="269"/>
+            <ac:spMk id="20" creationId="{00000000-0000-0000-0000-000000000000}"/>
+          </ac:spMkLst>
+        </pc:spChg>
+        <pc:spChg chg="mod">
+          <ac:chgData name="Giovanardi Fabio" userId="f4a989cf-038f-4c93-aae6-0cbdd9f74f63" providerId="ADAL" clId="{D979BA3E-480B-4515-8F4F-734DE973C2AB}" dt="2026-06-01T07:08:56.122" v="210" actId="20577"/>
+          <ac:spMkLst>
+            <pc:docMk/>
+            <pc:sldMk cId="0" sldId="269"/>
+            <ac:spMk id="30" creationId="{00000000-0000-0000-0000-000000000000}"/>
+          </ac:spMkLst>
+        </pc:spChg>
       </pc:sldChg>
     </pc:docChg>
   </pc:docChgLst>
@@ -1330,10 +1663,9 @@
             </a:lnSpc>
           </a:pPr>
           <a:r>
-            <a:rPr lang="fr-FR"/>
+            <a:rPr lang="fr-FR" noProof="0" dirty="0"/>
             <a:t>Origine / objectif du projet</a:t>
           </a:r>
-          <a:endParaRPr lang="en-US"/>
         </a:p>
       </dgm:t>
     </dgm:pt>
@@ -1372,10 +1704,9 @@
             </a:lnSpc>
           </a:pPr>
           <a:r>
-            <a:rPr lang="fr-FR"/>
+            <a:rPr lang="fr-FR" noProof="0" dirty="0"/>
             <a:t>Diagramme GANTT</a:t>
           </a:r>
-          <a:endParaRPr lang="en-US"/>
         </a:p>
       </dgm:t>
     </dgm:pt>
@@ -1414,10 +1745,9 @@
             </a:lnSpc>
           </a:pPr>
           <a:r>
-            <a:rPr lang="fr-FR"/>
+            <a:rPr lang="fr-FR" noProof="0" dirty="0"/>
             <a:t>Structure du code</a:t>
           </a:r>
-          <a:endParaRPr lang="en-US"/>
         </a:p>
       </dgm:t>
     </dgm:pt>
@@ -1456,10 +1786,9 @@
             </a:lnSpc>
           </a:pPr>
           <a:r>
-            <a:rPr lang="fr-FR"/>
+            <a:rPr lang="fr-FR" noProof="0" dirty="0"/>
             <a:t>Site WEB</a:t>
           </a:r>
-          <a:endParaRPr lang="en-US"/>
         </a:p>
       </dgm:t>
     </dgm:pt>
@@ -1498,10 +1827,9 @@
             </a:lnSpc>
           </a:pPr>
           <a:r>
-            <a:rPr lang="fr-FR"/>
+            <a:rPr lang="fr-FR" noProof="0" dirty="0"/>
             <a:t>Difficultés / facilités rencontrés</a:t>
           </a:r>
-          <a:endParaRPr lang="en-US"/>
         </a:p>
       </dgm:t>
     </dgm:pt>
@@ -1540,10 +1868,9 @@
             </a:lnSpc>
           </a:pPr>
           <a:r>
-            <a:rPr lang="fr-FR"/>
+            <a:rPr lang="fr-FR" noProof="0" dirty="0"/>
             <a:t>Avant-projet</a:t>
           </a:r>
-          <a:endParaRPr lang="en-US"/>
         </a:p>
       </dgm:t>
     </dgm:pt>
@@ -1582,10 +1909,9 @@
             </a:lnSpc>
           </a:pPr>
           <a:r>
-            <a:rPr lang="fr-FR"/>
+            <a:rPr lang="fr-FR" noProof="0" dirty="0"/>
             <a:t>Conclusion</a:t>
           </a:r>
-          <a:endParaRPr lang="en-US"/>
         </a:p>
       </dgm:t>
     </dgm:pt>
@@ -2178,10 +2504,9 @@
             <a:buNone/>
           </a:pPr>
           <a:r>
-            <a:rPr lang="fr-FR" sz="1600" kern="1200"/>
+            <a:rPr lang="fr-FR" sz="1600" kern="1200" noProof="0" dirty="0"/>
             <a:t>Origine / objectif du projet</a:t>
           </a:r>
-          <a:endParaRPr lang="en-US" sz="1600" kern="1200"/>
         </a:p>
       </dsp:txBody>
       <dsp:txXfrm>
@@ -2330,10 +2655,9 @@
             <a:buNone/>
           </a:pPr>
           <a:r>
-            <a:rPr lang="fr-FR" sz="1600" kern="1200"/>
+            <a:rPr lang="fr-FR" sz="1600" kern="1200" noProof="0" dirty="0"/>
             <a:t>Avant-projet</a:t>
           </a:r>
-          <a:endParaRPr lang="en-US" sz="1600" kern="1200"/>
         </a:p>
       </dsp:txBody>
       <dsp:txXfrm>
@@ -2490,10 +2814,9 @@
             <a:buNone/>
           </a:pPr>
           <a:r>
-            <a:rPr lang="fr-FR" sz="1600" kern="1200"/>
+            <a:rPr lang="fr-FR" sz="1600" kern="1200" noProof="0" dirty="0"/>
             <a:t>Diagramme GANTT</a:t>
           </a:r>
-          <a:endParaRPr lang="en-US" sz="1600" kern="1200"/>
         </a:p>
       </dsp:txBody>
       <dsp:txXfrm>
@@ -2650,10 +2973,9 @@
             <a:buNone/>
           </a:pPr>
           <a:r>
-            <a:rPr lang="fr-FR" sz="1600" kern="1200"/>
+            <a:rPr lang="fr-FR" sz="1600" kern="1200" noProof="0" dirty="0"/>
             <a:t>Structure du code</a:t>
           </a:r>
-          <a:endParaRPr lang="en-US" sz="1600" kern="1200"/>
         </a:p>
       </dsp:txBody>
       <dsp:txXfrm>
@@ -2810,10 +3132,9 @@
             <a:buNone/>
           </a:pPr>
           <a:r>
-            <a:rPr lang="fr-FR" sz="1600" kern="1200"/>
+            <a:rPr lang="fr-FR" sz="1600" kern="1200" noProof="0" dirty="0"/>
             <a:t>Site WEB</a:t>
           </a:r>
-          <a:endParaRPr lang="en-US" sz="1600" kern="1200"/>
         </a:p>
       </dsp:txBody>
       <dsp:txXfrm>
@@ -2970,10 +3291,9 @@
             <a:buNone/>
           </a:pPr>
           <a:r>
-            <a:rPr lang="fr-FR" sz="1600" kern="1200"/>
+            <a:rPr lang="fr-FR" sz="1600" kern="1200" noProof="0" dirty="0"/>
             <a:t>Difficultés / facilités rencontrés</a:t>
           </a:r>
-          <a:endParaRPr lang="en-US" sz="1600" kern="1200"/>
         </a:p>
       </dsp:txBody>
       <dsp:txXfrm>
@@ -3134,10 +3454,9 @@
             <a:buNone/>
           </a:pPr>
           <a:r>
-            <a:rPr lang="fr-FR" sz="1600" kern="1200"/>
+            <a:rPr lang="fr-FR" sz="1600" kern="1200" noProof="0" dirty="0"/>
             <a:t>Conclusion</a:t>
           </a:r>
-          <a:endParaRPr lang="en-US" sz="1600" kern="1200"/>
         </a:p>
       </dsp:txBody>
       <dsp:txXfrm>
@@ -4871,7 +5190,7 @@
           <a:bodyPr/>
           <a:lstStyle/>
           <a:p>
-            <a:endParaRPr lang="en-US" dirty="0"/>
+            <a:endParaRPr lang="en-US"/>
           </a:p>
         </p:txBody>
       </p:sp>
@@ -4930,7 +5249,7 @@
       </p:grpSpPr>
       <p:sp>
         <p:nvSpPr>
-          <p:cNvPr id="2" name="Slide Image Placeholder 1"/>
+          <p:cNvPr id="2" name="Espace réservé de l'image des diapositives 1"/>
           <p:cNvSpPr>
             <a:spLocks noGrp="1" noRot="1" noChangeAspect="1"/>
           </p:cNvSpPr>
@@ -4942,7 +5261,7 @@
       </p:sp>
       <p:sp>
         <p:nvSpPr>
-          <p:cNvPr id="3" name="Notes Placeholder 2"/>
+          <p:cNvPr id="3" name="Espace réservé des notes 2"/>
           <p:cNvSpPr>
             <a:spLocks noGrp="1"/>
           </p:cNvSpPr>
@@ -4955,18 +5274,178 @@
           <a:bodyPr/>
           <a:lstStyle/>
           <a:p>
-            <a:endParaRPr lang="en-US" dirty="0"/>
-          </a:p>
-        </p:txBody>
-      </p:sp>
-      <p:sp>
-        <p:nvSpPr>
-          <p:cNvPr id="4" name="Slide Number Placeholder 3"/>
+            <a:r>
+              <a:rPr lang="fr-FR" b="1" dirty="0"/>
+              <a:t>Tâches réalisées plus vite que prévu :</a:t>
+            </a:r>
+            <a:endParaRPr lang="fr-FR" dirty="0"/>
+          </a:p>
+          <a:p>
+            <a:r>
+              <a:rPr lang="fr-FR" dirty="0"/>
+              <a:t>Présentation (-30%) : contenu maîtrisé, slides faites en une session</a:t>
+            </a:r>
+          </a:p>
+          <a:p>
+            <a:r>
+              <a:rPr lang="fr-FR" dirty="0"/>
+              <a:t>HTML/CSS (-20%) : compétences existantes, design fluide dès le départ</a:t>
+            </a:r>
+          </a:p>
+          <a:p>
+            <a:r>
+              <a:rPr lang="fr-FR" dirty="0"/>
+              <a:t>Frontend Leaflet + </a:t>
+            </a:r>
+            <a:r>
+              <a:rPr lang="fr-FR" dirty="0" err="1"/>
+              <a:t>Swisstopo</a:t>
+            </a:r>
+            <a:r>
+              <a:rPr lang="fr-FR" dirty="0"/>
+              <a:t> (-10%) : API gratuite, bien documentée, intégration rapide</a:t>
+            </a:r>
+          </a:p>
+          <a:p>
+            <a:r>
+              <a:rPr lang="fr-FR" b="1" dirty="0"/>
+              <a:t>Dans les temps :</a:t>
+            </a:r>
+            <a:endParaRPr lang="fr-FR" dirty="0"/>
+          </a:p>
+          <a:p>
+            <a:r>
+              <a:rPr lang="fr-FR" dirty="0"/>
+              <a:t>Formulaires sport (UI) : travail répétitif mais borné — 3 blocs similaires</a:t>
+            </a:r>
+          </a:p>
+          <a:p>
+            <a:r>
+              <a:rPr lang="fr-FR" dirty="0"/>
+              <a:t>Architecture API + .</a:t>
+            </a:r>
+            <a:r>
+              <a:rPr lang="fr-FR" dirty="0" err="1"/>
+              <a:t>env</a:t>
+            </a:r>
+            <a:r>
+              <a:rPr lang="fr-FR" dirty="0"/>
+              <a:t> : Gin bien structuré, routes déclarées rapidement</a:t>
+            </a:r>
+          </a:p>
+          <a:p>
+            <a:r>
+              <a:rPr lang="fr-FR" b="1" dirty="0"/>
+              <a:t>Légers dépassements :</a:t>
+            </a:r>
+            <a:endParaRPr lang="fr-FR" dirty="0"/>
+          </a:p>
+          <a:p>
+            <a:r>
+              <a:rPr lang="fr-FR" dirty="0"/>
+              <a:t>Choix stack technique (+10%) : débat plus long que prévu entre Flask/Go et Leaflet/</a:t>
+            </a:r>
+            <a:r>
+              <a:rPr lang="fr-FR" dirty="0" err="1"/>
+              <a:t>OpenLayers</a:t>
+            </a:r>
+            <a:endParaRPr lang="fr-FR" dirty="0"/>
+          </a:p>
+          <a:p>
+            <a:r>
+              <a:rPr lang="fr-FR" dirty="0"/>
+              <a:t>Affichage GPX + export (+40%) : format GPX plus contraignant, bugs d'encodage XML</a:t>
+            </a:r>
+          </a:p>
+          <a:p>
+            <a:r>
+              <a:rPr lang="fr-FR" dirty="0"/>
+              <a:t>Documentation du code (+60%) : 18 fichiers à commenter, sous-estimé</a:t>
+            </a:r>
+          </a:p>
+          <a:p>
+            <a:r>
+              <a:rPr lang="fr-FR" b="1" dirty="0"/>
+              <a:t>Dépassements importants :</a:t>
+            </a:r>
+            <a:endParaRPr lang="fr-FR" dirty="0"/>
+          </a:p>
+          <a:p>
+            <a:r>
+              <a:rPr lang="fr-FR" dirty="0"/>
+              <a:t>Intégration </a:t>
+            </a:r>
+            <a:r>
+              <a:rPr lang="fr-FR" dirty="0" err="1"/>
+              <a:t>frontend↔backend</a:t>
+            </a:r>
+            <a:r>
+              <a:rPr lang="fr-FR" dirty="0"/>
+              <a:t> (+80%) : problèmes CORS, variables globales JS non synchronisées, cache navigateur</a:t>
+            </a:r>
+          </a:p>
+          <a:p>
+            <a:r>
+              <a:rPr lang="fr-FR" dirty="0"/>
+              <a:t>Tests &amp; calibrage boucles (+120%) : boucles triangulaires à ajuster, facteur sinuosité 2.6 à trouver empiriquement</a:t>
+            </a:r>
+          </a:p>
+          <a:p>
+            <a:r>
+              <a:rPr lang="fr-FR" b="1" dirty="0"/>
+              <a:t>Dépassements critiques :</a:t>
+            </a:r>
+            <a:endParaRPr lang="fr-FR" dirty="0"/>
+          </a:p>
+          <a:p>
+            <a:r>
+              <a:rPr lang="fr-FR" dirty="0"/>
+              <a:t>Formules FTP/VAP/Naismith (+150%) : calibrage sur vrais parcours, plusieurs aller-retours pour atteindre moins de 2 min d'écart</a:t>
+            </a:r>
+          </a:p>
+          <a:p>
+            <a:r>
+              <a:rPr lang="fr-FR" dirty="0"/>
+              <a:t>Import OSM / </a:t>
+            </a:r>
+            <a:r>
+              <a:rPr lang="fr-FR" dirty="0" err="1"/>
+              <a:t>pgRouting</a:t>
+            </a:r>
+            <a:r>
+              <a:rPr lang="fr-FR" dirty="0"/>
+              <a:t> (+200%) : Docker, topologie source/</a:t>
+            </a:r>
+            <a:r>
+              <a:rPr lang="fr-FR" dirty="0" err="1"/>
+              <a:t>target</a:t>
+            </a:r>
+            <a:r>
+              <a:rPr lang="fr-FR" dirty="0"/>
+              <a:t>/</a:t>
+            </a:r>
+            <a:r>
+              <a:rPr lang="fr-FR" dirty="0" err="1"/>
+              <a:t>cost</a:t>
+            </a:r>
+            <a:r>
+              <a:rPr lang="fr-FR" dirty="0"/>
+              <a:t>, nœuds non connectés, zones sans routes</a:t>
+            </a:r>
+          </a:p>
+          <a:p>
+            <a:endParaRPr lang="fr-CH" dirty="0"/>
+          </a:p>
+        </p:txBody>
+      </p:sp>
+      <p:sp>
+        <p:nvSpPr>
+          <p:cNvPr id="4" name="Espace réservé du numéro de diapositive 3"/>
           <p:cNvSpPr>
             <a:spLocks noGrp="1"/>
           </p:cNvSpPr>
           <p:nvPr>
-            <p:ph type="sldNum" sz="quarter" idx="10"/>
+            <p:ph type="sldNum" sz="quarter" idx="5"/>
           </p:nvPr>
         </p:nvSpPr>
         <p:spPr/>
@@ -4974,18 +5453,18 @@
           <a:bodyPr/>
           <a:lstStyle/>
           <a:p>
-            <a:fld id="{F7021451-1387-4CA6-816F-3879F97B5CBC}" type="slidenum">
-              <a:rPr lang="en-US"/>
-              <a:t>5</a:t>
+            <a:fld id="{07F5F5F3-2232-403D-852D-FC961377BE07}" type="slidenum">
+              <a:rPr lang="fr-CH" smtClean="0"/>
+              <a:t>4</a:t>
             </a:fld>
-            <a:endParaRPr lang="en-US"/>
+            <a:endParaRPr lang="fr-CH"/>
           </a:p>
         </p:txBody>
       </p:sp>
     </p:spTree>
     <p:extLst>
       <p:ext uri="{BB962C8B-B14F-4D97-AF65-F5344CB8AC3E}">
-        <p14:creationId xmlns:p14="http://schemas.microsoft.com/office/powerpoint/2010/main" val="1024086991"/>
+        <p14:creationId xmlns:p14="http://schemas.microsoft.com/office/powerpoint/2010/main" val="139015692"/>
       </p:ext>
     </p:extLst>
   </p:cSld>
@@ -5039,6 +5518,305 @@
           <a:bodyPr/>
           <a:lstStyle/>
           <a:p>
+            <a:r>
+              <a:rPr lang="fr-FR" b="1" dirty="0"/>
+              <a:t>Frontend — ce que voit l'utilisateur dans le navigateur</a:t>
+            </a:r>
+            <a:endParaRPr lang="fr-FR" dirty="0"/>
+          </a:p>
+          <a:p>
+            <a:r>
+              <a:rPr lang="fr-FR" b="1" dirty="0"/>
+              <a:t>HTML/CSS/JS</a:t>
+            </a:r>
+            <a:r>
+              <a:rPr lang="fr-FR" dirty="0"/>
+              <a:t> </a:t>
+            </a:r>
+          </a:p>
+          <a:p>
+            <a:r>
+              <a:rPr lang="fr-FR" b="1" dirty="0"/>
+              <a:t>Leaflet.js</a:t>
+            </a:r>
+            <a:r>
+              <a:rPr lang="fr-FR" dirty="0"/>
+              <a:t> : la bibliothèque qui affiche la carte interactive. Elle gère les tuiles, les marqueurs, les </a:t>
+            </a:r>
+            <a:r>
+              <a:rPr lang="fr-FR" dirty="0" err="1"/>
+              <a:t>popups</a:t>
+            </a:r>
+            <a:r>
+              <a:rPr lang="fr-FR" dirty="0"/>
+              <a:t> et les tracés </a:t>
+            </a:r>
+            <a:r>
+              <a:rPr lang="fr-FR" dirty="0" err="1"/>
+              <a:t>GeoJSON</a:t>
+            </a:r>
+            <a:r>
+              <a:rPr lang="fr-FR" dirty="0"/>
+              <a:t>.</a:t>
+            </a:r>
+          </a:p>
+          <a:p>
+            <a:r>
+              <a:rPr lang="fr-FR" b="1" dirty="0" err="1"/>
+              <a:t>Swisstopo</a:t>
+            </a:r>
+            <a:r>
+              <a:rPr lang="fr-FR" b="1" dirty="0"/>
+              <a:t> WMTS</a:t>
+            </a:r>
+            <a:r>
+              <a:rPr lang="fr-FR" dirty="0"/>
+              <a:t> : les fonds de carte (topographique et </a:t>
+            </a:r>
+            <a:r>
+              <a:rPr lang="fr-FR" dirty="0" err="1"/>
+              <a:t>orthophoto</a:t>
+            </a:r>
+            <a:r>
+              <a:rPr lang="fr-FR" dirty="0"/>
+              <a:t>) viennent de </a:t>
+            </a:r>
+            <a:r>
+              <a:rPr lang="fr-FR" dirty="0" err="1"/>
+              <a:t>Swisstopo</a:t>
+            </a:r>
+            <a:r>
+              <a:rPr lang="fr-FR" dirty="0"/>
+              <a:t> via le protocole WMTS </a:t>
+            </a:r>
+          </a:p>
+          <a:p>
+            <a:r>
+              <a:rPr lang="fr-FR" b="1" dirty="0" err="1"/>
+              <a:t>OpenStreetMap</a:t>
+            </a:r>
+            <a:r>
+              <a:rPr lang="fr-FR" dirty="0"/>
+              <a:t> : la base de données géographique collaborative dont viennent toutes nos routes. Utilisée pour le géocodage (</a:t>
+            </a:r>
+            <a:r>
+              <a:rPr lang="fr-FR" dirty="0" err="1"/>
+              <a:t>Nominatim</a:t>
+            </a:r>
+            <a:r>
+              <a:rPr lang="fr-FR" dirty="0"/>
+              <a:t>) et les données importées dans </a:t>
+            </a:r>
+            <a:r>
+              <a:rPr lang="fr-FR" dirty="0" err="1"/>
+              <a:t>pgRouting</a:t>
+            </a:r>
+            <a:r>
+              <a:rPr lang="fr-FR" dirty="0"/>
+              <a:t>.</a:t>
+            </a:r>
+          </a:p>
+          <a:p>
+            <a:r>
+              <a:rPr lang="fr-FR" b="1" dirty="0"/>
+              <a:t>6 fichiers JS modulaires</a:t>
+            </a:r>
+            <a:r>
+              <a:rPr lang="fr-FR" dirty="0"/>
+              <a:t> : chaque fichier a une responsabilité précise map.js pour la carte, search.js pour la recherche, routing.js pour l'itinéraire A→B, etc. On évite un seul gros fichier ingérable.</a:t>
+            </a:r>
+          </a:p>
+          <a:p>
+            <a:br>
+              <a:rPr lang="fr-FR" dirty="0"/>
+            </a:br>
+            <a:endParaRPr lang="fr-FR" dirty="0"/>
+          </a:p>
+          <a:p>
+            <a:r>
+              <a:rPr lang="fr-FR" b="1" dirty="0"/>
+              <a:t>Backend — le serveur Go</a:t>
+            </a:r>
+            <a:endParaRPr lang="fr-FR" dirty="0"/>
+          </a:p>
+          <a:p>
+            <a:r>
+              <a:rPr lang="fr-FR" b="1" dirty="0"/>
+              <a:t>Go 1.21 + Gin</a:t>
+            </a:r>
+            <a:r>
+              <a:rPr lang="fr-FR" dirty="0"/>
+              <a:t> : Go est un langage compilé très rapide. Gin est un mini-</a:t>
+            </a:r>
+            <a:r>
+              <a:rPr lang="fr-FR" dirty="0" err="1"/>
+              <a:t>framework</a:t>
+            </a:r>
+            <a:r>
+              <a:rPr lang="fr-FR" dirty="0"/>
+              <a:t> HTTP qui simplifie la déclaration des routes. Le serveur répond aux requêtes en moins de 5ms.</a:t>
+            </a:r>
+          </a:p>
+          <a:p>
+            <a:r>
+              <a:rPr lang="fr-FR" b="1" dirty="0"/>
+              <a:t>REST API 5 </a:t>
+            </a:r>
+            <a:r>
+              <a:rPr lang="fr-FR" b="1" dirty="0" err="1"/>
+              <a:t>endpoints</a:t>
+            </a:r>
+            <a:r>
+              <a:rPr lang="fr-FR" dirty="0"/>
+              <a:t> : le backend expose 5 URLs que le frontend appelle — /api/route, /api/</a:t>
+            </a:r>
+            <a:r>
+              <a:rPr lang="fr-FR" dirty="0" err="1"/>
+              <a:t>search</a:t>
+            </a:r>
+            <a:r>
+              <a:rPr lang="fr-FR" dirty="0"/>
+              <a:t>-routes, /api/</a:t>
+            </a:r>
+            <a:r>
+              <a:rPr lang="fr-FR" dirty="0" err="1"/>
+              <a:t>osm-ways</a:t>
+            </a:r>
+            <a:r>
+              <a:rPr lang="fr-FR" dirty="0"/>
+              <a:t>, /api/pois, /api/</a:t>
+            </a:r>
+            <a:r>
+              <a:rPr lang="fr-FR" dirty="0" err="1"/>
+              <a:t>health</a:t>
+            </a:r>
+            <a:r>
+              <a:rPr lang="fr-FR" dirty="0"/>
+              <a:t>.</a:t>
+            </a:r>
+          </a:p>
+          <a:p>
+            <a:r>
+              <a:rPr lang="fr-FR" b="1" dirty="0"/>
+              <a:t>Fichiers statiques</a:t>
+            </a:r>
+            <a:r>
+              <a:rPr lang="fr-FR" dirty="0"/>
+              <a:t> : Go sert aussi directement le HTML, CSS et JS du frontend. Pas besoin de serveur web séparé (</a:t>
+            </a:r>
+            <a:r>
+              <a:rPr lang="fr-FR" dirty="0" err="1"/>
+              <a:t>nginx</a:t>
+            </a:r>
+            <a:r>
+              <a:rPr lang="fr-FR" dirty="0"/>
+              <a:t>, Apache).</a:t>
+            </a:r>
+          </a:p>
+          <a:p>
+            <a:r>
+              <a:rPr lang="fr-FR" b="1" dirty="0"/>
+              <a:t>Connexion via .</a:t>
+            </a:r>
+            <a:r>
+              <a:rPr lang="fr-FR" b="1" dirty="0" err="1"/>
+              <a:t>env</a:t>
+            </a:r>
+            <a:r>
+              <a:rPr lang="fr-FR" dirty="0"/>
+              <a:t> : les identifiants PostgreSQL (hôte, port, mot de passe) sont dans un fichier .</a:t>
+            </a:r>
+            <a:r>
+              <a:rPr lang="fr-FR" dirty="0" err="1"/>
+              <a:t>env</a:t>
+            </a:r>
+            <a:r>
+              <a:rPr lang="fr-FR" dirty="0"/>
+              <a:t> non versionné — bonne pratique de sécurité.</a:t>
+            </a:r>
+          </a:p>
+          <a:p>
+            <a:br>
+              <a:rPr lang="fr-FR" dirty="0"/>
+            </a:br>
+            <a:endParaRPr lang="fr-FR" dirty="0"/>
+          </a:p>
+          <a:p>
+            <a:r>
+              <a:rPr lang="fr-FR" b="1" dirty="0"/>
+              <a:t>Base de données — PostgreSQL + extensions géospatiales</a:t>
+            </a:r>
+            <a:endParaRPr lang="fr-FR" dirty="0"/>
+          </a:p>
+          <a:p>
+            <a:r>
+              <a:rPr lang="fr-FR" b="1" dirty="0"/>
+              <a:t>PostgreSQL 15</a:t>
+            </a:r>
+            <a:r>
+              <a:rPr lang="fr-FR" dirty="0"/>
+              <a:t> : base de données relationnelle open-source, la plus avancée du marché.</a:t>
+            </a:r>
+          </a:p>
+          <a:p>
+            <a:r>
+              <a:rPr lang="fr-FR" b="1" dirty="0" err="1"/>
+              <a:t>PostGIS</a:t>
+            </a:r>
+            <a:r>
+              <a:rPr lang="fr-FR" dirty="0"/>
+              <a:t> : extension qui ajoute les types géométriques (POINT, LINESTRING) et les fonctions spatiales (</a:t>
+            </a:r>
+            <a:r>
+              <a:rPr lang="fr-FR" dirty="0" err="1"/>
+              <a:t>ST_Distance</a:t>
+            </a:r>
+            <a:r>
+              <a:rPr lang="fr-FR" dirty="0"/>
+              <a:t>, </a:t>
+            </a:r>
+            <a:r>
+              <a:rPr lang="fr-FR" dirty="0" err="1"/>
+              <a:t>ST_Union</a:t>
+            </a:r>
+            <a:r>
+              <a:rPr lang="fr-FR" dirty="0"/>
+              <a:t>...). Sans </a:t>
+            </a:r>
+            <a:r>
+              <a:rPr lang="fr-FR" dirty="0" err="1"/>
+              <a:t>PostGIS</a:t>
+            </a:r>
+            <a:r>
+              <a:rPr lang="fr-FR" dirty="0"/>
+              <a:t>, PostgreSQL ne comprend pas ce qu'est une coordonnée GPS.</a:t>
+            </a:r>
+          </a:p>
+          <a:p>
+            <a:r>
+              <a:rPr lang="fr-FR" b="1" dirty="0" err="1"/>
+              <a:t>pgRouting</a:t>
+            </a:r>
+            <a:r>
+              <a:rPr lang="fr-FR" b="1" dirty="0"/>
+              <a:t> + Dijkstra</a:t>
+            </a:r>
+            <a:r>
+              <a:rPr lang="fr-FR" dirty="0"/>
+              <a:t> : extension qui ajoute les algorithmes de routage sur graphe. Dijkstra calcule le plus court chemin entre deux nœuds — c'est lui qui génère les itinéraires sur le vrai réseau routier OSM.</a:t>
+            </a:r>
+          </a:p>
+          <a:p>
+            <a:r>
+              <a:rPr lang="fr-FR" b="1" dirty="0"/>
+              <a:t>Docker Desktop</a:t>
+            </a:r>
+            <a:r>
+              <a:rPr lang="fr-FR" dirty="0"/>
+              <a:t> : la base de données tourne dans un conteneur isolé. Tout le monde a exactement le même environnement, pas de "ça marche sur mon PC mais pas le tien".</a:t>
+            </a:r>
+          </a:p>
+          <a:p>
             <a:endParaRPr lang="en-US" dirty="0"/>
           </a:p>
         </p:txBody>
@@ -5060,7 +5838,7 @@
           <a:p>
             <a:fld id="{F7021451-1387-4CA6-816F-3879F97B5CBC}" type="slidenum">
               <a:rPr lang="en-US"/>
-              <a:t>6</a:t>
+              <a:t>5</a:t>
             </a:fld>
             <a:endParaRPr lang="en-US"/>
           </a:p>
@@ -5123,7 +5901,156 @@
           <a:bodyPr/>
           <a:lstStyle/>
           <a:p>
-            <a:endParaRPr lang="en-US" dirty="0"/>
+            <a:r>
+              <a:rPr lang="fr-FR" b="1" dirty="0"/>
+              <a:t>1 — Récupération &amp; tri des données</a:t>
+            </a:r>
+            <a:r>
+              <a:rPr lang="fr-FR" dirty="0"/>
+              <a:t> On a téléchargé les données routières d'</a:t>
+            </a:r>
+            <a:r>
+              <a:rPr lang="fr-FR" dirty="0" err="1"/>
+              <a:t>OpenStreetMap</a:t>
+            </a:r>
+            <a:r>
+              <a:rPr lang="fr-FR" dirty="0"/>
+              <a:t> pour la Suisse romande (fichier .</a:t>
+            </a:r>
+            <a:r>
+              <a:rPr lang="fr-FR" dirty="0" err="1"/>
+              <a:t>osm</a:t>
+            </a:r>
+            <a:r>
+              <a:rPr lang="fr-FR" dirty="0"/>
+              <a:t> de plusieurs Go), puis on a utilisé l'outil osm2pgrouting pour les importer automatiquement dans PostgreSQL. Cet outil crée le graphe routier — 351 509 tronçons et 291 381 intersections — prêt à être utilisé par Dijkstra.</a:t>
+            </a:r>
+          </a:p>
+          <a:p>
+            <a:endParaRPr lang="fr-FR" dirty="0"/>
+          </a:p>
+          <a:p>
+            <a:r>
+              <a:rPr lang="fr-FR" b="1" dirty="0"/>
+              <a:t>2 — CSS &amp; interface visuelle</a:t>
+            </a:r>
+            <a:r>
+              <a:rPr lang="fr-FR" dirty="0"/>
+              <a:t> Avant d'écrire une seule ligne de logique, on a défini l'apparence du site : palette verte </a:t>
+            </a:r>
+            <a:r>
+              <a:rPr lang="fr-FR" dirty="0" err="1"/>
+              <a:t>ChronoPath</a:t>
+            </a:r>
+            <a:r>
+              <a:rPr lang="fr-FR" dirty="0"/>
+              <a:t>, sidebar, onglets, </a:t>
+            </a:r>
+            <a:r>
+              <a:rPr lang="fr-FR" dirty="0" err="1"/>
+              <a:t>sliders</a:t>
+            </a:r>
+            <a:r>
+              <a:rPr lang="fr-FR" dirty="0"/>
+              <a:t>. Leaflet.js est intégré ici — il affiche la carte et les tuiles </a:t>
+            </a:r>
+            <a:r>
+              <a:rPr lang="fr-FR" dirty="0" err="1"/>
+              <a:t>Swisstopo</a:t>
+            </a:r>
+            <a:r>
+              <a:rPr lang="fr-FR" dirty="0"/>
+              <a:t> WMTS par-dessus.</a:t>
+            </a:r>
+          </a:p>
+          <a:p>
+            <a:endParaRPr lang="fr-FR" dirty="0"/>
+          </a:p>
+          <a:p>
+            <a:r>
+              <a:rPr lang="fr-FR" b="1" dirty="0"/>
+              <a:t>3 — Boutons &amp; commandes JS</a:t>
+            </a:r>
+            <a:r>
+              <a:rPr lang="fr-FR" dirty="0"/>
+              <a:t> C'est le cerveau du frontend. Les 6 fichiers JavaScript gèrent chacun une fonctionnalité : map.js pour la carte, search.js pour la recherche, routing.js pour l'itinéraire A→B, create.js pour le tracé manuel, cantons.js pour les couches, app.js pour la logique principale. Chaque bouton de l'interface est relié à une fonction JS qui appelle l'API Go.</a:t>
+            </a:r>
+          </a:p>
+          <a:p>
+            <a:endParaRPr lang="fr-FR" b="1" dirty="0"/>
+          </a:p>
+          <a:p>
+            <a:r>
+              <a:rPr lang="fr-FR" b="1" dirty="0"/>
+              <a:t>4 — Stockage Docker Desktop</a:t>
+            </a:r>
+            <a:r>
+              <a:rPr lang="fr-FR" dirty="0"/>
+              <a:t> La base de données PostgreSQL ne s'installe pas directement sur la machine — elle tourne dans un conteneur Docker nommé </a:t>
+            </a:r>
+            <a:r>
+              <a:rPr lang="fr-FR" dirty="0" err="1"/>
+              <a:t>gin_pgrouting</a:t>
+            </a:r>
+            <a:r>
+              <a:rPr lang="fr-FR" dirty="0"/>
+              <a:t>. L'avantage : tout le monde dans le groupe a exactement le même environnement, pas de problèmes de version ou de configuration. La commande pour démarrer : </a:t>
+            </a:r>
+            <a:r>
+              <a:rPr lang="fr-FR" sz="1200" kern="1200" dirty="0">
+                <a:solidFill>
+                  <a:schemeClr val="tx1"/>
+                </a:solidFill>
+                <a:latin typeface="+mn-lt"/>
+                <a:ea typeface="+mn-ea"/>
+                <a:cs typeface="+mn-cs"/>
+              </a:rPr>
+              <a:t>docker start </a:t>
+            </a:r>
+            <a:r>
+              <a:rPr lang="fr-FR" sz="1200" kern="1200" dirty="0" err="1">
+                <a:solidFill>
+                  <a:schemeClr val="tx1"/>
+                </a:solidFill>
+                <a:latin typeface="+mn-lt"/>
+                <a:ea typeface="+mn-ea"/>
+                <a:cs typeface="+mn-cs"/>
+              </a:rPr>
+              <a:t>gin_pgrouting</a:t>
+            </a:r>
+            <a:r>
+              <a:rPr lang="fr-FR" dirty="0"/>
+              <a:t>.</a:t>
+            </a:r>
+          </a:p>
+          <a:p>
+            <a:endParaRPr lang="fr-FR" b="1" dirty="0"/>
+          </a:p>
+          <a:p>
+            <a:r>
+              <a:rPr lang="fr-FR" b="1" dirty="0"/>
+              <a:t>5 — Imports </a:t>
+            </a:r>
+            <a:r>
+              <a:rPr lang="fr-FR" b="1" dirty="0" err="1"/>
+              <a:t>pgRouting</a:t>
+            </a:r>
+            <a:r>
+              <a:rPr lang="fr-FR" b="1" dirty="0"/>
+              <a:t> &amp; tests</a:t>
+            </a:r>
+            <a:r>
+              <a:rPr lang="fr-FR" dirty="0"/>
+              <a:t> Dernière étape : on branche tout. </a:t>
+            </a:r>
+            <a:r>
+              <a:rPr lang="fr-FR" dirty="0" err="1"/>
+              <a:t>pgRouting</a:t>
+            </a:r>
+            <a:r>
+              <a:rPr lang="fr-FR" dirty="0"/>
+              <a:t> reçoit les données OSM importées à l'étape 1 et peut maintenant calculer des itinéraires via Dijkstra sur le vrai réseau routier. Cette étape a inclus le calibrage des boucles triangulaires et la validation sur de vrais parcours — c'est ici qu'on a passé le plus de temps.</a:t>
+            </a:r>
           </a:p>
         </p:txBody>
       </p:sp>
@@ -5144,7 +6071,7 @@
           <a:p>
             <a:fld id="{F7021451-1387-4CA6-816F-3879F97B5CBC}" type="slidenum">
               <a:rPr lang="en-US"/>
-              <a:t>8</a:t>
+              <a:t>6</a:t>
             </a:fld>
             <a:endParaRPr lang="en-US"/>
           </a:p>
@@ -5207,194 +6134,7 @@
           <a:bodyPr/>
           <a:lstStyle/>
           <a:p>
-            <a:r>
-              <a:rPr lang="en-US" sz="1200" i="1" dirty="0" err="1">
-                <a:solidFill>
-                  <a:srgbClr val="2D6A4F"/>
-                </a:solidFill>
-                <a:latin typeface="Arial" pitchFamily="34" charset="0"/>
-                <a:ea typeface="Arial" pitchFamily="34" charset="-122"/>
-                <a:cs typeface="Arial" pitchFamily="34" charset="-120"/>
-              </a:rPr>
-              <a:t>Algorithme</a:t>
-            </a:r>
-            <a:r>
-              <a:rPr lang="en-US" sz="1200" i="1" dirty="0">
-                <a:solidFill>
-                  <a:srgbClr val="2D6A4F"/>
-                </a:solidFill>
-                <a:latin typeface="Arial" pitchFamily="34" charset="0"/>
-                <a:ea typeface="Arial" pitchFamily="34" charset="-122"/>
-                <a:cs typeface="Arial" pitchFamily="34" charset="-120"/>
-              </a:rPr>
-              <a:t> </a:t>
-            </a:r>
-            <a:r>
-              <a:rPr lang="en-US" sz="1200" i="1" dirty="0" err="1">
-                <a:solidFill>
-                  <a:srgbClr val="2D6A4F"/>
-                </a:solidFill>
-                <a:latin typeface="Arial" pitchFamily="34" charset="0"/>
-                <a:ea typeface="Arial" pitchFamily="34" charset="-122"/>
-                <a:cs typeface="Arial" pitchFamily="34" charset="-120"/>
-              </a:rPr>
-              <a:t>calibré</a:t>
-            </a:r>
-            <a:r>
-              <a:rPr lang="en-US" sz="1200" i="1" dirty="0">
-                <a:solidFill>
-                  <a:srgbClr val="2D6A4F"/>
-                </a:solidFill>
-                <a:latin typeface="Arial" pitchFamily="34" charset="0"/>
-                <a:ea typeface="Arial" pitchFamily="34" charset="-122"/>
-                <a:cs typeface="Arial" pitchFamily="34" charset="-120"/>
-              </a:rPr>
-              <a:t> avec </a:t>
-            </a:r>
-            <a:r>
-              <a:rPr lang="en-US" sz="1200" i="1" dirty="0" err="1">
-                <a:solidFill>
-                  <a:srgbClr val="2D6A4F"/>
-                </a:solidFill>
-                <a:latin typeface="Arial" pitchFamily="34" charset="0"/>
-                <a:ea typeface="Arial" pitchFamily="34" charset="-122"/>
-                <a:cs typeface="Arial" pitchFamily="34" charset="-120"/>
-              </a:rPr>
-              <a:t>facteur</a:t>
-            </a:r>
-            <a:r>
-              <a:rPr lang="en-US" sz="1200" i="1" dirty="0">
-                <a:solidFill>
-                  <a:srgbClr val="2D6A4F"/>
-                </a:solidFill>
-                <a:latin typeface="Arial" pitchFamily="34" charset="0"/>
-                <a:ea typeface="Arial" pitchFamily="34" charset="-122"/>
-                <a:cs typeface="Arial" pitchFamily="34" charset="-120"/>
-              </a:rPr>
-              <a:t> </a:t>
-            </a:r>
-            <a:r>
-              <a:rPr lang="en-US" sz="1200" i="1" dirty="0" err="1">
-                <a:solidFill>
-                  <a:srgbClr val="2D6A4F"/>
-                </a:solidFill>
-                <a:latin typeface="Arial" pitchFamily="34" charset="0"/>
-                <a:ea typeface="Arial" pitchFamily="34" charset="-122"/>
-                <a:cs typeface="Arial" pitchFamily="34" charset="-120"/>
-              </a:rPr>
-              <a:t>sinuosité</a:t>
-            </a:r>
-            <a:r>
-              <a:rPr lang="en-US" sz="1200" i="1" dirty="0">
-                <a:solidFill>
-                  <a:srgbClr val="2D6A4F"/>
-                </a:solidFill>
-                <a:latin typeface="Arial" pitchFamily="34" charset="0"/>
-                <a:ea typeface="Arial" pitchFamily="34" charset="-122"/>
-                <a:cs typeface="Arial" pitchFamily="34" charset="-120"/>
-              </a:rPr>
-              <a:t> 2.6</a:t>
-            </a:r>
-            <a:endParaRPr lang="en-US" sz="1200" dirty="0"/>
-          </a:p>
-          <a:p>
-            <a:r>
-              <a:rPr lang="en-US" sz="1200" i="1" dirty="0" err="1">
-                <a:solidFill>
-                  <a:srgbClr val="2D6A4F"/>
-                </a:solidFill>
-                <a:latin typeface="Arial" pitchFamily="34" charset="0"/>
-                <a:ea typeface="Arial" pitchFamily="34" charset="-122"/>
-                <a:cs typeface="Arial" pitchFamily="34" charset="-120"/>
-              </a:rPr>
-              <a:t>vitesse</a:t>
-            </a:r>
-            <a:r>
-              <a:rPr lang="en-US" sz="1200" i="1" dirty="0">
-                <a:solidFill>
-                  <a:srgbClr val="2D6A4F"/>
-                </a:solidFill>
-                <a:latin typeface="Arial" pitchFamily="34" charset="0"/>
-                <a:ea typeface="Arial" pitchFamily="34" charset="-122"/>
-                <a:cs typeface="Arial" pitchFamily="34" charset="-120"/>
-              </a:rPr>
-              <a:t> = 8 + FTP × 6.5 km/h</a:t>
-            </a:r>
-          </a:p>
-          <a:p>
-            <a:endParaRPr lang="en-US" sz="1200" i="1" dirty="0">
-              <a:solidFill>
-                <a:srgbClr val="2D6A4F"/>
-              </a:solidFill>
-              <a:latin typeface="Arial" pitchFamily="34" charset="0"/>
-              <a:cs typeface="Arial" pitchFamily="34" charset="-120"/>
-            </a:endParaRPr>
-          </a:p>
-          <a:p>
-            <a:r>
-              <a:rPr lang="en-US" sz="1200" i="1" dirty="0">
-                <a:solidFill>
-                  <a:srgbClr val="2D6A4F"/>
-                </a:solidFill>
-                <a:latin typeface="Arial" pitchFamily="34" charset="0"/>
-                <a:cs typeface="Arial" pitchFamily="34" charset="-120"/>
-              </a:rPr>
-              <a:t>- </a:t>
-            </a:r>
-            <a:r>
-              <a:rPr lang="en-US" sz="1200" i="1" dirty="0" err="1">
-                <a:solidFill>
-                  <a:srgbClr val="DC2626"/>
-                </a:solidFill>
-                <a:latin typeface="Arial" pitchFamily="34" charset="0"/>
-                <a:ea typeface="Arial" pitchFamily="34" charset="-122"/>
-                <a:cs typeface="Arial" pitchFamily="34" charset="-120"/>
-              </a:rPr>
-              <a:t>Facteur</a:t>
-            </a:r>
-            <a:r>
-              <a:rPr lang="en-US" sz="1200" i="1" dirty="0">
-                <a:solidFill>
-                  <a:srgbClr val="DC2626"/>
-                </a:solidFill>
-                <a:latin typeface="Arial" pitchFamily="34" charset="0"/>
-                <a:ea typeface="Arial" pitchFamily="34" charset="-122"/>
-                <a:cs typeface="Arial" pitchFamily="34" charset="-120"/>
-              </a:rPr>
-              <a:t> distance : 90% VAP sur 10km</a:t>
-            </a:r>
-            <a:endParaRPr lang="en-US" sz="1200" dirty="0"/>
-          </a:p>
-          <a:p>
-            <a:r>
-              <a:rPr lang="en-US" sz="1200" i="1" dirty="0" err="1">
-                <a:solidFill>
-                  <a:srgbClr val="DC2626"/>
-                </a:solidFill>
-                <a:latin typeface="Arial" pitchFamily="34" charset="0"/>
-                <a:ea typeface="Arial" pitchFamily="34" charset="-122"/>
-                <a:cs typeface="Arial" pitchFamily="34" charset="-120"/>
-              </a:rPr>
-              <a:t>Pénalité</a:t>
-            </a:r>
-            <a:r>
-              <a:rPr lang="en-US" sz="1200" i="1" dirty="0">
-                <a:solidFill>
-                  <a:srgbClr val="DC2626"/>
-                </a:solidFill>
-                <a:latin typeface="Arial" pitchFamily="34" charset="0"/>
-                <a:ea typeface="Arial" pitchFamily="34" charset="-122"/>
-                <a:cs typeface="Arial" pitchFamily="34" charset="-120"/>
-              </a:rPr>
-              <a:t> D+ : +0.5 min/100m</a:t>
-            </a:r>
-            <a:endParaRPr lang="en-US" sz="1200" dirty="0"/>
-          </a:p>
-          <a:p>
-            <a:endParaRPr lang="en-US" sz="1200" dirty="0"/>
-          </a:p>
-          <a:p>
-            <a:endParaRPr lang="en-US" dirty="0"/>
+            <a:endParaRPr lang="en-US"/>
           </a:p>
         </p:txBody>
       </p:sp>
@@ -5415,7 +6155,7 @@
           <a:p>
             <a:fld id="{F7021451-1387-4CA6-816F-3879F97B5CBC}" type="slidenum">
               <a:rPr lang="en-US"/>
-              <a:t>9</a:t>
+              <a:t>8</a:t>
             </a:fld>
             <a:endParaRPr lang="en-US"/>
           </a:p>
@@ -5478,7 +6218,278 @@
           <a:bodyPr/>
           <a:lstStyle/>
           <a:p>
+            <a:r>
+              <a:rPr lang="en-US" sz="1200" i="1" dirty="0" err="1">
+                <a:solidFill>
+                  <a:srgbClr val="2D6A4F"/>
+                </a:solidFill>
+                <a:latin typeface="Arial" pitchFamily="34" charset="0"/>
+                <a:ea typeface="Arial" pitchFamily="34" charset="-122"/>
+                <a:cs typeface="Arial" pitchFamily="34" charset="-120"/>
+              </a:rPr>
+              <a:t>Algorithme</a:t>
+            </a:r>
+            <a:r>
+              <a:rPr lang="en-US" sz="1200" i="1" dirty="0">
+                <a:solidFill>
+                  <a:srgbClr val="2D6A4F"/>
+                </a:solidFill>
+                <a:latin typeface="Arial" pitchFamily="34" charset="0"/>
+                <a:ea typeface="Arial" pitchFamily="34" charset="-122"/>
+                <a:cs typeface="Arial" pitchFamily="34" charset="-120"/>
+              </a:rPr>
+              <a:t> </a:t>
+            </a:r>
+            <a:r>
+              <a:rPr lang="en-US" sz="1200" i="1" dirty="0" err="1">
+                <a:solidFill>
+                  <a:srgbClr val="2D6A4F"/>
+                </a:solidFill>
+                <a:latin typeface="Arial" pitchFamily="34" charset="0"/>
+                <a:ea typeface="Arial" pitchFamily="34" charset="-122"/>
+                <a:cs typeface="Arial" pitchFamily="34" charset="-120"/>
+              </a:rPr>
+              <a:t>calibré</a:t>
+            </a:r>
+            <a:r>
+              <a:rPr lang="en-US" sz="1200" i="1" dirty="0">
+                <a:solidFill>
+                  <a:srgbClr val="2D6A4F"/>
+                </a:solidFill>
+                <a:latin typeface="Arial" pitchFamily="34" charset="0"/>
+                <a:ea typeface="Arial" pitchFamily="34" charset="-122"/>
+                <a:cs typeface="Arial" pitchFamily="34" charset="-120"/>
+              </a:rPr>
+              <a:t> avec </a:t>
+            </a:r>
+            <a:r>
+              <a:rPr lang="en-US" sz="1200" i="1" dirty="0" err="1">
+                <a:solidFill>
+                  <a:srgbClr val="2D6A4F"/>
+                </a:solidFill>
+                <a:latin typeface="Arial" pitchFamily="34" charset="0"/>
+                <a:ea typeface="Arial" pitchFamily="34" charset="-122"/>
+                <a:cs typeface="Arial" pitchFamily="34" charset="-120"/>
+              </a:rPr>
+              <a:t>facteur</a:t>
+            </a:r>
+            <a:r>
+              <a:rPr lang="en-US" sz="1200" i="1" dirty="0">
+                <a:solidFill>
+                  <a:srgbClr val="2D6A4F"/>
+                </a:solidFill>
+                <a:latin typeface="Arial" pitchFamily="34" charset="0"/>
+                <a:ea typeface="Arial" pitchFamily="34" charset="-122"/>
+                <a:cs typeface="Arial" pitchFamily="34" charset="-120"/>
+              </a:rPr>
+              <a:t> </a:t>
+            </a:r>
+            <a:r>
+              <a:rPr lang="en-US" sz="1200" i="1" dirty="0" err="1">
+                <a:solidFill>
+                  <a:srgbClr val="2D6A4F"/>
+                </a:solidFill>
+                <a:latin typeface="Arial" pitchFamily="34" charset="0"/>
+                <a:ea typeface="Arial" pitchFamily="34" charset="-122"/>
+                <a:cs typeface="Arial" pitchFamily="34" charset="-120"/>
+              </a:rPr>
+              <a:t>sinuosité</a:t>
+            </a:r>
+            <a:r>
+              <a:rPr lang="en-US" sz="1200" i="1" dirty="0">
+                <a:solidFill>
+                  <a:srgbClr val="2D6A4F"/>
+                </a:solidFill>
+                <a:latin typeface="Arial" pitchFamily="34" charset="0"/>
+                <a:ea typeface="Arial" pitchFamily="34" charset="-122"/>
+                <a:cs typeface="Arial" pitchFamily="34" charset="-120"/>
+              </a:rPr>
+              <a:t> 2.6</a:t>
+            </a:r>
+            <a:endParaRPr lang="en-US" sz="1200" dirty="0"/>
+          </a:p>
+          <a:p>
+            <a:r>
+              <a:rPr lang="en-US" sz="1200" i="1" dirty="0" err="1">
+                <a:solidFill>
+                  <a:srgbClr val="2D6A4F"/>
+                </a:solidFill>
+                <a:latin typeface="Arial" pitchFamily="34" charset="0"/>
+                <a:ea typeface="Arial" pitchFamily="34" charset="-122"/>
+                <a:cs typeface="Arial" pitchFamily="34" charset="-120"/>
+              </a:rPr>
+              <a:t>vitesse</a:t>
+            </a:r>
+            <a:r>
+              <a:rPr lang="en-US" sz="1200" i="1" dirty="0">
+                <a:solidFill>
+                  <a:srgbClr val="2D6A4F"/>
+                </a:solidFill>
+                <a:latin typeface="Arial" pitchFamily="34" charset="0"/>
+                <a:ea typeface="Arial" pitchFamily="34" charset="-122"/>
+                <a:cs typeface="Arial" pitchFamily="34" charset="-120"/>
+              </a:rPr>
+              <a:t> = 8 + FTP × 6.5 km/h</a:t>
+            </a:r>
+          </a:p>
+          <a:p>
+            <a:endParaRPr lang="en-US" sz="1200" i="1" dirty="0">
+              <a:solidFill>
+                <a:srgbClr val="2D6A4F"/>
+              </a:solidFill>
+              <a:latin typeface="Arial" pitchFamily="34" charset="0"/>
+              <a:cs typeface="Arial" pitchFamily="34" charset="-120"/>
+            </a:endParaRPr>
+          </a:p>
+          <a:p>
+            <a:r>
+              <a:rPr lang="en-US" sz="1200" i="1" dirty="0">
+                <a:solidFill>
+                  <a:srgbClr val="2D6A4F"/>
+                </a:solidFill>
+                <a:latin typeface="Arial" pitchFamily="34" charset="0"/>
+                <a:cs typeface="Arial" pitchFamily="34" charset="-120"/>
+              </a:rPr>
+              <a:t>- </a:t>
+            </a:r>
+            <a:r>
+              <a:rPr lang="en-US" sz="1200" i="1" dirty="0" err="1">
+                <a:solidFill>
+                  <a:srgbClr val="DC2626"/>
+                </a:solidFill>
+                <a:latin typeface="Arial" pitchFamily="34" charset="0"/>
+                <a:ea typeface="Arial" pitchFamily="34" charset="-122"/>
+                <a:cs typeface="Arial" pitchFamily="34" charset="-120"/>
+              </a:rPr>
+              <a:t>Facteur</a:t>
+            </a:r>
+            <a:r>
+              <a:rPr lang="en-US" sz="1200" i="1" dirty="0">
+                <a:solidFill>
+                  <a:srgbClr val="DC2626"/>
+                </a:solidFill>
+                <a:latin typeface="Arial" pitchFamily="34" charset="0"/>
+                <a:ea typeface="Arial" pitchFamily="34" charset="-122"/>
+                <a:cs typeface="Arial" pitchFamily="34" charset="-120"/>
+              </a:rPr>
+              <a:t> distance : 90% VAP sur 10km</a:t>
+            </a:r>
+            <a:endParaRPr lang="en-US" sz="1200" dirty="0"/>
+          </a:p>
+          <a:p>
+            <a:r>
+              <a:rPr lang="en-US" sz="1200" i="1" dirty="0" err="1">
+                <a:solidFill>
+                  <a:srgbClr val="DC2626"/>
+                </a:solidFill>
+                <a:latin typeface="Arial" pitchFamily="34" charset="0"/>
+                <a:ea typeface="Arial" pitchFamily="34" charset="-122"/>
+                <a:cs typeface="Arial" pitchFamily="34" charset="-120"/>
+              </a:rPr>
+              <a:t>Pénalité</a:t>
+            </a:r>
+            <a:r>
+              <a:rPr lang="en-US" sz="1200" i="1" dirty="0">
+                <a:solidFill>
+                  <a:srgbClr val="DC2626"/>
+                </a:solidFill>
+                <a:latin typeface="Arial" pitchFamily="34" charset="0"/>
+                <a:ea typeface="Arial" pitchFamily="34" charset="-122"/>
+                <a:cs typeface="Arial" pitchFamily="34" charset="-120"/>
+              </a:rPr>
+              <a:t> D+ : +0.5 min/100m</a:t>
+            </a:r>
+            <a:endParaRPr lang="en-US" sz="1200" dirty="0"/>
+          </a:p>
+          <a:p>
+            <a:endParaRPr lang="en-US" sz="1200" dirty="0"/>
+          </a:p>
+          <a:p>
             <a:endParaRPr lang="en-US" dirty="0"/>
+          </a:p>
+        </p:txBody>
+      </p:sp>
+      <p:sp>
+        <p:nvSpPr>
+          <p:cNvPr id="4" name="Slide Number Placeholder 3"/>
+          <p:cNvSpPr>
+            <a:spLocks noGrp="1"/>
+          </p:cNvSpPr>
+          <p:nvPr>
+            <p:ph type="sldNum" sz="quarter" idx="10"/>
+          </p:nvPr>
+        </p:nvSpPr>
+        <p:spPr/>
+        <p:txBody>
+          <a:bodyPr/>
+          <a:lstStyle/>
+          <a:p>
+            <a:fld id="{F7021451-1387-4CA6-816F-3879F97B5CBC}" type="slidenum">
+              <a:rPr lang="en-US"/>
+              <a:t>9</a:t>
+            </a:fld>
+            <a:endParaRPr lang="en-US"/>
+          </a:p>
+        </p:txBody>
+      </p:sp>
+    </p:spTree>
+    <p:extLst>
+      <p:ext uri="{BB962C8B-B14F-4D97-AF65-F5344CB8AC3E}">
+        <p14:creationId xmlns:p14="http://schemas.microsoft.com/office/powerpoint/2010/main" val="1024086991"/>
+      </p:ext>
+    </p:extLst>
+  </p:cSld>
+  <p:clrMapOvr>
+    <a:masterClrMapping/>
+  </p:clrMapOvr>
+</p:notes>
+</file>
+
+<file path=ppt/notesSlides/notesSlide7.xml><?xml version="1.0" encoding="utf-8"?>
+<p:notes xmlns:a="http://schemas.openxmlformats.org/drawingml/2006/main" xmlns:r="http://schemas.openxmlformats.org/officeDocument/2006/relationships" xmlns:p="http://schemas.openxmlformats.org/presentationml/2006/main">
+  <p:cSld>
+    <p:spTree>
+      <p:nvGrpSpPr>
+        <p:cNvPr id="1" name=""/>
+        <p:cNvGrpSpPr/>
+        <p:nvPr/>
+      </p:nvGrpSpPr>
+      <p:grpSpPr>
+        <a:xfrm>
+          <a:off x="0" y="0"/>
+          <a:ext cx="0" cy="0"/>
+          <a:chOff x="0" y="0"/>
+          <a:chExt cx="0" cy="0"/>
+        </a:xfrm>
+      </p:grpSpPr>
+      <p:sp>
+        <p:nvSpPr>
+          <p:cNvPr id="2" name="Slide Image Placeholder 1"/>
+          <p:cNvSpPr>
+            <a:spLocks noGrp="1" noRot="1" noChangeAspect="1"/>
+          </p:cNvSpPr>
+          <p:nvPr>
+            <p:ph type="sldImg"/>
+          </p:nvPr>
+        </p:nvSpPr>
+        <p:spPr/>
+      </p:sp>
+      <p:sp>
+        <p:nvSpPr>
+          <p:cNvPr id="3" name="Notes Placeholder 2"/>
+          <p:cNvSpPr>
+            <a:spLocks noGrp="1"/>
+          </p:cNvSpPr>
+          <p:nvPr>
+            <p:ph type="body" idx="1"/>
+          </p:nvPr>
+        </p:nvSpPr>
+        <p:spPr/>
+        <p:txBody>
+          <a:bodyPr/>
+          <a:lstStyle/>
+          <a:p>
+            <a:endParaRPr lang="en-US"/>
           </a:p>
         </p:txBody>
       </p:sp>
@@ -8818,10 +9829,9 @@
           <a:lstStyle/>
           <a:p>
             <a:r>
-              <a:rPr lang="fr-FR" sz="7200"/>
+              <a:rPr lang="fr-FR" sz="7200" noProof="0" dirty="0"/>
               <a:t>Projet GIN</a:t>
             </a:r>
-            <a:endParaRPr lang="fr-CH" sz="7200"/>
           </a:p>
         </p:txBody>
       </p:sp>
@@ -8854,30 +9864,30 @@
           <a:lstStyle/>
           <a:p>
             <a:r>
-              <a:rPr lang="fr-FR" sz="2800"/>
+              <a:rPr lang="fr-FR" sz="2800" noProof="0" dirty="0"/>
               <a:t>Création de parcours sportifs</a:t>
             </a:r>
           </a:p>
           <a:p>
             <a:r>
-              <a:rPr lang="fr-FR" sz="1600"/>
+              <a:rPr lang="fr-FR" sz="1600" noProof="0" dirty="0"/>
               <a:t>Course à pied </a:t>
             </a:r>
           </a:p>
           <a:p>
             <a:r>
-              <a:rPr lang="fr-FR" sz="1600"/>
+              <a:rPr lang="fr-FR" sz="1600" noProof="0" dirty="0"/>
               <a:t>Vélo</a:t>
             </a:r>
           </a:p>
           <a:p>
             <a:r>
-              <a:rPr lang="fr-FR" sz="1600"/>
+              <a:rPr lang="fr-FR" sz="1600" noProof="0" dirty="0"/>
               <a:t>Randonné</a:t>
             </a:r>
           </a:p>
           <a:p>
-            <a:endParaRPr lang="fr-FR" sz="2800"/>
+            <a:endParaRPr lang="fr-FR" sz="2800" noProof="0" dirty="0"/>
           </a:p>
         </p:txBody>
       </p:sp>
@@ -8911,24 +9921,89 @@
           <a:p>
             <a:pPr algn="ctr"/>
             <a:r>
-              <a:rPr lang="fr-FR"/>
+              <a:rPr lang="fr-FR" noProof="0" dirty="0"/>
               <a:t>Fabio – Mathis – William</a:t>
             </a:r>
-            <a:endParaRPr lang="fr-CH"/>
           </a:p>
           <a:p>
             <a:pPr algn="ctr"/>
             <a:r>
-              <a:rPr lang="fr-CH"/>
+              <a:rPr lang="fr-FR" noProof="0" dirty="0"/>
               <a:t>03.06.26</a:t>
             </a:r>
-            <a:endParaRPr lang="fr-FR"/>
-          </a:p>
-          <a:p>
-            <a:endParaRPr lang="fr-CH"/>
-          </a:p>
-        </p:txBody>
-      </p:sp>
+          </a:p>
+          <a:p>
+            <a:endParaRPr lang="fr-FR" noProof="0" dirty="0"/>
+          </a:p>
+        </p:txBody>
+      </p:sp>
+      <p:pic>
+        <p:nvPicPr>
+          <p:cNvPr id="6" name="Image 5">
+            <a:extLst>
+              <a:ext uri="{FF2B5EF4-FFF2-40B4-BE49-F238E27FC236}">
+                <a16:creationId xmlns:a16="http://schemas.microsoft.com/office/drawing/2014/main" id="{8AB6A35A-E4D6-1141-A3C1-09D73C949665}"/>
+              </a:ext>
+            </a:extLst>
+          </p:cNvPr>
+          <p:cNvPicPr>
+            <a:picLocks noChangeAspect="1"/>
+          </p:cNvPicPr>
+          <p:nvPr/>
+        </p:nvPicPr>
+        <p:blipFill>
+          <a:blip r:embed="rId2">
+            <a:extLst>
+              <a:ext uri="{28A0092B-C50C-407E-A947-70E740481C1C}">
+                <a14:useLocalDpi xmlns:a14="http://schemas.microsoft.com/office/drawing/2010/main" val="0"/>
+              </a:ext>
+            </a:extLst>
+          </a:blip>
+          <a:srcRect l="26711" t="19413" r="25684" b="30453"/>
+          <a:stretch>
+            <a:fillRect/>
+          </a:stretch>
+        </p:blipFill>
+        <p:spPr>
+          <a:xfrm>
+            <a:off x="184455" y="102413"/>
+            <a:ext cx="1439520" cy="1515980"/>
+          </a:xfrm>
+          <a:prstGeom prst="rect">
+            <a:avLst/>
+          </a:prstGeom>
+        </p:spPr>
+      </p:pic>
+      <p:pic>
+        <p:nvPicPr>
+          <p:cNvPr id="8" name="Image 7">
+            <a:extLst>
+              <a:ext uri="{FF2B5EF4-FFF2-40B4-BE49-F238E27FC236}">
+                <a16:creationId xmlns:a16="http://schemas.microsoft.com/office/drawing/2014/main" id="{8755FA51-59A5-87F4-9979-EF8446CE6C64}"/>
+              </a:ext>
+            </a:extLst>
+          </p:cNvPr>
+          <p:cNvPicPr>
+            <a:picLocks noChangeAspect="1"/>
+          </p:cNvPicPr>
+          <p:nvPr/>
+        </p:nvPicPr>
+        <p:blipFill>
+          <a:blip r:embed="rId3"/>
+          <a:stretch>
+            <a:fillRect/>
+          </a:stretch>
+        </p:blipFill>
+        <p:spPr>
+          <a:xfrm>
+            <a:off x="1697127" y="600280"/>
+            <a:ext cx="2728735" cy="520245"/>
+          </a:xfrm>
+          <a:prstGeom prst="rect">
+            <a:avLst/>
+          </a:prstGeom>
+        </p:spPr>
+      </p:pic>
     </p:spTree>
     <p:extLst>
       <p:ext uri="{BB962C8B-B14F-4D97-AF65-F5344CB8AC3E}">
@@ -8981,7 +10056,7 @@
           <a:lstStyle/>
           <a:p>
             <a:r>
-              <a:rPr lang="en-US" sz="3600" b="1" dirty="0">
+              <a:rPr lang="fr-FR" sz="3600" b="1" noProof="0" dirty="0">
                 <a:solidFill>
                   <a:srgbClr val="FFFFFF"/>
                 </a:solidFill>
@@ -8991,7 +10066,7 @@
               </a:rPr>
               <a:t>07 — Conclusion</a:t>
             </a:r>
-            <a:endParaRPr lang="en-US" sz="3600" dirty="0"/>
+            <a:endParaRPr lang="fr-FR" sz="3600" noProof="0" dirty="0"/>
           </a:p>
         </p:txBody>
       </p:sp>
@@ -9030,7 +10105,7 @@
           <a:bodyPr/>
           <a:lstStyle/>
           <a:p>
-            <a:endParaRPr lang="fr-CH" sz="2400"/>
+            <a:endParaRPr lang="fr-FR" sz="2400" noProof="0" dirty="0"/>
           </a:p>
         </p:txBody>
       </p:sp>
@@ -9057,7 +10132,7 @@
           <a:bodyPr/>
           <a:lstStyle/>
           <a:p>
-            <a:endParaRPr lang="fr-CH" sz="2400"/>
+            <a:endParaRPr lang="fr-FR" sz="2400" noProof="0" dirty="0"/>
           </a:p>
         </p:txBody>
       </p:sp>
@@ -9083,7 +10158,7 @@
           <a:lstStyle/>
           <a:p>
             <a:r>
-              <a:rPr lang="en-US" sz="1733" b="1" dirty="0">
+              <a:rPr lang="fr-FR" sz="1733" b="1" noProof="0" dirty="0">
                 <a:solidFill>
                   <a:srgbClr val="2D6A4F"/>
                 </a:solidFill>
@@ -9091,9 +10166,9 @@
                 <a:ea typeface="Arial" pitchFamily="34" charset="-122"/>
                 <a:cs typeface="Arial" pitchFamily="34" charset="-120"/>
               </a:rPr>
-              <a:t>✅  Projet intéressant</a:t>
-            </a:r>
-            <a:endParaRPr lang="en-US" sz="1733" dirty="0"/>
+              <a:t>Projet intéressant</a:t>
+            </a:r>
+            <a:endParaRPr lang="fr-FR" sz="1733" noProof="0" dirty="0"/>
           </a:p>
         </p:txBody>
       </p:sp>
@@ -9119,7 +10194,7 @@
           <a:lstStyle/>
           <a:p>
             <a:r>
-              <a:rPr lang="en-US" sz="1467" dirty="0">
+              <a:rPr lang="fr-FR" sz="1467" noProof="0" dirty="0">
                 <a:solidFill>
                   <a:srgbClr val="1A1A2E"/>
                 </a:solidFill>
@@ -9127,9 +10202,20 @@
                 <a:ea typeface="Arial" pitchFamily="34" charset="-122"/>
                 <a:cs typeface="Arial" pitchFamily="34" charset="-120"/>
               </a:rPr>
-              <a:t>Première vraie application full-stack avec données géospatiales réelles OSM + Swisstopo</a:t>
-            </a:r>
-            <a:endParaRPr lang="en-US" sz="1467" dirty="0"/>
+              <a:t>Première vraie application full-stack avec données géospatiales réelles OSM + </a:t>
+            </a:r>
+            <a:r>
+              <a:rPr lang="fr-FR" sz="1467" noProof="0" dirty="0" err="1">
+                <a:solidFill>
+                  <a:srgbClr val="1A1A2E"/>
+                </a:solidFill>
+                <a:latin typeface="Arial" pitchFamily="34" charset="0"/>
+                <a:ea typeface="Arial" pitchFamily="34" charset="-122"/>
+                <a:cs typeface="Arial" pitchFamily="34" charset="-120"/>
+              </a:rPr>
+              <a:t>Swisstopo</a:t>
+            </a:r>
+            <a:endParaRPr lang="fr-FR" sz="1467" noProof="0" dirty="0"/>
           </a:p>
         </p:txBody>
       </p:sp>
@@ -9168,7 +10254,7 @@
           <a:bodyPr/>
           <a:lstStyle/>
           <a:p>
-            <a:endParaRPr lang="fr-CH" sz="2400"/>
+            <a:endParaRPr lang="fr-FR" sz="2400" noProof="0" dirty="0"/>
           </a:p>
         </p:txBody>
       </p:sp>
@@ -9195,7 +10281,7 @@
           <a:bodyPr/>
           <a:lstStyle/>
           <a:p>
-            <a:endParaRPr lang="fr-CH" sz="2400"/>
+            <a:endParaRPr lang="fr-FR" sz="2400" noProof="0" dirty="0"/>
           </a:p>
         </p:txBody>
       </p:sp>
@@ -9221,7 +10307,7 @@
           <a:lstStyle/>
           <a:p>
             <a:r>
-              <a:rPr lang="en-US" sz="1733" b="1" dirty="0">
+              <a:rPr lang="fr-FR" sz="1733" b="1" noProof="0" dirty="0">
                 <a:solidFill>
                   <a:srgbClr val="457B9D"/>
                 </a:solidFill>
@@ -9229,9 +10315,9 @@
                 <a:ea typeface="Arial" pitchFamily="34" charset="-122"/>
                 <a:cs typeface="Arial" pitchFamily="34" charset="-120"/>
               </a:rPr>
-              <a:t>⏱️  Manque de temps</a:t>
-            </a:r>
-            <a:endParaRPr lang="en-US" sz="1733" dirty="0"/>
+              <a:t>Manque de temps</a:t>
+            </a:r>
+            <a:endParaRPr lang="fr-FR" sz="1733" noProof="0" dirty="0"/>
           </a:p>
         </p:txBody>
       </p:sp>
@@ -9257,7 +10343,7 @@
           <a:lstStyle/>
           <a:p>
             <a:r>
-              <a:rPr lang="en-US" sz="1467" dirty="0">
+              <a:rPr lang="fr-FR" sz="1467" noProof="0" dirty="0">
                 <a:solidFill>
                   <a:srgbClr val="1A1A2E"/>
                 </a:solidFill>
@@ -9267,7 +10353,7 @@
               </a:rPr>
               <a:t>Nombreuses fonctionnalités implémentées mais certaines auraient pu être plus poussées</a:t>
             </a:r>
-            <a:endParaRPr lang="en-US" sz="1467" dirty="0"/>
+            <a:endParaRPr lang="fr-FR" sz="1467" noProof="0" dirty="0"/>
           </a:p>
         </p:txBody>
       </p:sp>
@@ -9319,7 +10405,7 @@
           </a:lstStyle>
           <a:p>
             <a:r>
-              <a:rPr lang="en-US" dirty="0"/>
+              <a:rPr lang="fr-FR" noProof="0" dirty="0"/>
               <a:t>Conclusion</a:t>
             </a:r>
           </a:p>
@@ -9372,10 +10458,9 @@
           <a:lstStyle/>
           <a:p>
             <a:r>
-              <a:rPr lang="fr-FR"/>
+              <a:rPr lang="fr-FR" noProof="0" dirty="0"/>
               <a:t>Sommaire</a:t>
             </a:r>
-            <a:endParaRPr lang="fr-CH"/>
           </a:p>
         </p:txBody>
       </p:sp>
@@ -9395,7 +10480,7 @@
             <p:ph idx="1"/>
             <p:extLst>
               <p:ext uri="{D42A27DB-BD31-4B8C-83A1-F6EECF244321}">
-                <p14:modId xmlns:p14="http://schemas.microsoft.com/office/powerpoint/2010/main" val="867833329"/>
+                <p14:modId xmlns:p14="http://schemas.microsoft.com/office/powerpoint/2010/main" val="2769049029"/>
               </p:ext>
             </p:extLst>
           </p:nvPr>
@@ -9499,7 +10584,7 @@
           <a:bodyPr/>
           <a:lstStyle/>
           <a:p>
-            <a:endParaRPr lang="fr-CH" sz="2400"/>
+            <a:endParaRPr lang="fr-FR" sz="2400" noProof="0" dirty="0"/>
           </a:p>
         </p:txBody>
       </p:sp>
@@ -9525,7 +10610,7 @@
           <a:lstStyle/>
           <a:p>
             <a:r>
-              <a:rPr lang="en-US" sz="3600" b="1" dirty="0">
+              <a:rPr lang="fr-FR" sz="3600" b="1" noProof="0" dirty="0">
                 <a:solidFill>
                   <a:srgbClr val="FFFFFF"/>
                 </a:solidFill>
@@ -9533,20 +10618,9 @@
                 <a:ea typeface="Arial" pitchFamily="34" charset="-122"/>
                 <a:cs typeface="Arial" pitchFamily="34" charset="-120"/>
               </a:rPr>
-              <a:t>Avant-</a:t>
-            </a:r>
-            <a:r>
-              <a:rPr lang="en-US" sz="3600" b="1" dirty="0" err="1">
-                <a:solidFill>
-                  <a:srgbClr val="FFFFFF"/>
-                </a:solidFill>
-                <a:latin typeface="Arial" pitchFamily="34" charset="0"/>
-                <a:ea typeface="Arial" pitchFamily="34" charset="-122"/>
-                <a:cs typeface="Arial" pitchFamily="34" charset="-120"/>
-              </a:rPr>
-              <a:t>projet</a:t>
-            </a:r>
-            <a:endParaRPr lang="en-US" sz="3600" dirty="0"/>
+              <a:t>Avant-projet</a:t>
+            </a:r>
+            <a:endParaRPr lang="fr-FR" sz="3600" noProof="0" dirty="0"/>
           </a:p>
         </p:txBody>
       </p:sp>
@@ -9585,7 +10659,7 @@
           <a:bodyPr/>
           <a:lstStyle/>
           <a:p>
-            <a:endParaRPr lang="fr-CH" sz="2400"/>
+            <a:endParaRPr lang="fr-FR" sz="2400" noProof="0" dirty="0"/>
           </a:p>
         </p:txBody>
       </p:sp>
@@ -9634,7 +10708,7 @@
           <a:lstStyle/>
           <a:p>
             <a:r>
-              <a:rPr lang="en-US" sz="2000" b="1" dirty="0">
+              <a:rPr lang="fr-FR" sz="2000" b="1" noProof="0" dirty="0">
                 <a:solidFill>
                   <a:srgbClr val="2D6A4F"/>
                 </a:solidFill>
@@ -9644,7 +10718,7 @@
               </a:rPr>
               <a:t>Un site pour trois sports</a:t>
             </a:r>
-            <a:endParaRPr lang="en-US" sz="2000" dirty="0"/>
+            <a:endParaRPr lang="fr-FR" sz="2000" noProof="0" dirty="0"/>
           </a:p>
         </p:txBody>
       </p:sp>
@@ -9671,7 +10745,7 @@
           <a:bodyPr/>
           <a:lstStyle/>
           <a:p>
-            <a:endParaRPr lang="fr-CH" sz="2400"/>
+            <a:endParaRPr lang="fr-FR" sz="2400" noProof="0" dirty="0"/>
           </a:p>
         </p:txBody>
       </p:sp>
@@ -9697,7 +10771,7 @@
           <a:lstStyle/>
           <a:p>
             <a:r>
-              <a:rPr lang="en-US" sz="1533" dirty="0">
+              <a:rPr lang="fr-FR" sz="1533" noProof="0" dirty="0">
                 <a:solidFill>
                   <a:srgbClr val="1A1A2E"/>
                 </a:solidFill>
@@ -9707,7 +10781,7 @@
               </a:rPr>
               <a:t>Trois mondes différents</a:t>
             </a:r>
-            <a:endParaRPr lang="en-US" sz="1533" dirty="0"/>
+            <a:endParaRPr lang="fr-FR" sz="1533" noProof="0" dirty="0"/>
           </a:p>
         </p:txBody>
       </p:sp>
@@ -9734,7 +10808,7 @@
           <a:bodyPr/>
           <a:lstStyle/>
           <a:p>
-            <a:endParaRPr lang="fr-CH" sz="2400"/>
+            <a:endParaRPr lang="fr-FR" sz="2400" noProof="0" dirty="0"/>
           </a:p>
         </p:txBody>
       </p:sp>
@@ -9760,7 +10834,7 @@
           <a:lstStyle/>
           <a:p>
             <a:r>
-              <a:rPr lang="en-US" sz="1533" dirty="0">
+              <a:rPr lang="fr-FR" sz="1533" noProof="0" dirty="0">
                 <a:solidFill>
                   <a:srgbClr val="1A1A2E"/>
                 </a:solidFill>
@@ -9770,7 +10844,7 @@
               </a:rPr>
               <a:t>Trois contraintes différentes</a:t>
             </a:r>
-            <a:endParaRPr lang="en-US" sz="1533" dirty="0"/>
+            <a:endParaRPr lang="fr-FR" sz="1533" noProof="0" dirty="0"/>
           </a:p>
         </p:txBody>
       </p:sp>
@@ -9797,7 +10871,7 @@
           <a:bodyPr/>
           <a:lstStyle/>
           <a:p>
-            <a:endParaRPr lang="fr-CH" sz="2400"/>
+            <a:endParaRPr lang="fr-FR" sz="2400" noProof="0" dirty="0"/>
           </a:p>
         </p:txBody>
       </p:sp>
@@ -9823,7 +10897,7 @@
           <a:lstStyle/>
           <a:p>
             <a:r>
-              <a:rPr lang="en-US" sz="1533" dirty="0">
+              <a:rPr lang="fr-FR" sz="1533" noProof="0" dirty="0">
                 <a:solidFill>
                   <a:srgbClr val="1A1A2E"/>
                 </a:solidFill>
@@ -9833,7 +10907,7 @@
               </a:rPr>
               <a:t>Trois couleurs bien distinctes</a:t>
             </a:r>
-            <a:endParaRPr lang="en-US" sz="1533" dirty="0"/>
+            <a:endParaRPr lang="fr-FR" sz="1533" noProof="0" dirty="0"/>
           </a:p>
         </p:txBody>
       </p:sp>
@@ -9863,7 +10937,7 @@
           <a:bodyPr/>
           <a:lstStyle/>
           <a:p>
-            <a:endParaRPr lang="fr-CH" sz="2400"/>
+            <a:endParaRPr lang="fr-FR" sz="2400" noProof="0" dirty="0"/>
           </a:p>
         </p:txBody>
       </p:sp>
@@ -9889,7 +10963,7 @@
           <a:lstStyle/>
           <a:p>
             <a:r>
-              <a:rPr lang="en-US" sz="2000" b="1" dirty="0">
+              <a:rPr lang="fr-FR" sz="2000" b="1" noProof="0" dirty="0">
                 <a:solidFill>
                   <a:srgbClr val="2D6A4F"/>
                 </a:solidFill>
@@ -9899,7 +10973,7 @@
               </a:rPr>
               <a:t>Un objectif commun</a:t>
             </a:r>
-            <a:endParaRPr lang="en-US" sz="2000" dirty="0"/>
+            <a:endParaRPr lang="fr-FR" sz="2000" noProof="0" dirty="0"/>
           </a:p>
         </p:txBody>
       </p:sp>
@@ -9926,7 +11000,7 @@
           <a:bodyPr/>
           <a:lstStyle/>
           <a:p>
-            <a:endParaRPr lang="fr-CH" sz="2400"/>
+            <a:endParaRPr lang="fr-FR" sz="2400" noProof="0" dirty="0"/>
           </a:p>
         </p:txBody>
       </p:sp>
@@ -9952,7 +11026,7 @@
           <a:lstStyle/>
           <a:p>
             <a:r>
-              <a:rPr lang="en-US" sz="1467" dirty="0">
+              <a:rPr lang="fr-FR" sz="1467" noProof="0" dirty="0">
                 <a:solidFill>
                   <a:srgbClr val="1A1A2E"/>
                 </a:solidFill>
@@ -9962,7 +11036,7 @@
               </a:rPr>
               <a:t>Créer des parcours</a:t>
             </a:r>
-            <a:endParaRPr lang="en-US" sz="1467" dirty="0"/>
+            <a:endParaRPr lang="fr-FR" sz="1467" noProof="0" dirty="0"/>
           </a:p>
         </p:txBody>
       </p:sp>
@@ -9989,7 +11063,7 @@
           <a:bodyPr/>
           <a:lstStyle/>
           <a:p>
-            <a:endParaRPr lang="fr-CH" sz="2400"/>
+            <a:endParaRPr lang="fr-FR" sz="2400" noProof="0" dirty="0"/>
           </a:p>
         </p:txBody>
       </p:sp>
@@ -10015,7 +11089,7 @@
           <a:lstStyle/>
           <a:p>
             <a:r>
-              <a:rPr lang="en-US" sz="1467" dirty="0">
+              <a:rPr lang="fr-FR" sz="1467" noProof="0" dirty="0">
                 <a:solidFill>
                   <a:srgbClr val="1A1A2E"/>
                 </a:solidFill>
@@ -10025,7 +11099,7 @@
               </a:rPr>
               <a:t>Rechercher des parcours</a:t>
             </a:r>
-            <a:endParaRPr lang="en-US" sz="1467" dirty="0"/>
+            <a:endParaRPr lang="fr-FR" sz="1467" noProof="0" dirty="0"/>
           </a:p>
         </p:txBody>
       </p:sp>
@@ -10052,7 +11126,7 @@
           <a:bodyPr/>
           <a:lstStyle/>
           <a:p>
-            <a:endParaRPr lang="fr-CH" sz="2400"/>
+            <a:endParaRPr lang="fr-FR" sz="2400" noProof="0" dirty="0"/>
           </a:p>
         </p:txBody>
       </p:sp>
@@ -10078,7 +11152,7 @@
           <a:lstStyle/>
           <a:p>
             <a:r>
-              <a:rPr lang="en-US" sz="1467" dirty="0">
+              <a:rPr lang="fr-FR" sz="1467" noProof="0" dirty="0">
                 <a:solidFill>
                   <a:srgbClr val="1A1A2E"/>
                 </a:solidFill>
@@ -10088,7 +11162,7 @@
               </a:rPr>
               <a:t>Consulter des parcours</a:t>
             </a:r>
-            <a:endParaRPr lang="en-US" sz="1467" dirty="0"/>
+            <a:endParaRPr lang="fr-FR" sz="1467" noProof="0" dirty="0"/>
           </a:p>
         </p:txBody>
       </p:sp>
@@ -10115,7 +11189,7 @@
           <a:bodyPr/>
           <a:lstStyle/>
           <a:p>
-            <a:endParaRPr lang="fr-CH" sz="2400"/>
+            <a:endParaRPr lang="fr-FR" sz="2400" noProof="0" dirty="0"/>
           </a:p>
         </p:txBody>
       </p:sp>
@@ -10141,7 +11215,7 @@
           <a:lstStyle/>
           <a:p>
             <a:r>
-              <a:rPr lang="en-US" sz="1467" dirty="0">
+              <a:rPr lang="fr-FR" sz="1467" noProof="0" dirty="0">
                 <a:solidFill>
                   <a:srgbClr val="1A1A2E"/>
                 </a:solidFill>
@@ -10151,7 +11225,7 @@
               </a:rPr>
               <a:t>Gestion personnelle</a:t>
             </a:r>
-            <a:endParaRPr lang="en-US" sz="1467" dirty="0"/>
+            <a:endParaRPr lang="fr-FR" sz="1467" noProof="0" dirty="0"/>
           </a:p>
         </p:txBody>
       </p:sp>
@@ -10207,10 +11281,9 @@
           <a:lstStyle/>
           <a:p>
             <a:r>
-              <a:rPr lang="fr-FR" dirty="0"/>
+              <a:rPr lang="fr-FR" noProof="0" dirty="0"/>
               <a:t>Diagramme GANTT</a:t>
             </a:r>
-            <a:endParaRPr lang="fr-CH" dirty="0"/>
           </a:p>
         </p:txBody>
       </p:sp>
@@ -10231,15 +11304,45 @@
           </p:nvPr>
         </p:nvPicPr>
         <p:blipFill>
-          <a:blip r:embed="rId2"/>
+          <a:blip r:embed="rId3"/>
           <a:stretch>
             <a:fillRect/>
           </a:stretch>
         </p:blipFill>
         <p:spPr>
           <a:xfrm>
-            <a:off x="1925978" y="1341359"/>
-            <a:ext cx="8499567" cy="5437144"/>
+            <a:off x="458637" y="1012166"/>
+            <a:ext cx="8844052" cy="5657510"/>
+          </a:xfrm>
+          <a:prstGeom prst="rect">
+            <a:avLst/>
+          </a:prstGeom>
+        </p:spPr>
+      </p:pic>
+      <p:pic>
+        <p:nvPicPr>
+          <p:cNvPr id="5" name="Image 4">
+            <a:extLst>
+              <a:ext uri="{FF2B5EF4-FFF2-40B4-BE49-F238E27FC236}">
+                <a16:creationId xmlns:a16="http://schemas.microsoft.com/office/drawing/2014/main" id="{9C76BF35-67B9-B2B8-6198-DE0ADFC13502}"/>
+              </a:ext>
+            </a:extLst>
+          </p:cNvPr>
+          <p:cNvPicPr>
+            <a:picLocks noChangeAspect="1"/>
+          </p:cNvPicPr>
+          <p:nvPr/>
+        </p:nvPicPr>
+        <p:blipFill>
+          <a:blip r:embed="rId4"/>
+          <a:stretch>
+            <a:fillRect/>
+          </a:stretch>
+        </p:blipFill>
+        <p:spPr>
+          <a:xfrm>
+            <a:off x="471782" y="991984"/>
+            <a:ext cx="8830907" cy="5677692"/>
           </a:xfrm>
           <a:prstGeom prst="rect">
             <a:avLst/>
@@ -10256,6 +11359,81 @@
   <p:clrMapOvr>
     <a:masterClrMapping/>
   </p:clrMapOvr>
+  <p:timing>
+    <p:tnLst>
+      <p:par>
+        <p:cTn id="1" dur="indefinite" restart="never" nodeType="tmRoot">
+          <p:childTnLst>
+            <p:seq concurrent="1" nextAc="seek">
+              <p:cTn id="2" dur="indefinite" nodeType="mainSeq">
+                <p:childTnLst>
+                  <p:par>
+                    <p:cTn id="3" fill="hold">
+                      <p:stCondLst>
+                        <p:cond delay="indefinite"/>
+                      </p:stCondLst>
+                      <p:childTnLst>
+                        <p:par>
+                          <p:cTn id="4" fill="hold">
+                            <p:stCondLst>
+                              <p:cond delay="0"/>
+                            </p:stCondLst>
+                            <p:childTnLst>
+                              <p:par>
+                                <p:cTn id="5" presetID="1" presetClass="entr" presetSubtype="0" fill="hold" nodeType="clickEffect">
+                                  <p:stCondLst>
+                                    <p:cond delay="0"/>
+                                  </p:stCondLst>
+                                  <p:childTnLst>
+                                    <p:set>
+                                      <p:cBhvr>
+                                        <p:cTn id="6" dur="1" fill="hold">
+                                          <p:stCondLst>
+                                            <p:cond delay="0"/>
+                                          </p:stCondLst>
+                                        </p:cTn>
+                                        <p:tgtEl>
+                                          <p:spTgt spid="5"/>
+                                        </p:tgtEl>
+                                        <p:attrNameLst>
+                                          <p:attrName>style.visibility</p:attrName>
+                                        </p:attrNameLst>
+                                      </p:cBhvr>
+                                      <p:to>
+                                        <p:strVal val="visible"/>
+                                      </p:to>
+                                    </p:set>
+                                  </p:childTnLst>
+                                </p:cTn>
+                              </p:par>
+                            </p:childTnLst>
+                          </p:cTn>
+                        </p:par>
+                      </p:childTnLst>
+                    </p:cTn>
+                  </p:par>
+                </p:childTnLst>
+              </p:cTn>
+              <p:prevCondLst>
+                <p:cond evt="onPrev" delay="0">
+                  <p:tgtEl>
+                    <p:sldTgt/>
+                  </p:tgtEl>
+                </p:cond>
+              </p:prevCondLst>
+              <p:nextCondLst>
+                <p:cond evt="onNext" delay="0">
+                  <p:tgtEl>
+                    <p:sldTgt/>
+                  </p:tgtEl>
+                </p:cond>
+              </p:nextCondLst>
+            </p:seq>
+          </p:childTnLst>
+        </p:cTn>
+      </p:par>
+    </p:tnLst>
+  </p:timing>
 </p:sld>
 </file>
 
@@ -10285,7 +11463,7 @@
         <p:spPr>
           <a:xfrm>
             <a:off x="487680" y="121920"/>
-            <a:ext cx="10972800" cy="853440"/>
+            <a:ext cx="5056229" cy="853440"/>
           </a:xfrm>
           <a:prstGeom prst="rect">
             <a:avLst/>
@@ -10298,7 +11476,7 @@
           <a:lstStyle/>
           <a:p>
             <a:r>
-              <a:rPr lang="en-US" sz="3733" b="1" dirty="0">
+              <a:rPr lang="fr-FR" sz="3733" b="1" noProof="0" dirty="0">
                 <a:solidFill>
                   <a:srgbClr val="FFFFFF"/>
                 </a:solidFill>
@@ -10308,7 +11486,7 @@
               </a:rPr>
               <a:t>02 — Architecture technique</a:t>
             </a:r>
-            <a:endParaRPr lang="en-US" sz="3733" dirty="0"/>
+            <a:endParaRPr lang="fr-FR" sz="3733" noProof="0" dirty="0"/>
           </a:p>
         </p:txBody>
       </p:sp>
@@ -10320,7 +11498,7 @@
         </p:nvSpPr>
         <p:spPr>
           <a:xfrm>
-            <a:off x="304800" y="1280160"/>
+            <a:off x="120769" y="1280160"/>
             <a:ext cx="3779520" cy="5242560"/>
           </a:xfrm>
           <a:prstGeom prst="rect">
@@ -10347,7 +11525,7 @@
           <a:bodyPr/>
           <a:lstStyle/>
           <a:p>
-            <a:endParaRPr lang="fr-CH" sz="2400"/>
+            <a:endParaRPr lang="fr-FR" sz="2400" noProof="0" dirty="0"/>
           </a:p>
         </p:txBody>
       </p:sp>
@@ -10359,7 +11537,7 @@
         </p:nvSpPr>
         <p:spPr>
           <a:xfrm>
-            <a:off x="304800" y="1280160"/>
+            <a:off x="120769" y="1246503"/>
             <a:ext cx="3779520" cy="670560"/>
           </a:xfrm>
           <a:prstGeom prst="rect">
@@ -10374,7 +11552,7 @@
           <a:bodyPr/>
           <a:lstStyle/>
           <a:p>
-            <a:endParaRPr lang="fr-CH" sz="2400"/>
+            <a:endParaRPr lang="fr-FR" sz="2400" noProof="0" dirty="0"/>
           </a:p>
         </p:txBody>
       </p:sp>
@@ -10386,7 +11564,7 @@
         </p:nvSpPr>
         <p:spPr>
           <a:xfrm>
-            <a:off x="426720" y="1341120"/>
+            <a:off x="242689" y="1307463"/>
             <a:ext cx="3535680" cy="548640"/>
           </a:xfrm>
           <a:prstGeom prst="rect">
@@ -10401,7 +11579,7 @@
           <a:p>
             <a:pPr algn="ctr"/>
             <a:r>
-              <a:rPr lang="en-US" sz="1867" b="1" dirty="0">
+              <a:rPr lang="fr-FR" sz="1867" b="1" noProof="0" dirty="0">
                 <a:solidFill>
                   <a:srgbClr val="FFFFFF"/>
                 </a:solidFill>
@@ -10409,9 +11587,9 @@
                 <a:ea typeface="Arial" pitchFamily="34" charset="-122"/>
                 <a:cs typeface="Arial" pitchFamily="34" charset="-120"/>
               </a:rPr>
-              <a:t>🌐 Frontend</a:t>
-            </a:r>
-            <a:endParaRPr lang="en-US" sz="1867" dirty="0"/>
+              <a:t>Frontend</a:t>
+            </a:r>
+            <a:endParaRPr lang="fr-FR" sz="1867" noProof="0" dirty="0"/>
           </a:p>
         </p:txBody>
       </p:sp>
@@ -10423,7 +11601,7 @@
         </p:nvSpPr>
         <p:spPr>
           <a:xfrm>
-            <a:off x="487680" y="2133600"/>
+            <a:off x="303649" y="2099943"/>
             <a:ext cx="3474720" cy="609600"/>
           </a:xfrm>
           <a:prstGeom prst="rect">
@@ -10437,7 +11615,7 @@
           <a:lstStyle/>
           <a:p>
             <a:r>
-              <a:rPr lang="en-US" sz="1467" dirty="0">
+              <a:rPr lang="fr-FR" sz="1467" noProof="0" dirty="0">
                 <a:solidFill>
                   <a:srgbClr val="1A1A2E"/>
                 </a:solidFill>
@@ -10445,9 +11623,9 @@
                 <a:ea typeface="Arial" pitchFamily="34" charset="-122"/>
                 <a:cs typeface="Arial" pitchFamily="34" charset="-120"/>
               </a:rPr>
-              <a:t>• HTML / CSS / JS vanilla</a:t>
-            </a:r>
-            <a:endParaRPr lang="en-US" sz="1467" dirty="0"/>
+              <a:t>• HTML / CSS / JS</a:t>
+            </a:r>
+            <a:endParaRPr lang="fr-FR" sz="1467" noProof="0" dirty="0"/>
           </a:p>
         </p:txBody>
       </p:sp>
@@ -10459,7 +11637,7 @@
         </p:nvSpPr>
         <p:spPr>
           <a:xfrm>
-            <a:off x="487680" y="2865120"/>
+            <a:off x="303649" y="2831463"/>
             <a:ext cx="3474720" cy="609600"/>
           </a:xfrm>
           <a:prstGeom prst="rect">
@@ -10473,7 +11651,7 @@
           <a:lstStyle/>
           <a:p>
             <a:r>
-              <a:rPr lang="en-US" sz="1467" dirty="0">
+              <a:rPr lang="fr-FR" sz="1467" noProof="0" dirty="0">
                 <a:solidFill>
                   <a:srgbClr val="1A1A2E"/>
                 </a:solidFill>
@@ -10481,9 +11659,9 @@
                 <a:ea typeface="Arial" pitchFamily="34" charset="-122"/>
                 <a:cs typeface="Arial" pitchFamily="34" charset="-120"/>
               </a:rPr>
-              <a:t>• Leaflet.js 1.9</a:t>
-            </a:r>
-            <a:endParaRPr lang="en-US" sz="1467" dirty="0"/>
+              <a:t>• Leaflet.js</a:t>
+            </a:r>
+            <a:endParaRPr lang="fr-FR" sz="1467" noProof="0" dirty="0"/>
           </a:p>
         </p:txBody>
       </p:sp>
@@ -10495,7 +11673,7 @@
         </p:nvSpPr>
         <p:spPr>
           <a:xfrm>
-            <a:off x="487680" y="3596640"/>
+            <a:off x="303649" y="3562983"/>
             <a:ext cx="3474720" cy="609600"/>
           </a:xfrm>
           <a:prstGeom prst="rect">
@@ -10509,7 +11687,7 @@
           <a:lstStyle/>
           <a:p>
             <a:r>
-              <a:rPr lang="en-US" sz="1467" dirty="0">
+              <a:rPr lang="fr-FR" sz="1467" noProof="0" dirty="0">
                 <a:solidFill>
                   <a:srgbClr val="1A1A2E"/>
                 </a:solidFill>
@@ -10517,35 +11695,10 @@
                 <a:ea typeface="Arial" pitchFamily="34" charset="-122"/>
                 <a:cs typeface="Arial" pitchFamily="34" charset="-120"/>
               </a:rPr>
-              <a:t>• Swisstopo WMTS (gratuit)</a:t>
-            </a:r>
-            <a:endParaRPr lang="en-US" sz="1467" dirty="0"/>
-          </a:p>
-        </p:txBody>
-      </p:sp>
-      <p:sp>
-        <p:nvSpPr>
-          <p:cNvPr id="10" name="Text 8"/>
-          <p:cNvSpPr/>
-          <p:nvPr/>
-        </p:nvSpPr>
-        <p:spPr>
-          <a:xfrm>
-            <a:off x="487680" y="4328160"/>
-            <a:ext cx="3474720" cy="609600"/>
-          </a:xfrm>
-          <a:prstGeom prst="rect">
-            <a:avLst/>
-          </a:prstGeom>
-          <a:noFill/>
-          <a:ln/>
-        </p:spPr>
-        <p:txBody>
-          <a:bodyPr wrap="square" rtlCol="0" anchor="ctr"/>
-          <a:lstStyle/>
-          <a:p>
-            <a:r>
-              <a:rPr lang="en-US" sz="1467" dirty="0">
+              <a:t>• </a:t>
+            </a:r>
+            <a:r>
+              <a:rPr lang="fr-FR" sz="1467" noProof="0" dirty="0" err="1">
                 <a:solidFill>
                   <a:srgbClr val="1A1A2E"/>
                 </a:solidFill>
@@ -10553,21 +11706,32 @@
                 <a:ea typeface="Arial" pitchFamily="34" charset="-122"/>
                 <a:cs typeface="Arial" pitchFamily="34" charset="-120"/>
               </a:rPr>
-              <a:t>• Open Street Map</a:t>
-            </a:r>
-            <a:endParaRPr lang="en-US" sz="1467" dirty="0"/>
-          </a:p>
-        </p:txBody>
-      </p:sp>
-      <p:sp>
-        <p:nvSpPr>
-          <p:cNvPr id="11" name="Text 9"/>
+              <a:t>Swisstopo</a:t>
+            </a:r>
+            <a:r>
+              <a:rPr lang="fr-FR" sz="1467" noProof="0" dirty="0">
+                <a:solidFill>
+                  <a:srgbClr val="1A1A2E"/>
+                </a:solidFill>
+                <a:latin typeface="Arial" pitchFamily="34" charset="0"/>
+                <a:ea typeface="Arial" pitchFamily="34" charset="-122"/>
+                <a:cs typeface="Arial" pitchFamily="34" charset="-120"/>
+              </a:rPr>
+              <a:t> WMTS</a:t>
+            </a:r>
+            <a:endParaRPr lang="fr-FR" sz="1467" noProof="0" dirty="0"/>
+          </a:p>
+        </p:txBody>
+      </p:sp>
+      <p:sp>
+        <p:nvSpPr>
+          <p:cNvPr id="10" name="Text 8"/>
           <p:cNvSpPr/>
           <p:nvPr/>
         </p:nvSpPr>
         <p:spPr>
           <a:xfrm>
-            <a:off x="487680" y="5059680"/>
+            <a:off x="303649" y="4294503"/>
             <a:ext cx="3474720" cy="609600"/>
           </a:xfrm>
           <a:prstGeom prst="rect">
@@ -10581,7 +11745,54 @@
           <a:lstStyle/>
           <a:p>
             <a:r>
-              <a:rPr lang="en-US" sz="1467" dirty="0">
+              <a:rPr lang="fr-FR" sz="1467" noProof="0" dirty="0">
+                <a:solidFill>
+                  <a:srgbClr val="1A1A2E"/>
+                </a:solidFill>
+                <a:latin typeface="Arial" pitchFamily="34" charset="0"/>
+                <a:ea typeface="Arial" pitchFamily="34" charset="-122"/>
+                <a:cs typeface="Arial" pitchFamily="34" charset="-120"/>
+              </a:rPr>
+              <a:t>• Open Street </a:t>
+            </a:r>
+            <a:r>
+              <a:rPr lang="fr-FR" sz="1467" noProof="0" dirty="0" err="1">
+                <a:solidFill>
+                  <a:srgbClr val="1A1A2E"/>
+                </a:solidFill>
+                <a:latin typeface="Arial" pitchFamily="34" charset="0"/>
+                <a:ea typeface="Arial" pitchFamily="34" charset="-122"/>
+                <a:cs typeface="Arial" pitchFamily="34" charset="-120"/>
+              </a:rPr>
+              <a:t>Map</a:t>
+            </a:r>
+            <a:endParaRPr lang="fr-FR" sz="1467" noProof="0" dirty="0"/>
+          </a:p>
+        </p:txBody>
+      </p:sp>
+      <p:sp>
+        <p:nvSpPr>
+          <p:cNvPr id="11" name="Text 9"/>
+          <p:cNvSpPr/>
+          <p:nvPr/>
+        </p:nvSpPr>
+        <p:spPr>
+          <a:xfrm>
+            <a:off x="303649" y="5026023"/>
+            <a:ext cx="3474720" cy="609600"/>
+          </a:xfrm>
+          <a:prstGeom prst="rect">
+            <a:avLst/>
+          </a:prstGeom>
+          <a:noFill/>
+          <a:ln/>
+        </p:spPr>
+        <p:txBody>
+          <a:bodyPr wrap="square" rtlCol="0" anchor="ctr"/>
+          <a:lstStyle/>
+          <a:p>
+            <a:r>
+              <a:rPr lang="fr-FR" sz="1467" noProof="0" dirty="0">
                 <a:solidFill>
                   <a:srgbClr val="1A1A2E"/>
                 </a:solidFill>
@@ -10591,7 +11802,7 @@
               </a:rPr>
               <a:t>• 6 fichiers JS modulaires</a:t>
             </a:r>
-            <a:endParaRPr lang="en-US" sz="1467" dirty="0"/>
+            <a:endParaRPr lang="fr-FR" sz="1467" noProof="0" dirty="0"/>
           </a:p>
         </p:txBody>
       </p:sp>
@@ -10603,7 +11814,7 @@
         </p:nvSpPr>
         <p:spPr>
           <a:xfrm>
-            <a:off x="4389120" y="1280160"/>
+            <a:off x="4203367" y="1280160"/>
             <a:ext cx="3779520" cy="5242560"/>
           </a:xfrm>
           <a:prstGeom prst="rect">
@@ -10630,7 +11841,7 @@
           <a:bodyPr/>
           <a:lstStyle/>
           <a:p>
-            <a:endParaRPr lang="fr-CH" sz="2400"/>
+            <a:endParaRPr lang="fr-FR" sz="2400" noProof="0" dirty="0"/>
           </a:p>
         </p:txBody>
       </p:sp>
@@ -10642,7 +11853,7 @@
         </p:nvSpPr>
         <p:spPr>
           <a:xfrm>
-            <a:off x="4389120" y="1280160"/>
+            <a:off x="4205089" y="1246503"/>
             <a:ext cx="3779520" cy="670560"/>
           </a:xfrm>
           <a:prstGeom prst="rect">
@@ -10657,7 +11868,7 @@
           <a:bodyPr/>
           <a:lstStyle/>
           <a:p>
-            <a:endParaRPr lang="fr-CH" sz="2400"/>
+            <a:endParaRPr lang="fr-FR" sz="2400" noProof="0" dirty="0"/>
           </a:p>
         </p:txBody>
       </p:sp>
@@ -10669,7 +11880,7 @@
         </p:nvSpPr>
         <p:spPr>
           <a:xfrm>
-            <a:off x="4511040" y="1341120"/>
+            <a:off x="4327009" y="1307463"/>
             <a:ext cx="3535680" cy="548640"/>
           </a:xfrm>
           <a:prstGeom prst="rect">
@@ -10684,7 +11895,7 @@
           <a:p>
             <a:pPr algn="ctr"/>
             <a:r>
-              <a:rPr lang="en-US" sz="1867" b="1" dirty="0">
+              <a:rPr lang="fr-FR" sz="1867" b="1" noProof="0" dirty="0">
                 <a:solidFill>
                   <a:srgbClr val="FFFFFF"/>
                 </a:solidFill>
@@ -10692,9 +11903,9 @@
                 <a:ea typeface="Arial" pitchFamily="34" charset="-122"/>
                 <a:cs typeface="Arial" pitchFamily="34" charset="-120"/>
               </a:rPr>
-              <a:t>⚙️ Backend Go</a:t>
-            </a:r>
-            <a:endParaRPr lang="en-US" sz="1867" dirty="0"/>
+              <a:t>Backend</a:t>
+            </a:r>
+            <a:endParaRPr lang="fr-FR" sz="1867" noProof="0" dirty="0"/>
           </a:p>
         </p:txBody>
       </p:sp>
@@ -10706,7 +11917,7 @@
         </p:nvSpPr>
         <p:spPr>
           <a:xfrm>
-            <a:off x="4572000" y="2133600"/>
+            <a:off x="4387969" y="2099943"/>
             <a:ext cx="3474720" cy="609600"/>
           </a:xfrm>
           <a:prstGeom prst="rect">
@@ -10720,7 +11931,7 @@
           <a:lstStyle/>
           <a:p>
             <a:r>
-              <a:rPr lang="en-US" sz="1467" dirty="0">
+              <a:rPr lang="fr-FR" sz="1467" noProof="0" dirty="0">
                 <a:solidFill>
                   <a:srgbClr val="1A1A2E"/>
                 </a:solidFill>
@@ -10728,35 +11939,10 @@
                 <a:ea typeface="Arial" pitchFamily="34" charset="-122"/>
                 <a:cs typeface="Arial" pitchFamily="34" charset="-120"/>
               </a:rPr>
-              <a:t>• Go 1.21 + Gin framework</a:t>
-            </a:r>
-            <a:endParaRPr lang="en-US" sz="1467" dirty="0"/>
-          </a:p>
-        </p:txBody>
-      </p:sp>
-      <p:sp>
-        <p:nvSpPr>
-          <p:cNvPr id="16" name="Text 14"/>
-          <p:cNvSpPr/>
-          <p:nvPr/>
-        </p:nvSpPr>
-        <p:spPr>
-          <a:xfrm>
-            <a:off x="4572000" y="2865120"/>
-            <a:ext cx="3474720" cy="609600"/>
-          </a:xfrm>
-          <a:prstGeom prst="rect">
-            <a:avLst/>
-          </a:prstGeom>
-          <a:noFill/>
-          <a:ln/>
-        </p:spPr>
-        <p:txBody>
-          <a:bodyPr wrap="square" rtlCol="0" anchor="ctr"/>
-          <a:lstStyle/>
-          <a:p>
-            <a:r>
-              <a:rPr lang="en-US" sz="1467" dirty="0">
+              <a:t>• Go 1.21 + Gin </a:t>
+            </a:r>
+            <a:r>
+              <a:rPr lang="fr-FR" sz="1467" noProof="0" dirty="0" err="1">
                 <a:solidFill>
                   <a:srgbClr val="1A1A2E"/>
                 </a:solidFill>
@@ -10764,9 +11950,9 @@
                 <a:ea typeface="Arial" pitchFamily="34" charset="-122"/>
                 <a:cs typeface="Arial" pitchFamily="34" charset="-120"/>
               </a:rPr>
-              <a:t>• Binaire natif → &lt;5ms</a:t>
-            </a:r>
-            <a:endParaRPr lang="en-US" sz="1467" dirty="0"/>
+              <a:t>framework</a:t>
+            </a:r>
+            <a:endParaRPr lang="fr-FR" sz="1467" noProof="0" dirty="0"/>
           </a:p>
         </p:txBody>
       </p:sp>
@@ -10778,7 +11964,7 @@
         </p:nvSpPr>
         <p:spPr>
           <a:xfrm>
-            <a:off x="4572000" y="3596640"/>
+            <a:off x="4393145" y="2827495"/>
             <a:ext cx="3474720" cy="609600"/>
           </a:xfrm>
           <a:prstGeom prst="rect">
@@ -10792,7 +11978,7 @@
           <a:lstStyle/>
           <a:p>
             <a:r>
-              <a:rPr lang="en-US" sz="1467" dirty="0">
+              <a:rPr lang="fr-FR" sz="1467" noProof="0" dirty="0">
                 <a:solidFill>
                   <a:srgbClr val="1A1A2E"/>
                 </a:solidFill>
@@ -10800,35 +11986,10 @@
                 <a:ea typeface="Arial" pitchFamily="34" charset="-122"/>
                 <a:cs typeface="Arial" pitchFamily="34" charset="-120"/>
               </a:rPr>
-              <a:t>• REST API 5 endpoints</a:t>
-            </a:r>
-            <a:endParaRPr lang="en-US" sz="1467" dirty="0"/>
-          </a:p>
-        </p:txBody>
-      </p:sp>
-      <p:sp>
-        <p:nvSpPr>
-          <p:cNvPr id="18" name="Text 16"/>
-          <p:cNvSpPr/>
-          <p:nvPr/>
-        </p:nvSpPr>
-        <p:spPr>
-          <a:xfrm>
-            <a:off x="4572000" y="4328160"/>
-            <a:ext cx="3474720" cy="609600"/>
-          </a:xfrm>
-          <a:prstGeom prst="rect">
-            <a:avLst/>
-          </a:prstGeom>
-          <a:noFill/>
-          <a:ln/>
-        </p:spPr>
-        <p:txBody>
-          <a:bodyPr wrap="square" rtlCol="0" anchor="ctr"/>
-          <a:lstStyle/>
-          <a:p>
-            <a:r>
-              <a:rPr lang="en-US" sz="1467" dirty="0">
+              <a:t>• REST API 5 </a:t>
+            </a:r>
+            <a:r>
+              <a:rPr lang="fr-FR" sz="1467" noProof="0" dirty="0" err="1">
                 <a:solidFill>
                   <a:srgbClr val="1A1A2E"/>
                 </a:solidFill>
@@ -10836,21 +11997,21 @@
                 <a:ea typeface="Arial" pitchFamily="34" charset="-122"/>
                 <a:cs typeface="Arial" pitchFamily="34" charset="-120"/>
               </a:rPr>
-              <a:t>• Fichiers statiques servis</a:t>
-            </a:r>
-            <a:endParaRPr lang="en-US" sz="1467" dirty="0"/>
-          </a:p>
-        </p:txBody>
-      </p:sp>
-      <p:sp>
-        <p:nvSpPr>
-          <p:cNvPr id="19" name="Text 17"/>
+              <a:t>endpoints</a:t>
+            </a:r>
+            <a:endParaRPr lang="fr-FR" sz="1467" noProof="0" dirty="0"/>
+          </a:p>
+        </p:txBody>
+      </p:sp>
+      <p:sp>
+        <p:nvSpPr>
+          <p:cNvPr id="18" name="Text 16"/>
           <p:cNvSpPr/>
           <p:nvPr/>
         </p:nvSpPr>
         <p:spPr>
           <a:xfrm>
-            <a:off x="4572000" y="5059680"/>
+            <a:off x="4393145" y="3559015"/>
             <a:ext cx="3474720" cy="609600"/>
           </a:xfrm>
           <a:prstGeom prst="rect">
@@ -10864,7 +12025,7 @@
           <a:lstStyle/>
           <a:p>
             <a:r>
-              <a:rPr lang="en-US" sz="1467" dirty="0">
+              <a:rPr lang="fr-FR" sz="1467" noProof="0" dirty="0">
                 <a:solidFill>
                   <a:srgbClr val="1A1A2E"/>
                 </a:solidFill>
@@ -10872,9 +12033,56 @@
                 <a:ea typeface="Arial" pitchFamily="34" charset="-122"/>
                 <a:cs typeface="Arial" pitchFamily="34" charset="-120"/>
               </a:rPr>
-              <a:t>• Connexion via .env</a:t>
-            </a:r>
-            <a:endParaRPr lang="en-US" sz="1467" dirty="0"/>
+              <a:t>• Fichiers statiques</a:t>
+            </a:r>
+            <a:endParaRPr lang="fr-FR" sz="1467" noProof="0" dirty="0"/>
+          </a:p>
+        </p:txBody>
+      </p:sp>
+      <p:sp>
+        <p:nvSpPr>
+          <p:cNvPr id="19" name="Text 17"/>
+          <p:cNvSpPr/>
+          <p:nvPr/>
+        </p:nvSpPr>
+        <p:spPr>
+          <a:xfrm>
+            <a:off x="4393145" y="4290535"/>
+            <a:ext cx="3474720" cy="609600"/>
+          </a:xfrm>
+          <a:prstGeom prst="rect">
+            <a:avLst/>
+          </a:prstGeom>
+          <a:noFill/>
+          <a:ln/>
+        </p:spPr>
+        <p:txBody>
+          <a:bodyPr wrap="square" rtlCol="0" anchor="ctr"/>
+          <a:lstStyle/>
+          <a:p>
+            <a:r>
+              <a:rPr lang="fr-FR" sz="1467" noProof="0" dirty="0">
+                <a:solidFill>
+                  <a:srgbClr val="1A1A2E"/>
+                </a:solidFill>
+                <a:latin typeface="Arial" pitchFamily="34" charset="0"/>
+                <a:ea typeface="Arial" pitchFamily="34" charset="-122"/>
+                <a:cs typeface="Arial" pitchFamily="34" charset="-120"/>
+              </a:rPr>
+              <a:t>• Connexion via .</a:t>
+            </a:r>
+            <a:r>
+              <a:rPr lang="fr-FR" sz="1467" noProof="0" dirty="0" err="1">
+                <a:solidFill>
+                  <a:srgbClr val="1A1A2E"/>
+                </a:solidFill>
+                <a:latin typeface="Arial" pitchFamily="34" charset="0"/>
+                <a:ea typeface="Arial" pitchFamily="34" charset="-122"/>
+                <a:cs typeface="Arial" pitchFamily="34" charset="-120"/>
+              </a:rPr>
+              <a:t>env</a:t>
+            </a:r>
+            <a:endParaRPr lang="fr-FR" sz="1467" noProof="0" dirty="0"/>
           </a:p>
         </p:txBody>
       </p:sp>
@@ -10886,7 +12094,7 @@
         </p:nvSpPr>
         <p:spPr>
           <a:xfrm>
-            <a:off x="8473440" y="1280160"/>
+            <a:off x="8289409" y="1280160"/>
             <a:ext cx="3779520" cy="5242560"/>
           </a:xfrm>
           <a:prstGeom prst="rect">
@@ -10913,7 +12121,7 @@
           <a:bodyPr/>
           <a:lstStyle/>
           <a:p>
-            <a:endParaRPr lang="fr-CH" sz="2400"/>
+            <a:endParaRPr lang="fr-FR" sz="2400" noProof="0" dirty="0"/>
           </a:p>
         </p:txBody>
       </p:sp>
@@ -10925,7 +12133,7 @@
         </p:nvSpPr>
         <p:spPr>
           <a:xfrm>
-            <a:off x="8473440" y="1280160"/>
+            <a:off x="8289409" y="1280160"/>
             <a:ext cx="3779520" cy="670560"/>
           </a:xfrm>
           <a:prstGeom prst="rect">
@@ -10940,7 +12148,7 @@
           <a:bodyPr/>
           <a:lstStyle/>
           <a:p>
-            <a:endParaRPr lang="fr-CH" sz="2400"/>
+            <a:endParaRPr lang="fr-FR" sz="2400" noProof="0" dirty="0"/>
           </a:p>
         </p:txBody>
       </p:sp>
@@ -10952,7 +12160,7 @@
         </p:nvSpPr>
         <p:spPr>
           <a:xfrm>
-            <a:off x="8595360" y="1341120"/>
+            <a:off x="8411329" y="1307463"/>
             <a:ext cx="3535680" cy="548640"/>
           </a:xfrm>
           <a:prstGeom prst="rect">
@@ -10967,7 +12175,7 @@
           <a:p>
             <a:pPr algn="ctr"/>
             <a:r>
-              <a:rPr lang="en-US" sz="1867" b="1" dirty="0">
+              <a:rPr lang="fr-FR" sz="1867" b="1" noProof="0" dirty="0">
                 <a:solidFill>
                   <a:srgbClr val="FFFFFF"/>
                 </a:solidFill>
@@ -10975,9 +12183,9 @@
                 <a:ea typeface="Arial" pitchFamily="34" charset="-122"/>
                 <a:cs typeface="Arial" pitchFamily="34" charset="-120"/>
               </a:rPr>
-              <a:t>🗄️ Base de données</a:t>
-            </a:r>
-            <a:endParaRPr lang="en-US" sz="1867" dirty="0"/>
+              <a:t>Base de données</a:t>
+            </a:r>
+            <a:endParaRPr lang="fr-FR" sz="1867" noProof="0" dirty="0"/>
           </a:p>
         </p:txBody>
       </p:sp>
@@ -10989,7 +12197,7 @@
         </p:nvSpPr>
         <p:spPr>
           <a:xfrm>
-            <a:off x="8656320" y="2133600"/>
+            <a:off x="8472289" y="2099943"/>
             <a:ext cx="3474720" cy="609600"/>
           </a:xfrm>
           <a:prstGeom prst="rect">
@@ -11003,7 +12211,7 @@
           <a:lstStyle/>
           <a:p>
             <a:r>
-              <a:rPr lang="en-US" sz="1467" dirty="0">
+              <a:rPr lang="fr-FR" sz="1467" noProof="0" dirty="0">
                 <a:solidFill>
                   <a:srgbClr val="1A1A2E"/>
                 </a:solidFill>
@@ -11013,7 +12221,7 @@
               </a:rPr>
               <a:t>• PostgreSQL 15</a:t>
             </a:r>
-            <a:endParaRPr lang="en-US" sz="1467" dirty="0"/>
+            <a:endParaRPr lang="fr-FR" sz="1467" noProof="0" dirty="0"/>
           </a:p>
         </p:txBody>
       </p:sp>
@@ -11025,7 +12233,7 @@
         </p:nvSpPr>
         <p:spPr>
           <a:xfrm>
-            <a:off x="8656320" y="2865120"/>
+            <a:off x="8472289" y="2827495"/>
             <a:ext cx="3474720" cy="609600"/>
           </a:xfrm>
           <a:prstGeom prst="rect">
@@ -11039,7 +12247,7 @@
           <a:lstStyle/>
           <a:p>
             <a:r>
-              <a:rPr lang="en-US" sz="1467" dirty="0">
+              <a:rPr lang="fr-FR" sz="1467" noProof="0" dirty="0">
                 <a:solidFill>
                   <a:srgbClr val="1A1A2E"/>
                 </a:solidFill>
@@ -11047,35 +12255,10 @@
                 <a:ea typeface="Arial" pitchFamily="34" charset="-122"/>
                 <a:cs typeface="Arial" pitchFamily="34" charset="-120"/>
               </a:rPr>
-              <a:t>• PostGIS — géométries</a:t>
-            </a:r>
-            <a:endParaRPr lang="en-US" sz="1467" dirty="0"/>
-          </a:p>
-        </p:txBody>
-      </p:sp>
-      <p:sp>
-        <p:nvSpPr>
-          <p:cNvPr id="25" name="Text 23"/>
-          <p:cNvSpPr/>
-          <p:nvPr/>
-        </p:nvSpPr>
-        <p:spPr>
-          <a:xfrm>
-            <a:off x="8656320" y="3596640"/>
-            <a:ext cx="3474720" cy="609600"/>
-          </a:xfrm>
-          <a:prstGeom prst="rect">
-            <a:avLst/>
-          </a:prstGeom>
-          <a:noFill/>
-          <a:ln/>
-        </p:spPr>
-        <p:txBody>
-          <a:bodyPr wrap="square" rtlCol="0" anchor="ctr"/>
-          <a:lstStyle/>
-          <a:p>
-            <a:r>
-              <a:rPr lang="en-US" sz="1467" dirty="0">
+              <a:t>• </a:t>
+            </a:r>
+            <a:r>
+              <a:rPr lang="fr-FR" sz="1467" noProof="0" dirty="0" err="1">
                 <a:solidFill>
                   <a:srgbClr val="1A1A2E"/>
                 </a:solidFill>
@@ -11083,21 +12266,32 @@
                 <a:ea typeface="Arial" pitchFamily="34" charset="-122"/>
                 <a:cs typeface="Arial" pitchFamily="34" charset="-120"/>
               </a:rPr>
-              <a:t>• pgRouting 3.4 — Dijkstra</a:t>
-            </a:r>
-            <a:endParaRPr lang="en-US" sz="1467" dirty="0"/>
-          </a:p>
-        </p:txBody>
-      </p:sp>
-      <p:sp>
-        <p:nvSpPr>
-          <p:cNvPr id="26" name="Text 24"/>
+              <a:t>PostGIS</a:t>
+            </a:r>
+            <a:r>
+              <a:rPr lang="fr-FR" sz="1467" noProof="0" dirty="0">
+                <a:solidFill>
+                  <a:srgbClr val="1A1A2E"/>
+                </a:solidFill>
+                <a:latin typeface="Arial" pitchFamily="34" charset="0"/>
+                <a:ea typeface="Arial" pitchFamily="34" charset="-122"/>
+                <a:cs typeface="Arial" pitchFamily="34" charset="-120"/>
+              </a:rPr>
+              <a:t> - géométries</a:t>
+            </a:r>
+            <a:endParaRPr lang="fr-FR" sz="1467" noProof="0" dirty="0"/>
+          </a:p>
+        </p:txBody>
+      </p:sp>
+      <p:sp>
+        <p:nvSpPr>
+          <p:cNvPr id="25" name="Text 23"/>
           <p:cNvSpPr/>
           <p:nvPr/>
         </p:nvSpPr>
         <p:spPr>
           <a:xfrm>
-            <a:off x="8656320" y="4328160"/>
+            <a:off x="8472289" y="3559015"/>
             <a:ext cx="3474720" cy="609600"/>
           </a:xfrm>
           <a:prstGeom prst="rect">
@@ -11111,7 +12305,65 @@
           <a:lstStyle/>
           <a:p>
             <a:r>
-              <a:rPr lang="en-US" sz="1467" dirty="0">
+              <a:rPr lang="fr-FR" sz="1467" noProof="0" dirty="0">
+                <a:solidFill>
+                  <a:srgbClr val="1A1A2E"/>
+                </a:solidFill>
+                <a:latin typeface="Arial" pitchFamily="34" charset="0"/>
+                <a:ea typeface="Arial" pitchFamily="34" charset="-122"/>
+                <a:cs typeface="Arial" pitchFamily="34" charset="-120"/>
+              </a:rPr>
+              <a:t>• </a:t>
+            </a:r>
+            <a:r>
+              <a:rPr lang="fr-FR" sz="1467" noProof="0" dirty="0" err="1">
+                <a:solidFill>
+                  <a:srgbClr val="1A1A2E"/>
+                </a:solidFill>
+                <a:latin typeface="Arial" pitchFamily="34" charset="0"/>
+                <a:ea typeface="Arial" pitchFamily="34" charset="-122"/>
+                <a:cs typeface="Arial" pitchFamily="34" charset="-120"/>
+              </a:rPr>
+              <a:t>pgRouting</a:t>
+            </a:r>
+            <a:r>
+              <a:rPr lang="fr-FR" sz="1467" noProof="0" dirty="0">
+                <a:solidFill>
+                  <a:srgbClr val="1A1A2E"/>
+                </a:solidFill>
+                <a:latin typeface="Arial" pitchFamily="34" charset="0"/>
+                <a:ea typeface="Arial" pitchFamily="34" charset="-122"/>
+                <a:cs typeface="Arial" pitchFamily="34" charset="-120"/>
+              </a:rPr>
+              <a:t> - Dijkstra</a:t>
+            </a:r>
+            <a:endParaRPr lang="fr-FR" sz="1467" noProof="0" dirty="0"/>
+          </a:p>
+        </p:txBody>
+      </p:sp>
+      <p:sp>
+        <p:nvSpPr>
+          <p:cNvPr id="26" name="Text 24"/>
+          <p:cNvSpPr/>
+          <p:nvPr/>
+        </p:nvSpPr>
+        <p:spPr>
+          <a:xfrm>
+            <a:off x="8472289" y="4290535"/>
+            <a:ext cx="3474720" cy="609600"/>
+          </a:xfrm>
+          <a:prstGeom prst="rect">
+            <a:avLst/>
+          </a:prstGeom>
+          <a:noFill/>
+          <a:ln/>
+        </p:spPr>
+        <p:txBody>
+          <a:bodyPr wrap="square" rtlCol="0" anchor="ctr"/>
+          <a:lstStyle/>
+          <a:p>
+            <a:r>
+              <a:rPr lang="fr-FR" sz="1467" noProof="0" dirty="0">
                 <a:solidFill>
                   <a:srgbClr val="1A1A2E"/>
                 </a:solidFill>
@@ -11121,43 +12373,7 @@
               </a:rPr>
               <a:t>• Docker Desktop</a:t>
             </a:r>
-            <a:endParaRPr lang="en-US" sz="1467" dirty="0"/>
-          </a:p>
-        </p:txBody>
-      </p:sp>
-      <p:sp>
-        <p:nvSpPr>
-          <p:cNvPr id="27" name="Text 25"/>
-          <p:cNvSpPr/>
-          <p:nvPr/>
-        </p:nvSpPr>
-        <p:spPr>
-          <a:xfrm>
-            <a:off x="8656320" y="5059680"/>
-            <a:ext cx="3474720" cy="609600"/>
-          </a:xfrm>
-          <a:prstGeom prst="rect">
-            <a:avLst/>
-          </a:prstGeom>
-          <a:noFill/>
-          <a:ln/>
-        </p:spPr>
-        <p:txBody>
-          <a:bodyPr wrap="square" rtlCol="0" anchor="ctr"/>
-          <a:lstStyle/>
-          <a:p>
-            <a:r>
-              <a:rPr lang="en-US" sz="1467" dirty="0">
-                <a:solidFill>
-                  <a:srgbClr val="1A1A2E"/>
-                </a:solidFill>
-                <a:latin typeface="Arial" pitchFamily="34" charset="0"/>
-                <a:ea typeface="Arial" pitchFamily="34" charset="-122"/>
-                <a:cs typeface="Arial" pitchFamily="34" charset="-120"/>
-              </a:rPr>
-              <a:t>• 351 509 ways OSM</a:t>
-            </a:r>
-            <a:endParaRPr lang="en-US" sz="1467" dirty="0"/>
+            <a:endParaRPr lang="fr-FR" sz="1467" noProof="0" dirty="0"/>
           </a:p>
         </p:txBody>
       </p:sp>
@@ -11168,9 +12384,9 @@
           <p:nvPr/>
         </p:nvSpPr>
         <p:spPr>
-          <a:xfrm>
-            <a:off x="4084320" y="3901440"/>
-            <a:ext cx="304800" cy="0"/>
+          <a:xfrm flipV="1">
+            <a:off x="3904315" y="4054416"/>
+            <a:ext cx="295026" cy="1330"/>
           </a:xfrm>
           <a:prstGeom prst="line">
             <a:avLst/>
@@ -11187,7 +12403,7 @@
           <a:bodyPr/>
           <a:lstStyle/>
           <a:p>
-            <a:endParaRPr lang="fr-CH" sz="2400"/>
+            <a:endParaRPr lang="fr-FR" sz="2400" noProof="0" dirty="0"/>
           </a:p>
         </p:txBody>
       </p:sp>
@@ -11199,8 +12415,8 @@
         </p:nvSpPr>
         <p:spPr>
           <a:xfrm>
-            <a:off x="8168640" y="3901440"/>
-            <a:ext cx="304800" cy="0"/>
+            <a:off x="7982887" y="4050964"/>
+            <a:ext cx="306522" cy="3451"/>
           </a:xfrm>
           <a:prstGeom prst="line">
             <a:avLst/>
@@ -11217,7 +12433,7 @@
           <a:bodyPr/>
           <a:lstStyle/>
           <a:p>
-            <a:endParaRPr lang="fr-CH" sz="2400"/>
+            <a:endParaRPr lang="fr-FR" sz="2400" noProof="0" dirty="0"/>
           </a:p>
         </p:txBody>
       </p:sp>
@@ -11229,7 +12445,7 @@
         </p:nvSpPr>
         <p:spPr>
           <a:xfrm>
-            <a:off x="4084320" y="3596640"/>
+            <a:off x="3904315" y="3559015"/>
             <a:ext cx="304800" cy="304800"/>
           </a:xfrm>
           <a:prstGeom prst="rect">
@@ -11244,7 +12460,7 @@
           <a:p>
             <a:pPr algn="ctr"/>
             <a:r>
-              <a:rPr lang="en-US" sz="1067" dirty="0">
+              <a:rPr lang="fr-FR" sz="1067" noProof="0" dirty="0">
                 <a:solidFill>
                   <a:srgbClr val="6B7280"/>
                 </a:solidFill>
@@ -11254,7 +12470,7 @@
               </a:rPr>
               <a:t>HTTP</a:t>
             </a:r>
-            <a:endParaRPr lang="en-US" sz="1067" dirty="0"/>
+            <a:endParaRPr lang="fr-FR" sz="1067" noProof="0" dirty="0"/>
           </a:p>
         </p:txBody>
       </p:sp>
@@ -11266,7 +12482,7 @@
         </p:nvSpPr>
         <p:spPr>
           <a:xfrm>
-            <a:off x="8168640" y="3596640"/>
+            <a:off x="7989785" y="3596640"/>
             <a:ext cx="304800" cy="304800"/>
           </a:xfrm>
           <a:prstGeom prst="rect">
@@ -11281,7 +12497,7 @@
           <a:p>
             <a:pPr algn="ctr"/>
             <a:r>
-              <a:rPr lang="en-US" sz="1067" dirty="0">
+              <a:rPr lang="fr-FR" sz="1067" noProof="0" dirty="0">
                 <a:solidFill>
                   <a:srgbClr val="6B7280"/>
                 </a:solidFill>
@@ -11291,7 +12507,7 @@
               </a:rPr>
               <a:t>SQL</a:t>
             </a:r>
-            <a:endParaRPr lang="en-US" sz="1067" dirty="0"/>
+            <a:endParaRPr lang="fr-FR" sz="1067" noProof="0" dirty="0"/>
           </a:p>
         </p:txBody>
       </p:sp>
@@ -11312,7 +12528,7 @@
         <p:spPr>
           <a:xfrm>
             <a:off x="426720" y="297655"/>
-            <a:ext cx="10515600" cy="1325563"/>
+            <a:ext cx="5220706" cy="602455"/>
           </a:xfrm>
           <a:prstGeom prst="rect">
             <a:avLst/>
@@ -11341,10 +12557,9 @@
           </a:lstStyle>
           <a:p>
             <a:r>
-              <a:rPr lang="fr-FR" dirty="0"/>
+              <a:rPr lang="fr-FR" noProof="0" dirty="0"/>
               <a:t>Architecture du projet</a:t>
             </a:r>
-            <a:endParaRPr lang="fr-CH" dirty="0"/>
           </a:p>
         </p:txBody>
       </p:sp>
@@ -11408,7 +12623,7 @@
           <a:bodyPr/>
           <a:lstStyle/>
           <a:p>
-            <a:endParaRPr lang="fr-CH" sz="2400"/>
+            <a:endParaRPr lang="fr-FR" sz="2400" noProof="0" dirty="0"/>
           </a:p>
         </p:txBody>
       </p:sp>
@@ -11434,7 +12649,7 @@
           <a:lstStyle/>
           <a:p>
             <a:r>
-              <a:rPr lang="en-US" sz="2133" b="1" dirty="0">
+              <a:rPr lang="fr-FR" sz="2133" b="1" noProof="0" dirty="0">
                 <a:solidFill>
                   <a:srgbClr val="40916C"/>
                 </a:solidFill>
@@ -11442,9 +12657,42 @@
                 <a:ea typeface="Courier New" pitchFamily="34" charset="-122"/>
                 <a:cs typeface="Courier New" pitchFamily="34" charset="-120"/>
               </a:rPr>
-              <a:t>🔗  github.com/Fabio-gio/GIN_projet</a:t>
-            </a:r>
-            <a:endParaRPr lang="en-US" sz="2133" dirty="0"/>
+              <a:t>🔗  github.com/Fabio-</a:t>
+            </a:r>
+            <a:r>
+              <a:rPr lang="fr-FR" sz="2133" b="1" noProof="0" dirty="0" err="1">
+                <a:solidFill>
+                  <a:srgbClr val="40916C"/>
+                </a:solidFill>
+                <a:latin typeface="Courier New" pitchFamily="34" charset="0"/>
+                <a:ea typeface="Courier New" pitchFamily="34" charset="-122"/>
+                <a:cs typeface="Courier New" pitchFamily="34" charset="-120"/>
+              </a:rPr>
+              <a:t>gio</a:t>
+            </a:r>
+            <a:r>
+              <a:rPr lang="fr-FR" sz="2133" b="1" noProof="0" dirty="0">
+                <a:solidFill>
+                  <a:srgbClr val="40916C"/>
+                </a:solidFill>
+                <a:latin typeface="Courier New" pitchFamily="34" charset="0"/>
+                <a:ea typeface="Courier New" pitchFamily="34" charset="-122"/>
+                <a:cs typeface="Courier New" pitchFamily="34" charset="-120"/>
+              </a:rPr>
+              <a:t>/</a:t>
+            </a:r>
+            <a:r>
+              <a:rPr lang="fr-FR" sz="2133" b="1" noProof="0" dirty="0" err="1">
+                <a:solidFill>
+                  <a:srgbClr val="40916C"/>
+                </a:solidFill>
+                <a:latin typeface="Courier New" pitchFamily="34" charset="0"/>
+                <a:ea typeface="Courier New" pitchFamily="34" charset="-122"/>
+                <a:cs typeface="Courier New" pitchFamily="34" charset="-120"/>
+              </a:rPr>
+              <a:t>GIN_projet</a:t>
+            </a:r>
+            <a:endParaRPr lang="fr-FR" sz="2133" noProof="0" dirty="0"/>
           </a:p>
         </p:txBody>
       </p:sp>
@@ -11476,7 +12724,7 @@
           <a:bodyPr/>
           <a:lstStyle/>
           <a:p>
-            <a:endParaRPr lang="fr-CH" sz="2400"/>
+            <a:endParaRPr lang="fr-FR" sz="2400" noProof="0" dirty="0"/>
           </a:p>
         </p:txBody>
       </p:sp>
@@ -11503,7 +12751,7 @@
           <a:bodyPr/>
           <a:lstStyle/>
           <a:p>
-            <a:endParaRPr lang="fr-CH" sz="2400"/>
+            <a:endParaRPr lang="fr-FR" sz="2400" noProof="0" dirty="0"/>
           </a:p>
         </p:txBody>
       </p:sp>
@@ -11530,7 +12778,7 @@
           <a:p>
             <a:pPr algn="ctr"/>
             <a:r>
-              <a:rPr lang="en-US" sz="1867" b="1" dirty="0">
+              <a:rPr lang="fr-FR" sz="1867" b="1" noProof="0" dirty="0">
                 <a:solidFill>
                   <a:srgbClr val="FFFFFF"/>
                 </a:solidFill>
@@ -11540,7 +12788,7 @@
               </a:rPr>
               <a:t>1</a:t>
             </a:r>
-            <a:endParaRPr lang="en-US" sz="1867" dirty="0"/>
+            <a:endParaRPr lang="fr-FR" sz="1867" noProof="0" dirty="0"/>
           </a:p>
         </p:txBody>
       </p:sp>
@@ -11566,7 +12814,7 @@
           <a:lstStyle/>
           <a:p>
             <a:r>
-              <a:rPr lang="en-US" sz="1533" b="1" dirty="0">
+              <a:rPr lang="fr-FR" sz="1533" b="1" noProof="0" dirty="0">
                 <a:solidFill>
                   <a:srgbClr val="1A1A2E"/>
                 </a:solidFill>
@@ -11576,7 +12824,7 @@
               </a:rPr>
               <a:t>Récupération &amp; tri des données</a:t>
             </a:r>
-            <a:endParaRPr lang="en-US" sz="1533" dirty="0"/>
+            <a:endParaRPr lang="fr-FR" sz="1533" noProof="0" dirty="0"/>
           </a:p>
         </p:txBody>
       </p:sp>
@@ -11602,7 +12850,7 @@
           <a:lstStyle/>
           <a:p>
             <a:r>
-              <a:rPr lang="en-US" sz="1267" i="1" dirty="0">
+              <a:rPr lang="fr-FR" sz="1267" i="1" noProof="0" dirty="0">
                 <a:solidFill>
                   <a:srgbClr val="6B7280"/>
                 </a:solidFill>
@@ -11610,9 +12858,9 @@
                 <a:ea typeface="Arial" pitchFamily="34" charset="-122"/>
                 <a:cs typeface="Arial" pitchFamily="34" charset="-120"/>
               </a:rPr>
-              <a:t>Routes OSM importées via osm2pgrouting — 351 509 ways</a:t>
-            </a:r>
-            <a:endParaRPr lang="en-US" sz="1267" dirty="0"/>
+              <a:t>Routes OSM importées via osm2pgrouting</a:t>
+            </a:r>
+            <a:endParaRPr lang="fr-FR" sz="1267" noProof="0" dirty="0"/>
           </a:p>
         </p:txBody>
       </p:sp>
@@ -11644,7 +12892,7 @@
           <a:bodyPr/>
           <a:lstStyle/>
           <a:p>
-            <a:endParaRPr lang="fr-CH" sz="2400"/>
+            <a:endParaRPr lang="fr-FR" sz="2400" noProof="0" dirty="0"/>
           </a:p>
         </p:txBody>
       </p:sp>
@@ -11671,7 +12919,7 @@
           <a:bodyPr/>
           <a:lstStyle/>
           <a:p>
-            <a:endParaRPr lang="fr-CH" sz="2400"/>
+            <a:endParaRPr lang="fr-FR" sz="2400" noProof="0" dirty="0"/>
           </a:p>
         </p:txBody>
       </p:sp>
@@ -11698,7 +12946,7 @@
           <a:p>
             <a:pPr algn="ctr"/>
             <a:r>
-              <a:rPr lang="en-US" sz="1867" b="1" dirty="0">
+              <a:rPr lang="fr-FR" sz="1867" b="1" noProof="0" dirty="0">
                 <a:solidFill>
                   <a:srgbClr val="FFFFFF"/>
                 </a:solidFill>
@@ -11708,7 +12956,7 @@
               </a:rPr>
               <a:t>2</a:t>
             </a:r>
-            <a:endParaRPr lang="en-US" sz="1867" dirty="0"/>
+            <a:endParaRPr lang="fr-FR" sz="1867" noProof="0" dirty="0"/>
           </a:p>
         </p:txBody>
       </p:sp>
@@ -11734,7 +12982,7 @@
           <a:lstStyle/>
           <a:p>
             <a:r>
-              <a:rPr lang="en-US" sz="1533" b="1" dirty="0">
+              <a:rPr lang="fr-FR" sz="1533" b="1" noProof="0" dirty="0">
                 <a:solidFill>
                   <a:srgbClr val="1A1A2E"/>
                 </a:solidFill>
@@ -11744,7 +12992,7 @@
               </a:rPr>
               <a:t>CSS &amp; interface visuelle</a:t>
             </a:r>
-            <a:endParaRPr lang="en-US" sz="1533" dirty="0"/>
+            <a:endParaRPr lang="fr-FR" sz="1533" noProof="0" dirty="0"/>
           </a:p>
         </p:txBody>
       </p:sp>
@@ -11770,7 +13018,7 @@
           <a:lstStyle/>
           <a:p>
             <a:r>
-              <a:rPr lang="en-US" sz="1267" i="1" dirty="0">
+              <a:rPr lang="fr-FR" sz="1267" i="1" noProof="0" dirty="0">
                 <a:solidFill>
                   <a:srgbClr val="6B7280"/>
                 </a:solidFill>
@@ -11778,9 +13026,31 @@
                 <a:ea typeface="Arial" pitchFamily="34" charset="-122"/>
                 <a:cs typeface="Arial" pitchFamily="34" charset="-120"/>
               </a:rPr>
-              <a:t>Leaflet.js + Swisstopo WMTS, design vert ChronoPath</a:t>
-            </a:r>
-            <a:endParaRPr lang="en-US" sz="1267" dirty="0"/>
+              <a:t>Leaflet.js + </a:t>
+            </a:r>
+            <a:r>
+              <a:rPr lang="fr-FR" sz="1267" i="1" noProof="0" dirty="0" err="1">
+                <a:solidFill>
+                  <a:srgbClr val="6B7280"/>
+                </a:solidFill>
+                <a:latin typeface="Arial" pitchFamily="34" charset="0"/>
+                <a:ea typeface="Arial" pitchFamily="34" charset="-122"/>
+                <a:cs typeface="Arial" pitchFamily="34" charset="-120"/>
+              </a:rPr>
+              <a:t>Swisstopo</a:t>
+            </a:r>
+            <a:r>
+              <a:rPr lang="fr-FR" sz="1267" i="1" noProof="0" dirty="0">
+                <a:solidFill>
+                  <a:srgbClr val="6B7280"/>
+                </a:solidFill>
+                <a:latin typeface="Arial" pitchFamily="34" charset="0"/>
+                <a:ea typeface="Arial" pitchFamily="34" charset="-122"/>
+                <a:cs typeface="Arial" pitchFamily="34" charset="-120"/>
+              </a:rPr>
+              <a:t> WMTS</a:t>
+            </a:r>
+            <a:endParaRPr lang="fr-FR" sz="1267" noProof="0" dirty="0"/>
           </a:p>
         </p:txBody>
       </p:sp>
@@ -11812,7 +13082,7 @@
           <a:bodyPr/>
           <a:lstStyle/>
           <a:p>
-            <a:endParaRPr lang="fr-CH" sz="2400"/>
+            <a:endParaRPr lang="fr-FR" sz="2400" noProof="0" dirty="0"/>
           </a:p>
         </p:txBody>
       </p:sp>
@@ -11839,7 +13109,7 @@
           <a:bodyPr/>
           <a:lstStyle/>
           <a:p>
-            <a:endParaRPr lang="fr-CH" sz="2400"/>
+            <a:endParaRPr lang="fr-FR" sz="2400" noProof="0" dirty="0"/>
           </a:p>
         </p:txBody>
       </p:sp>
@@ -11866,7 +13136,7 @@
           <a:p>
             <a:pPr algn="ctr"/>
             <a:r>
-              <a:rPr lang="en-US" sz="1867" b="1" dirty="0">
+              <a:rPr lang="fr-FR" sz="1867" b="1" noProof="0" dirty="0">
                 <a:solidFill>
                   <a:srgbClr val="FFFFFF"/>
                 </a:solidFill>
@@ -11876,7 +13146,7 @@
               </a:rPr>
               <a:t>3</a:t>
             </a:r>
-            <a:endParaRPr lang="en-US" sz="1867" dirty="0"/>
+            <a:endParaRPr lang="fr-FR" sz="1867" noProof="0" dirty="0"/>
           </a:p>
         </p:txBody>
       </p:sp>
@@ -11902,7 +13172,7 @@
           <a:lstStyle/>
           <a:p>
             <a:r>
-              <a:rPr lang="en-US" sz="1533" b="1" dirty="0">
+              <a:rPr lang="fr-FR" sz="1533" b="1" noProof="0" dirty="0">
                 <a:solidFill>
                   <a:srgbClr val="1A1A2E"/>
                 </a:solidFill>
@@ -11912,7 +13182,7 @@
               </a:rPr>
               <a:t>Boutons &amp; commandes JS</a:t>
             </a:r>
-            <a:endParaRPr lang="en-US" sz="1533" dirty="0"/>
+            <a:endParaRPr lang="fr-FR" sz="1533" noProof="0" dirty="0"/>
           </a:p>
         </p:txBody>
       </p:sp>
@@ -11938,7 +13208,7 @@
           <a:lstStyle/>
           <a:p>
             <a:r>
-              <a:rPr lang="en-US" sz="1267" i="1" dirty="0">
+              <a:rPr lang="fr-FR" sz="1267" i="1" noProof="0" dirty="0">
                 <a:solidFill>
                   <a:srgbClr val="6B7280"/>
                 </a:solidFill>
@@ -11946,9 +13216,9 @@
                 <a:ea typeface="Arial" pitchFamily="34" charset="-122"/>
                 <a:cs typeface="Arial" pitchFamily="34" charset="-120"/>
               </a:rPr>
-              <a:t>6 fichiers JS modulaires — search, routing, create, app...</a:t>
-            </a:r>
-            <a:endParaRPr lang="en-US" sz="1267" dirty="0"/>
+              <a:t>6 fichiers JS modulaires</a:t>
+            </a:r>
+            <a:endParaRPr lang="fr-FR" sz="1267" noProof="0" dirty="0"/>
           </a:p>
         </p:txBody>
       </p:sp>
@@ -11980,7 +13250,7 @@
           <a:bodyPr/>
           <a:lstStyle/>
           <a:p>
-            <a:endParaRPr lang="fr-CH" sz="2400"/>
+            <a:endParaRPr lang="fr-FR" sz="2400" noProof="0" dirty="0"/>
           </a:p>
         </p:txBody>
       </p:sp>
@@ -12007,7 +13277,7 @@
           <a:bodyPr/>
           <a:lstStyle/>
           <a:p>
-            <a:endParaRPr lang="fr-CH" sz="2400"/>
+            <a:endParaRPr lang="fr-FR" sz="2400" noProof="0" dirty="0"/>
           </a:p>
         </p:txBody>
       </p:sp>
@@ -12034,7 +13304,7 @@
           <a:p>
             <a:pPr algn="ctr"/>
             <a:r>
-              <a:rPr lang="en-US" sz="1867" b="1" dirty="0">
+              <a:rPr lang="fr-FR" sz="1867" b="1" noProof="0" dirty="0">
                 <a:solidFill>
                   <a:srgbClr val="FFFFFF"/>
                 </a:solidFill>
@@ -12044,7 +13314,7 @@
               </a:rPr>
               <a:t>4</a:t>
             </a:r>
-            <a:endParaRPr lang="en-US" sz="1867" dirty="0"/>
+            <a:endParaRPr lang="fr-FR" sz="1867" noProof="0" dirty="0"/>
           </a:p>
         </p:txBody>
       </p:sp>
@@ -12070,7 +13340,7 @@
           <a:lstStyle/>
           <a:p>
             <a:r>
-              <a:rPr lang="en-US" sz="1533" b="1" dirty="0">
+              <a:rPr lang="fr-FR" sz="1533" b="1" noProof="0" dirty="0">
                 <a:solidFill>
                   <a:srgbClr val="1A1A2E"/>
                 </a:solidFill>
@@ -12080,7 +13350,7 @@
               </a:rPr>
               <a:t>Stockage Docker Desktop</a:t>
             </a:r>
-            <a:endParaRPr lang="en-US" sz="1533" dirty="0"/>
+            <a:endParaRPr lang="fr-FR" sz="1533" noProof="0" dirty="0"/>
           </a:p>
         </p:txBody>
       </p:sp>
@@ -12106,7 +13376,7 @@
           <a:lstStyle/>
           <a:p>
             <a:r>
-              <a:rPr lang="en-US" sz="1267" i="1" dirty="0">
+              <a:rPr lang="fr-FR" sz="1267" i="1" noProof="0" dirty="0">
                 <a:solidFill>
                   <a:srgbClr val="6B7280"/>
                 </a:solidFill>
@@ -12114,9 +13384,64 @@
                 <a:ea typeface="Arial" pitchFamily="34" charset="-122"/>
                 <a:cs typeface="Arial" pitchFamily="34" charset="-120"/>
               </a:rPr>
-              <a:t>PostgreSQL 15 + PostGIS + pgRouting dans conteneur gin_pgrouting</a:t>
-            </a:r>
-            <a:endParaRPr lang="en-US" sz="1267" dirty="0"/>
+              <a:t>PostgreSQL 15 + </a:t>
+            </a:r>
+            <a:r>
+              <a:rPr lang="fr-FR" sz="1267" i="1" noProof="0" dirty="0" err="1">
+                <a:solidFill>
+                  <a:srgbClr val="6B7280"/>
+                </a:solidFill>
+                <a:latin typeface="Arial" pitchFamily="34" charset="0"/>
+                <a:ea typeface="Arial" pitchFamily="34" charset="-122"/>
+                <a:cs typeface="Arial" pitchFamily="34" charset="-120"/>
+              </a:rPr>
+              <a:t>PostGIS</a:t>
+            </a:r>
+            <a:r>
+              <a:rPr lang="fr-FR" sz="1267" i="1" noProof="0" dirty="0">
+                <a:solidFill>
+                  <a:srgbClr val="6B7280"/>
+                </a:solidFill>
+                <a:latin typeface="Arial" pitchFamily="34" charset="0"/>
+                <a:ea typeface="Arial" pitchFamily="34" charset="-122"/>
+                <a:cs typeface="Arial" pitchFamily="34" charset="-120"/>
+              </a:rPr>
+              <a:t> + </a:t>
+            </a:r>
+            <a:r>
+              <a:rPr lang="fr-FR" sz="1267" i="1" noProof="0" dirty="0" err="1">
+                <a:solidFill>
+                  <a:srgbClr val="6B7280"/>
+                </a:solidFill>
+                <a:latin typeface="Arial" pitchFamily="34" charset="0"/>
+                <a:ea typeface="Arial" pitchFamily="34" charset="-122"/>
+                <a:cs typeface="Arial" pitchFamily="34" charset="-120"/>
+              </a:rPr>
+              <a:t>pgRouting</a:t>
+            </a:r>
+            <a:r>
+              <a:rPr lang="fr-FR" sz="1267" i="1" noProof="0" dirty="0">
+                <a:solidFill>
+                  <a:srgbClr val="6B7280"/>
+                </a:solidFill>
+                <a:latin typeface="Arial" pitchFamily="34" charset="0"/>
+                <a:ea typeface="Arial" pitchFamily="34" charset="-122"/>
+                <a:cs typeface="Arial" pitchFamily="34" charset="-120"/>
+              </a:rPr>
+              <a:t> dans conteneur </a:t>
+            </a:r>
+            <a:r>
+              <a:rPr lang="fr-FR" sz="1267" i="1" noProof="0" dirty="0" err="1">
+                <a:solidFill>
+                  <a:srgbClr val="6B7280"/>
+                </a:solidFill>
+                <a:latin typeface="Arial" pitchFamily="34" charset="0"/>
+                <a:ea typeface="Arial" pitchFamily="34" charset="-122"/>
+                <a:cs typeface="Arial" pitchFamily="34" charset="-120"/>
+              </a:rPr>
+              <a:t>gin_pgrouting</a:t>
+            </a:r>
+            <a:endParaRPr lang="fr-FR" sz="1267" noProof="0" dirty="0"/>
           </a:p>
         </p:txBody>
       </p:sp>
@@ -12148,7 +13473,7 @@
           <a:bodyPr/>
           <a:lstStyle/>
           <a:p>
-            <a:endParaRPr lang="fr-CH" sz="2400"/>
+            <a:endParaRPr lang="fr-FR" sz="2400" noProof="0" dirty="0"/>
           </a:p>
         </p:txBody>
       </p:sp>
@@ -12175,7 +13500,7 @@
           <a:bodyPr/>
           <a:lstStyle/>
           <a:p>
-            <a:endParaRPr lang="fr-CH" sz="2400"/>
+            <a:endParaRPr lang="fr-FR" sz="2400" noProof="0" dirty="0"/>
           </a:p>
         </p:txBody>
       </p:sp>
@@ -12202,7 +13527,7 @@
           <a:p>
             <a:pPr algn="ctr"/>
             <a:r>
-              <a:rPr lang="en-US" sz="1867" b="1" dirty="0">
+              <a:rPr lang="fr-FR" sz="1867" b="1" noProof="0" dirty="0">
                 <a:solidFill>
                   <a:srgbClr val="FFFFFF"/>
                 </a:solidFill>
@@ -12212,7 +13537,7 @@
               </a:rPr>
               <a:t>5</a:t>
             </a:r>
-            <a:endParaRPr lang="en-US" sz="1867" dirty="0"/>
+            <a:endParaRPr lang="fr-FR" sz="1867" noProof="0" dirty="0"/>
           </a:p>
         </p:txBody>
       </p:sp>
@@ -12238,7 +13563,7 @@
           <a:lstStyle/>
           <a:p>
             <a:r>
-              <a:rPr lang="en-US" sz="1533" b="1" dirty="0">
+              <a:rPr lang="fr-FR" sz="1533" b="1" noProof="0" dirty="0">
                 <a:solidFill>
                   <a:srgbClr val="1A1A2E"/>
                 </a:solidFill>
@@ -12246,9 +13571,31 @@
                 <a:ea typeface="Arial" pitchFamily="34" charset="-122"/>
                 <a:cs typeface="Arial" pitchFamily="34" charset="-120"/>
               </a:rPr>
-              <a:t>Imports pgRouting &amp; tests</a:t>
-            </a:r>
-            <a:endParaRPr lang="en-US" sz="1533" dirty="0"/>
+              <a:t>Imports </a:t>
+            </a:r>
+            <a:r>
+              <a:rPr lang="fr-FR" sz="1533" b="1" noProof="0" dirty="0" err="1">
+                <a:solidFill>
+                  <a:srgbClr val="1A1A2E"/>
+                </a:solidFill>
+                <a:latin typeface="Arial" pitchFamily="34" charset="0"/>
+                <a:ea typeface="Arial" pitchFamily="34" charset="-122"/>
+                <a:cs typeface="Arial" pitchFamily="34" charset="-120"/>
+              </a:rPr>
+              <a:t>pgRouting</a:t>
+            </a:r>
+            <a:r>
+              <a:rPr lang="fr-FR" sz="1533" b="1" noProof="0" dirty="0">
+                <a:solidFill>
+                  <a:srgbClr val="1A1A2E"/>
+                </a:solidFill>
+                <a:latin typeface="Arial" pitchFamily="34" charset="0"/>
+                <a:ea typeface="Arial" pitchFamily="34" charset="-122"/>
+                <a:cs typeface="Arial" pitchFamily="34" charset="-120"/>
+              </a:rPr>
+              <a:t> &amp; tests</a:t>
+            </a:r>
+            <a:endParaRPr lang="fr-FR" sz="1533" noProof="0" dirty="0"/>
           </a:p>
         </p:txBody>
       </p:sp>
@@ -12274,7 +13621,7 @@
           <a:lstStyle/>
           <a:p>
             <a:r>
-              <a:rPr lang="en-US" sz="1267" i="1" dirty="0">
+              <a:rPr lang="fr-FR" sz="1267" i="1" noProof="0" dirty="0">
                 <a:solidFill>
                   <a:srgbClr val="6B7280"/>
                 </a:solidFill>
@@ -12282,9 +13629,9 @@
                 <a:ea typeface="Arial" pitchFamily="34" charset="-122"/>
                 <a:cs typeface="Arial" pitchFamily="34" charset="-120"/>
               </a:rPr>
-              <a:t>Dijkstra sur graphe OSM réel — boucles triangulaires calibrées</a:t>
-            </a:r>
-            <a:endParaRPr lang="en-US" sz="1267" dirty="0"/>
+              <a:t>Dijkstra sur graphe OSM réel </a:t>
+            </a:r>
+            <a:endParaRPr lang="fr-FR" sz="1267" noProof="0" dirty="0"/>
           </a:p>
         </p:txBody>
       </p:sp>
@@ -12336,7 +13683,7 @@
           </a:lstStyle>
           <a:p>
             <a:r>
-              <a:rPr lang="en-US" dirty="0"/>
+              <a:rPr lang="fr-FR" noProof="0" dirty="0"/>
               <a:t>Structure du code</a:t>
             </a:r>
           </a:p>
@@ -12431,7 +13778,7 @@
           <a:lstStyle/>
           <a:p>
             <a:pPr algn="ctr"/>
-            <a:endParaRPr lang="en-US"/>
+            <a:endParaRPr lang="fr-FR" noProof="0" dirty="0"/>
           </a:p>
         </p:txBody>
       </p:sp>
@@ -12464,7 +13811,7 @@
           <a:lstStyle/>
           <a:p>
             <a:r>
-              <a:rPr lang="en-US" kern="1200" dirty="0">
+              <a:rPr lang="fr-FR" kern="1200" noProof="0" dirty="0">
                 <a:solidFill>
                   <a:schemeClr val="tx1"/>
                 </a:solidFill>
@@ -12509,7 +13856,7 @@
               <a:buNone/>
             </a:pPr>
             <a:r>
-              <a:rPr lang="en-US" sz="2400" kern="1200" dirty="0">
+              <a:rPr lang="fr-FR" sz="2400" kern="1200" noProof="0" dirty="0">
                 <a:solidFill>
                   <a:schemeClr val="tx1"/>
                 </a:solidFill>
@@ -12520,21 +13867,21 @@
               <a:t>Liens :</a:t>
             </a:r>
             <a:r>
-              <a:rPr lang="en-US" sz="2400" dirty="0"/>
+              <a:rPr lang="fr-FR" sz="2400" noProof="0" dirty="0"/>
               <a:t> </a:t>
             </a:r>
             <a:r>
-              <a:rPr lang="en-US" sz="2400" dirty="0">
+              <a:rPr lang="fr-FR" sz="2400" noProof="0" dirty="0">
                 <a:hlinkClick r:id="rId2"/>
               </a:rPr>
               <a:t>http://localhost:8080</a:t>
             </a:r>
             <a:r>
-              <a:rPr lang="en-US" sz="2400" dirty="0"/>
+              <a:rPr lang="fr-FR" sz="2400" noProof="0" dirty="0"/>
               <a:t> </a:t>
             </a:r>
             <a:r>
-              <a:rPr lang="en-US" sz="2400" kern="1200" dirty="0">
+              <a:rPr lang="fr-FR" sz="2400" kern="1200" noProof="0" dirty="0">
                 <a:solidFill>
                   <a:schemeClr val="tx1"/>
                 </a:solidFill>
@@ -12648,7 +13995,7 @@
           <a:lstStyle/>
           <a:p>
             <a:r>
-              <a:rPr lang="en-US" sz="3600" b="1" dirty="0" err="1">
+              <a:rPr lang="fr-FR" sz="3600" b="1" noProof="0" dirty="0">
                 <a:solidFill>
                   <a:srgbClr val="FFFFFF"/>
                 </a:solidFill>
@@ -12658,7 +14005,7 @@
               </a:rPr>
               <a:t>rencontrées</a:t>
             </a:r>
-            <a:endParaRPr lang="en-US" sz="3600" dirty="0"/>
+            <a:endParaRPr lang="fr-FR" sz="3600" noProof="0" dirty="0"/>
           </a:p>
         </p:txBody>
       </p:sp>
@@ -12697,7 +14044,7 @@
           <a:bodyPr/>
           <a:lstStyle/>
           <a:p>
-            <a:endParaRPr lang="fr-CH" sz="2400"/>
+            <a:endParaRPr lang="fr-FR" sz="2400" noProof="0" dirty="0"/>
           </a:p>
         </p:txBody>
       </p:sp>
@@ -12724,7 +14071,7 @@
           <a:bodyPr/>
           <a:lstStyle/>
           <a:p>
-            <a:endParaRPr lang="fr-CH" sz="2400"/>
+            <a:endParaRPr lang="fr-FR" sz="2400" noProof="0" dirty="0"/>
           </a:p>
         </p:txBody>
       </p:sp>
@@ -12750,7 +14097,7 @@
           <a:lstStyle/>
           <a:p>
             <a:r>
-              <a:rPr lang="en-US" sz="1867" b="1" dirty="0" err="1">
+              <a:rPr lang="fr-FR" sz="1867" b="1" noProof="0" dirty="0">
                 <a:solidFill>
                   <a:srgbClr val="FFFFFF"/>
                 </a:solidFill>
@@ -12760,7 +14107,7 @@
               </a:rPr>
               <a:t>Difficultés</a:t>
             </a:r>
-            <a:endParaRPr lang="en-US" sz="1867" dirty="0"/>
+            <a:endParaRPr lang="fr-FR" sz="1867" noProof="0" dirty="0"/>
           </a:p>
         </p:txBody>
       </p:sp>
@@ -12792,7 +14139,7 @@
           <a:bodyPr/>
           <a:lstStyle/>
           <a:p>
-            <a:endParaRPr lang="fr-CH" sz="2400"/>
+            <a:endParaRPr lang="fr-FR" sz="2400" noProof="0" dirty="0"/>
           </a:p>
         </p:txBody>
       </p:sp>
@@ -12818,7 +14165,7 @@
           <a:lstStyle/>
           <a:p>
             <a:r>
-              <a:rPr lang="en-US" sz="1600" b="1" dirty="0">
+              <a:rPr lang="fr-FR" sz="1600" b="1" noProof="0" dirty="0" err="1">
                 <a:solidFill>
                   <a:srgbClr val="DC2626"/>
                 </a:solidFill>
@@ -12828,7 +14175,7 @@
               </a:rPr>
               <a:t>pgRouting</a:t>
             </a:r>
-            <a:endParaRPr lang="en-US" sz="1600" dirty="0"/>
+            <a:endParaRPr lang="fr-FR" sz="1600" noProof="0" dirty="0"/>
           </a:p>
         </p:txBody>
       </p:sp>
@@ -12854,7 +14201,7 @@
           <a:lstStyle/>
           <a:p>
             <a:r>
-              <a:rPr lang="en-US" sz="1400" dirty="0">
+              <a:rPr lang="fr-FR" sz="1400" noProof="0" dirty="0">
                 <a:solidFill>
                   <a:srgbClr val="1A1A2E"/>
                 </a:solidFill>
@@ -12864,7 +14211,7 @@
               </a:rPr>
               <a:t>Configuration Docker, import OSM, requêtes Dijkstra</a:t>
             </a:r>
-            <a:endParaRPr lang="en-US" sz="1400" dirty="0"/>
+            <a:endParaRPr lang="fr-FR" sz="1400" noProof="0" dirty="0"/>
           </a:p>
         </p:txBody>
       </p:sp>
@@ -12896,7 +14243,7 @@
           <a:bodyPr/>
           <a:lstStyle/>
           <a:p>
-            <a:endParaRPr lang="fr-CH" sz="2400"/>
+            <a:endParaRPr lang="fr-FR" sz="2400" noProof="0" dirty="0"/>
           </a:p>
         </p:txBody>
       </p:sp>
@@ -12922,7 +14269,7 @@
           <a:lstStyle/>
           <a:p>
             <a:r>
-              <a:rPr lang="en-US" sz="1600" b="1" dirty="0">
+              <a:rPr lang="fr-FR" sz="1600" b="1" noProof="0" dirty="0">
                 <a:solidFill>
                   <a:srgbClr val="DC2626"/>
                 </a:solidFill>
@@ -12932,7 +14279,7 @@
               </a:rPr>
               <a:t>Formules sportives</a:t>
             </a:r>
-            <a:endParaRPr lang="en-US" sz="1600" dirty="0"/>
+            <a:endParaRPr lang="fr-FR" sz="1600" noProof="0" dirty="0"/>
           </a:p>
         </p:txBody>
       </p:sp>
@@ -12958,7 +14305,7 @@
           <a:lstStyle/>
           <a:p>
             <a:r>
-              <a:rPr lang="en-US" sz="1400" dirty="0">
+              <a:rPr lang="fr-FR" sz="1400" noProof="0" dirty="0">
                 <a:solidFill>
                   <a:srgbClr val="1A1A2E"/>
                 </a:solidFill>
@@ -12966,9 +14313,9 @@
                 <a:ea typeface="Arial" pitchFamily="34" charset="-122"/>
                 <a:cs typeface="Arial" pitchFamily="34" charset="-120"/>
               </a:rPr>
-              <a:t>Calibrage FTP/VAP/Naismith — ajustements itératifs</a:t>
-            </a:r>
-            <a:endParaRPr lang="en-US" sz="1400" dirty="0"/>
+              <a:t>Calibrage FTP/VAP/Naismith - ajustements itératifs</a:t>
+            </a:r>
+            <a:endParaRPr lang="fr-FR" sz="1400" noProof="0" dirty="0"/>
           </a:p>
         </p:txBody>
       </p:sp>
@@ -13000,7 +14347,7 @@
           <a:bodyPr/>
           <a:lstStyle/>
           <a:p>
-            <a:endParaRPr lang="fr-CH" sz="2400"/>
+            <a:endParaRPr lang="fr-FR" sz="2400" noProof="0" dirty="0"/>
           </a:p>
         </p:txBody>
       </p:sp>
@@ -13026,7 +14373,7 @@
           <a:lstStyle/>
           <a:p>
             <a:r>
-              <a:rPr lang="en-US" sz="1600" b="1" dirty="0">
+              <a:rPr lang="fr-FR" sz="1600" b="1" noProof="0" dirty="0">
                 <a:solidFill>
                   <a:srgbClr val="DC2626"/>
                 </a:solidFill>
@@ -13036,7 +14383,7 @@
               </a:rPr>
               <a:t>Manque de temps</a:t>
             </a:r>
-            <a:endParaRPr lang="en-US" sz="1600" dirty="0"/>
+            <a:endParaRPr lang="fr-FR" sz="1600" noProof="0" dirty="0"/>
           </a:p>
         </p:txBody>
       </p:sp>
@@ -13062,7 +14409,7 @@
           <a:lstStyle/>
           <a:p>
             <a:r>
-              <a:rPr lang="en-US" sz="1400" dirty="0">
+              <a:rPr lang="fr-FR" sz="1400" noProof="0" dirty="0">
                 <a:solidFill>
                   <a:srgbClr val="1A1A2E"/>
                 </a:solidFill>
@@ -13072,7 +14419,7 @@
               </a:rPr>
               <a:t>Nombreuses fonctionnalités à implémenter en 5 semaines</a:t>
             </a:r>
-            <a:endParaRPr lang="en-US" sz="1400" dirty="0"/>
+            <a:endParaRPr lang="fr-FR" sz="1400" noProof="0" dirty="0"/>
           </a:p>
         </p:txBody>
       </p:sp>
@@ -13111,7 +14458,7 @@
           <a:bodyPr/>
           <a:lstStyle/>
           <a:p>
-            <a:endParaRPr lang="fr-CH" sz="2400"/>
+            <a:endParaRPr lang="fr-FR" sz="2400" noProof="0" dirty="0"/>
           </a:p>
         </p:txBody>
       </p:sp>
@@ -13138,7 +14485,7 @@
           <a:bodyPr/>
           <a:lstStyle/>
           <a:p>
-            <a:endParaRPr lang="fr-CH" sz="2400"/>
+            <a:endParaRPr lang="fr-FR" sz="2400" noProof="0" dirty="0"/>
           </a:p>
         </p:txBody>
       </p:sp>
@@ -13164,7 +14511,7 @@
           <a:lstStyle/>
           <a:p>
             <a:r>
-              <a:rPr lang="en-US" sz="1867" b="1" dirty="0" err="1">
+              <a:rPr lang="fr-FR" sz="1867" b="1" noProof="0" dirty="0">
                 <a:solidFill>
                   <a:srgbClr val="FFFFFF"/>
                 </a:solidFill>
@@ -13174,7 +14521,7 @@
               </a:rPr>
               <a:t>Facilités</a:t>
             </a:r>
-            <a:endParaRPr lang="en-US" sz="1867" dirty="0"/>
+            <a:endParaRPr lang="fr-FR" sz="1867" noProof="0" dirty="0"/>
           </a:p>
         </p:txBody>
       </p:sp>
@@ -13206,7 +14553,7 @@
           <a:bodyPr/>
           <a:lstStyle/>
           <a:p>
-            <a:endParaRPr lang="fr-CH" sz="2400"/>
+            <a:endParaRPr lang="fr-FR" sz="2400" noProof="0" dirty="0"/>
           </a:p>
         </p:txBody>
       </p:sp>
@@ -13232,7 +14579,7 @@
           <a:lstStyle/>
           <a:p>
             <a:r>
-              <a:rPr lang="en-US" sz="1600" b="1" dirty="0">
+              <a:rPr lang="fr-FR" sz="1600" b="1" noProof="0" dirty="0">
                 <a:solidFill>
                   <a:srgbClr val="2D6A4F"/>
                 </a:solidFill>
@@ -13242,7 +14589,7 @@
               </a:rPr>
               <a:t>Frontend (HTML/CSS)</a:t>
             </a:r>
-            <a:endParaRPr lang="en-US" sz="1600" dirty="0"/>
+            <a:endParaRPr lang="fr-FR" sz="1600" noProof="0" dirty="0"/>
           </a:p>
         </p:txBody>
       </p:sp>
@@ -13268,7 +14615,7 @@
           <a:lstStyle/>
           <a:p>
             <a:r>
-              <a:rPr lang="en-US" sz="1400" dirty="0">
+              <a:rPr lang="fr-FR" sz="1400" noProof="0" dirty="0">
                 <a:solidFill>
                   <a:srgbClr val="1A1A2E"/>
                 </a:solidFill>
@@ -13276,9 +14623,31 @@
                 <a:ea typeface="Arial" pitchFamily="34" charset="-122"/>
                 <a:cs typeface="Arial" pitchFamily="34" charset="-120"/>
               </a:rPr>
-              <a:t>Leaflet.js bien documenté, API Swisstopo simple et gratuite</a:t>
-            </a:r>
-            <a:endParaRPr lang="en-US" sz="1400" dirty="0"/>
+              <a:t>Leaflet.js bien documenté, API </a:t>
+            </a:r>
+            <a:r>
+              <a:rPr lang="fr-FR" sz="1400" noProof="0" dirty="0" err="1">
+                <a:solidFill>
+                  <a:srgbClr val="1A1A2E"/>
+                </a:solidFill>
+                <a:latin typeface="Arial" pitchFamily="34" charset="0"/>
+                <a:ea typeface="Arial" pitchFamily="34" charset="-122"/>
+                <a:cs typeface="Arial" pitchFamily="34" charset="-120"/>
+              </a:rPr>
+              <a:t>Swisstopo</a:t>
+            </a:r>
+            <a:r>
+              <a:rPr lang="fr-FR" sz="1400" noProof="0" dirty="0">
+                <a:solidFill>
+                  <a:srgbClr val="1A1A2E"/>
+                </a:solidFill>
+                <a:latin typeface="Arial" pitchFamily="34" charset="0"/>
+                <a:ea typeface="Arial" pitchFamily="34" charset="-122"/>
+                <a:cs typeface="Arial" pitchFamily="34" charset="-120"/>
+              </a:rPr>
+              <a:t> simple et gratuite</a:t>
+            </a:r>
+            <a:endParaRPr lang="fr-FR" sz="1400" noProof="0" dirty="0"/>
           </a:p>
         </p:txBody>
       </p:sp>
@@ -13310,7 +14679,7 @@
           <a:bodyPr/>
           <a:lstStyle/>
           <a:p>
-            <a:endParaRPr lang="fr-CH" sz="2400"/>
+            <a:endParaRPr lang="fr-FR" sz="2400" noProof="0" dirty="0"/>
           </a:p>
         </p:txBody>
       </p:sp>
@@ -13336,7 +14705,7 @@
           <a:lstStyle/>
           <a:p>
             <a:r>
-              <a:rPr lang="en-US" sz="1600" b="1" dirty="0">
+              <a:rPr lang="fr-FR" sz="1600" b="1" noProof="0" dirty="0">
                 <a:solidFill>
                   <a:srgbClr val="2D6A4F"/>
                 </a:solidFill>
@@ -13344,9 +14713,9 @@
                 <a:ea typeface="Arial" pitchFamily="34" charset="-122"/>
                 <a:cs typeface="Arial" pitchFamily="34" charset="-120"/>
               </a:rPr>
-              <a:t>Go (Backend)</a:t>
-            </a:r>
-            <a:endParaRPr lang="en-US" sz="1600" dirty="0"/>
+              <a:t>Backend (Go)</a:t>
+            </a:r>
+            <a:endParaRPr lang="fr-FR" sz="1600" noProof="0" dirty="0"/>
           </a:p>
         </p:txBody>
       </p:sp>
@@ -13372,7 +14741,7 @@
           <a:lstStyle/>
           <a:p>
             <a:r>
-              <a:rPr lang="en-US" sz="1400" dirty="0">
+              <a:rPr lang="fr-FR" sz="1400" noProof="0" dirty="0">
                 <a:solidFill>
                   <a:srgbClr val="1A1A2E"/>
                 </a:solidFill>
@@ -13380,10 +14749,10 @@
                 <a:ea typeface="Arial" pitchFamily="34" charset="-122"/>
                 <a:cs typeface="Arial" pitchFamily="34" charset="-120"/>
               </a:rPr>
-              <a:t>Gin framework intuitif, performances </a:t>
-            </a:r>
-            <a:r>
-              <a:rPr lang="en-US" sz="1400" dirty="0" err="1">
+              <a:t>Gin </a:t>
+            </a:r>
+            <a:r>
+              <a:rPr lang="fr-FR" sz="1400" noProof="0" dirty="0" err="1">
                 <a:solidFill>
                   <a:srgbClr val="1A1A2E"/>
                 </a:solidFill>
@@ -13391,9 +14760,20 @@
                 <a:ea typeface="Arial" pitchFamily="34" charset="-122"/>
                 <a:cs typeface="Arial" pitchFamily="34" charset="-120"/>
               </a:rPr>
-              <a:t>excellentes</a:t>
-            </a:r>
-            <a:endParaRPr lang="en-US" sz="1400" dirty="0"/>
+              <a:t>framework</a:t>
+            </a:r>
+            <a:r>
+              <a:rPr lang="fr-FR" sz="1400" noProof="0" dirty="0">
+                <a:solidFill>
+                  <a:srgbClr val="1A1A2E"/>
+                </a:solidFill>
+                <a:latin typeface="Arial" pitchFamily="34" charset="0"/>
+                <a:ea typeface="Arial" pitchFamily="34" charset="-122"/>
+                <a:cs typeface="Arial" pitchFamily="34" charset="-120"/>
+              </a:rPr>
+              <a:t> intuitif, performances excellentes</a:t>
+            </a:r>
+            <a:endParaRPr lang="fr-FR" sz="1400" noProof="0" dirty="0"/>
           </a:p>
         </p:txBody>
       </p:sp>
@@ -13445,18 +14825,9 @@
           </a:lstStyle>
           <a:p>
             <a:r>
-              <a:rPr lang="en-US" dirty="0" err="1"/>
-              <a:t>Difficultés</a:t>
-            </a:r>
-            <a:r>
-              <a:rPr lang="en-US" dirty="0"/>
-              <a:t> - </a:t>
-            </a:r>
-            <a:r>
-              <a:rPr lang="en-US" dirty="0" err="1"/>
-              <a:t>Facilités</a:t>
-            </a:r>
-            <a:endParaRPr lang="en-US" dirty="0"/>
+              <a:rPr lang="fr-FR" noProof="0" dirty="0"/>
+              <a:t>Difficultés - Facilités</a:t>
+            </a:r>
           </a:p>
         </p:txBody>
       </p:sp>
@@ -13507,7 +14878,7 @@
           <a:lstStyle/>
           <a:p>
             <a:r>
-              <a:rPr lang="en-US" sz="3600" b="1" dirty="0">
+              <a:rPr lang="fr-FR" sz="3600" b="1" noProof="0" dirty="0">
                 <a:solidFill>
                   <a:srgbClr val="FFFFFF"/>
                 </a:solidFill>
@@ -13517,7 +14888,7 @@
               </a:rPr>
               <a:t>06 — Test de parcours</a:t>
             </a:r>
-            <a:endParaRPr lang="en-US" sz="3600" dirty="0"/>
+            <a:endParaRPr lang="fr-FR" sz="3600" noProof="0" dirty="0"/>
           </a:p>
         </p:txBody>
       </p:sp>
@@ -13556,7 +14927,7 @@
           <a:bodyPr/>
           <a:lstStyle/>
           <a:p>
-            <a:endParaRPr lang="fr-CH" sz="2400"/>
+            <a:endParaRPr lang="fr-FR" sz="2400" noProof="0" dirty="0"/>
           </a:p>
         </p:txBody>
       </p:sp>
@@ -13583,7 +14954,7 @@
           <a:bodyPr/>
           <a:lstStyle/>
           <a:p>
-            <a:endParaRPr lang="fr-CH" sz="2400"/>
+            <a:endParaRPr lang="fr-FR" sz="2400" noProof="0" dirty="0"/>
           </a:p>
         </p:txBody>
       </p:sp>
@@ -13609,7 +14980,7 @@
           <a:lstStyle/>
           <a:p>
             <a:r>
-              <a:rPr lang="en-US" sz="1867" b="1" dirty="0">
+              <a:rPr lang="fr-FR" sz="1867" b="1" noProof="0" dirty="0">
                 <a:solidFill>
                   <a:srgbClr val="FFFFFF"/>
                 </a:solidFill>
@@ -13619,7 +14990,7 @@
               </a:rPr>
               <a:t>À vélo</a:t>
             </a:r>
-            <a:endParaRPr lang="en-US" sz="1867" dirty="0"/>
+            <a:endParaRPr lang="fr-FR" sz="1867" noProof="0" dirty="0"/>
           </a:p>
         </p:txBody>
       </p:sp>
@@ -13645,7 +15016,7 @@
           <a:lstStyle/>
           <a:p>
             <a:r>
-              <a:rPr lang="en-US" sz="1600" b="1" dirty="0">
+              <a:rPr lang="fr-FR" sz="1600" b="1" noProof="0" dirty="0">
                 <a:solidFill>
                   <a:srgbClr val="2D6A4F"/>
                 </a:solidFill>
@@ -13657,7 +15028,7 @@
 </a:t>
             </a:r>
             <a:r>
-              <a:rPr lang="en-US" sz="1600" dirty="0">
+              <a:rPr lang="fr-FR" sz="1600" noProof="0" dirty="0">
                 <a:solidFill>
                   <a:srgbClr val="1A1A2E"/>
                 </a:solidFill>
@@ -13671,7 +15042,7 @@
 </a:t>
             </a:r>
             <a:r>
-              <a:rPr lang="en-US" sz="1600" b="1" dirty="0">
+              <a:rPr lang="fr-FR" sz="1600" b="1" noProof="0" dirty="0">
                 <a:solidFill>
                   <a:srgbClr val="2D6A4F"/>
                 </a:solidFill>
@@ -13679,9 +15050,45 @@
                 <a:ea typeface="Arial" pitchFamily="34" charset="-122"/>
                 <a:cs typeface="Arial" pitchFamily="34" charset="-120"/>
               </a:rPr>
-              <a:t>Estimation app : 3h51 </a:t>
-            </a:r>
-            <a:endParaRPr lang="en-US" sz="1600" dirty="0"/>
+              <a:t>Estimation app : 3h51</a:t>
+            </a:r>
+          </a:p>
+          <a:p>
+            <a:endParaRPr lang="fr-FR" sz="1600" b="1" noProof="0" dirty="0">
+              <a:solidFill>
+                <a:srgbClr val="2D6A4F"/>
+              </a:solidFill>
+              <a:latin typeface="Arial" pitchFamily="34" charset="0"/>
+              <a:ea typeface="Arial" pitchFamily="34" charset="-122"/>
+              <a:cs typeface="Arial" pitchFamily="34" charset="-120"/>
+            </a:endParaRPr>
+          </a:p>
+          <a:p>
+            <a:r>
+              <a:rPr lang="fr-FR" sz="1600" noProof="0" dirty="0">
+                <a:latin typeface="Arial" pitchFamily="34" charset="0"/>
+                <a:ea typeface="Arial" pitchFamily="34" charset="-122"/>
+                <a:cs typeface="Arial" pitchFamily="34" charset="-120"/>
+              </a:rPr>
+              <a:t>Estimation Google </a:t>
+            </a:r>
+            <a:r>
+              <a:rPr lang="fr-FR" sz="1600" noProof="0" dirty="0" err="1">
+                <a:latin typeface="Arial" pitchFamily="34" charset="0"/>
+                <a:ea typeface="Arial" pitchFamily="34" charset="-122"/>
+                <a:cs typeface="Arial" pitchFamily="34" charset="-120"/>
+              </a:rPr>
+              <a:t>Maps</a:t>
+            </a:r>
+            <a:r>
+              <a:rPr lang="fr-FR" sz="1600" noProof="0" dirty="0">
+                <a:latin typeface="Arial" pitchFamily="34" charset="0"/>
+                <a:ea typeface="Arial" pitchFamily="34" charset="-122"/>
+                <a:cs typeface="Arial" pitchFamily="34" charset="-120"/>
+              </a:rPr>
+              <a:t> : 5h20  </a:t>
+            </a:r>
+            <a:endParaRPr lang="fr-FR" sz="1600" noProof="0" dirty="0"/>
           </a:p>
         </p:txBody>
       </p:sp>
@@ -13713,7 +15120,7 @@
           <a:bodyPr/>
           <a:lstStyle/>
           <a:p>
-            <a:endParaRPr lang="fr-CH" sz="2400"/>
+            <a:endParaRPr lang="fr-FR" sz="2400" noProof="0" dirty="0"/>
           </a:p>
         </p:txBody>
       </p:sp>
@@ -13739,7 +15146,7 @@
           <a:lstStyle/>
           <a:p>
             <a:r>
-              <a:rPr lang="en-US" sz="1333" i="1" dirty="0">
+              <a:rPr lang="fr-FR" sz="1333" i="1" noProof="0" dirty="0">
                 <a:solidFill>
                   <a:srgbClr val="2D6A4F"/>
                 </a:solidFill>
@@ -13749,11 +15156,11 @@
               </a:rPr>
               <a:t>Algorithme calibré avec facteur sinuosité 2.6</a:t>
             </a:r>
-            <a:endParaRPr lang="en-US" sz="1333" dirty="0"/>
-          </a:p>
-          <a:p>
-            <a:r>
-              <a:rPr lang="en-US" sz="1333" i="1" dirty="0">
+            <a:endParaRPr lang="fr-FR" sz="1333" noProof="0" dirty="0"/>
+          </a:p>
+          <a:p>
+            <a:r>
+              <a:rPr lang="fr-FR" sz="1333" i="1" noProof="0" dirty="0">
                 <a:solidFill>
                   <a:srgbClr val="2D6A4F"/>
                 </a:solidFill>
@@ -13763,7 +15170,7 @@
               </a:rPr>
               <a:t>vitesse = 8 + FTP × 6.5 km/h</a:t>
             </a:r>
-            <a:endParaRPr lang="en-US" sz="1333" dirty="0"/>
+            <a:endParaRPr lang="fr-FR" sz="1333" noProof="0" dirty="0"/>
           </a:p>
         </p:txBody>
       </p:sp>
@@ -13802,7 +15209,7 @@
           <a:bodyPr/>
           <a:lstStyle/>
           <a:p>
-            <a:endParaRPr lang="fr-CH" sz="2400"/>
+            <a:endParaRPr lang="fr-FR" sz="2400" noProof="0" dirty="0"/>
           </a:p>
         </p:txBody>
       </p:sp>
@@ -13829,7 +15236,7 @@
           <a:bodyPr/>
           <a:lstStyle/>
           <a:p>
-            <a:endParaRPr lang="fr-CH" sz="2400"/>
+            <a:endParaRPr lang="fr-FR" sz="2400" noProof="0" dirty="0"/>
           </a:p>
         </p:txBody>
       </p:sp>
@@ -13855,7 +15262,7 @@
           <a:lstStyle/>
           <a:p>
             <a:r>
-              <a:rPr lang="en-US" sz="1867" b="1" dirty="0">
+              <a:rPr lang="fr-FR" sz="1867" b="1" noProof="0" dirty="0">
                 <a:solidFill>
                   <a:srgbClr val="FFFFFF"/>
                 </a:solidFill>
@@ -13865,7 +15272,7 @@
               </a:rPr>
               <a:t>En course à pied</a:t>
             </a:r>
-            <a:endParaRPr lang="en-US" sz="1867" dirty="0"/>
+            <a:endParaRPr lang="fr-FR" sz="1867" noProof="0" dirty="0"/>
           </a:p>
         </p:txBody>
       </p:sp>
@@ -13891,7 +15298,7 @@
           <a:lstStyle/>
           <a:p>
             <a:r>
-              <a:rPr lang="en-US" sz="1600" b="1" dirty="0">
+              <a:rPr lang="fr-FR" sz="1600" b="1" noProof="0" dirty="0">
                 <a:solidFill>
                   <a:srgbClr val="DC2626"/>
                 </a:solidFill>
@@ -13903,7 +15310,7 @@
 </a:t>
             </a:r>
             <a:r>
-              <a:rPr lang="en-US" sz="1600" dirty="0">
+              <a:rPr lang="fr-FR" sz="1600" noProof="0" dirty="0">
                 <a:solidFill>
                   <a:srgbClr val="1A1A2E"/>
                 </a:solidFill>
@@ -13917,7 +15324,7 @@
 </a:t>
             </a:r>
             <a:r>
-              <a:rPr lang="en-US" sz="1600" b="1" dirty="0">
+              <a:rPr lang="fr-FR" sz="1600" b="1" noProof="0" dirty="0">
                 <a:solidFill>
                   <a:srgbClr val="DC2626"/>
                 </a:solidFill>
@@ -13925,9 +15332,9 @@
                 <a:ea typeface="Arial" pitchFamily="34" charset="-122"/>
                 <a:cs typeface="Arial" pitchFamily="34" charset="-120"/>
               </a:rPr>
-              <a:t>Estimation app : ~52 min </a:t>
-            </a:r>
-            <a:endParaRPr lang="en-US" sz="1600" dirty="0"/>
+              <a:t>Estimation app : ~53 min</a:t>
+            </a:r>
+            <a:endParaRPr lang="fr-FR" sz="1600" noProof="0" dirty="0"/>
           </a:p>
         </p:txBody>
       </p:sp>
@@ -13959,7 +15366,7 @@
           <a:bodyPr/>
           <a:lstStyle/>
           <a:p>
-            <a:endParaRPr lang="fr-CH" sz="2400"/>
+            <a:endParaRPr lang="fr-FR" sz="2400" noProof="0" dirty="0"/>
           </a:p>
         </p:txBody>
       </p:sp>
@@ -13985,7 +15392,7 @@
           <a:lstStyle/>
           <a:p>
             <a:r>
-              <a:rPr lang="en-US" sz="1333" i="1" dirty="0">
+              <a:rPr lang="fr-FR" sz="1333" i="1" noProof="0" dirty="0">
                 <a:solidFill>
                   <a:srgbClr val="DC2626"/>
                 </a:solidFill>
@@ -13995,11 +15402,11 @@
               </a:rPr>
               <a:t>Facteur distance : 90% VAP sur 10km</a:t>
             </a:r>
-            <a:endParaRPr lang="en-US" sz="1333" dirty="0"/>
-          </a:p>
-          <a:p>
-            <a:r>
-              <a:rPr lang="en-US" sz="1333" i="1" dirty="0">
+            <a:endParaRPr lang="fr-FR" sz="1333" noProof="0" dirty="0"/>
+          </a:p>
+          <a:p>
+            <a:r>
+              <a:rPr lang="fr-FR" sz="1333" i="1" noProof="0" dirty="0">
                 <a:solidFill>
                   <a:srgbClr val="DC2626"/>
                 </a:solidFill>
@@ -14009,7 +15416,7 @@
               </a:rPr>
               <a:t>Pénalité D+ : +0.5 min/100m</a:t>
             </a:r>
-            <a:endParaRPr lang="en-US" sz="1333" dirty="0"/>
+            <a:endParaRPr lang="fr-FR" sz="1333" noProof="0" dirty="0"/>
           </a:p>
         </p:txBody>
       </p:sp>
@@ -14061,14 +15468,9 @@
           </a:lstStyle>
           <a:p>
             <a:r>
-              <a:rPr lang="en-US" dirty="0"/>
-              <a:t>Tests de </a:t>
-            </a:r>
-            <a:r>
-              <a:rPr lang="en-US" dirty="0" err="1"/>
-              <a:t>parcours</a:t>
-            </a:r>
-            <a:endParaRPr lang="en-US" dirty="0"/>
+              <a:rPr lang="fr-FR" noProof="0" dirty="0"/>
+              <a:t>Tests de parcours</a:t>
+            </a:r>
           </a:p>
         </p:txBody>
       </p:sp>
@@ -14884,14 +16286,14 @@
 <file path=customXml/itemProps1.xml><?xml version="1.0" encoding="utf-8"?>
 <ds:datastoreItem xmlns:ds="http://schemas.openxmlformats.org/officeDocument/2006/customXml" ds:itemID="{D5967946-C2E7-44B2-BAA3-3BE2C987DF08}">
   <ds:schemaRefs>
-    <ds:schemaRef ds:uri="http://schemas.openxmlformats.org/package/2006/metadata/core-properties"/>
-    <ds:schemaRef ds:uri="http://schemas.microsoft.com/office/infopath/2007/PartnerControls"/>
+    <ds:schemaRef ds:uri="2fdefbfd-c998-4f74-a6c8-2499f19be793"/>
     <ds:schemaRef ds:uri="http://purl.org/dc/dcmitype/"/>
     <ds:schemaRef ds:uri="http://purl.org/dc/elements/1.1/"/>
-    <ds:schemaRef ds:uri="http://schemas.microsoft.com/office/2006/metadata/properties"/>
     <ds:schemaRef ds:uri="http://purl.org/dc/terms/"/>
     <ds:schemaRef ds:uri="http://schemas.microsoft.com/office/2006/documentManagement/types"/>
-    <ds:schemaRef ds:uri="2fdefbfd-c998-4f74-a6c8-2499f19be793"/>
+    <ds:schemaRef ds:uri="http://schemas.microsoft.com/office/2006/metadata/properties"/>
+    <ds:schemaRef ds:uri="http://schemas.microsoft.com/office/infopath/2007/PartnerControls"/>
+    <ds:schemaRef ds:uri="http://schemas.openxmlformats.org/package/2006/metadata/core-properties"/>
     <ds:schemaRef ds:uri="http://www.w3.org/XML/1998/namespace"/>
   </ds:schemaRefs>
 </ds:datastoreItem>

</xml_diff>